<commit_message>
Update pitch deck with current AI drafting flow
</commit_message>
<xml_diff>
--- a/slides/SponsorBridge-pitch.pptx
+++ b/slides/SponsorBridge-pitch.pptx
@@ -269,7 +269,7 @@
             <a:pPr/>
             <a:r>
               <a:rPr lang="en-US"/>
-              <a:t>I'm Afiq. I built SponsorBridge to help UPM student organisers turn an event idea into a clear sponsorship request. WorkBuddy does the preparation work through local tools, while students stay in control of the draft. This is a local prototype, not an official UPM service.</a:t>
+              <a:t>SponsorBridge is a local prototype built with WorkBuddy and presented by Afiq. It helps student organisers clarify a sponsorship ask. It is not an official UPM service. Screenshots use the current submission frontend with an existing saved fictional request; no new model run was started for these slides.</a:t>
             </a:r>
             <a:endParaRPr/>
           </a:p>
@@ -320,7 +320,7 @@
             <a:pPr/>
             <a:r>
               <a:rPr lang="en-US"/>
-              <a:t>I started with a practical preparation problem: an organiser has an idea, but the request may not yet explain quantities, deadlines or what can safely be offered to a sponsor. I frame this as the motivation for the prototype, not a finding from market statistics or user research. SponsorBridge keeps those unknowns visible and makes the ask reviewable.</a:t>
+              <a:t>This is a problem framing, not a market-statistics or user-research result. Contributions can be products, services or cash. Proposed support and organiser-stated benefits are drafts, not sponsor agreements or university approval.</a:t>
             </a:r>
             <a:endParaRPr/>
           </a:p>
@@ -371,7 +371,7 @@
             <a:pPr/>
             <a:r>
               <a:rPr lang="en-US"/>
-              <a:t>WorkBuddy did more than help me code. In the recorded demonstration, I manually started it, it read the saved request through the local adapter, interpreted the inputs and saved a plan and clarification output. After browser-saved answers and my explicit resume, it reread the latest state and saved package drafts. Students then edited and reviewed content. Saving on the website never automatically launches the agent.</a:t>
+              <a:t>One explicit run first prepares event details and clarification questions. The organiser saves answers, then a later explicit run drafts cards. The optional button invokes CodeBuddy CLI, not an existing WorkBuddy desktop conversation. Manual WorkBuddy handoff remains available under Advanced. The screenshot shows cards already saved: the button opens them without another model run.</a:t>
             </a:r>
             <a:endParaRPr/>
           </a:p>
@@ -422,7 +422,7 @@
             <a:pPr/>
             <a:r>
               <a:rPr lang="en-US"/>
-              <a:t>Our fictional Blue Lane group proposes First Splash Swimming Clinic for beginner students. The drafts request 48 sealed 500 millilitre bottles, a loan of 12 kickboards, and one coach for three hours. Only a written student-team thank-you is offered. The 7 November date and 24-person estimate are proposed; Demo Training Pool access and permissions remain unconfirmed. No contribution is secured, and coaching qualifications and supervision have not been verified.</a:t>
+              <a:t>The existing Campus Sustainability Fair request is fictional. Saved author: CodeBuddy CLI via API key. Two cards request reusable bottles and repair-workshop materials, with quantities/date/venue/approvals/tax status unconfirmed. A revision-1 fictional organiser answer supplies logo on the event page and verbal thanks during opening remarks only; no booth, social-media mention, extra branding, price or university endorsement. Both cards await content review. README documents live card content recovered from CLI traces and validated; a fresh live end-to-end run of the final one-click streamed path has not been performed.</a:t>
             </a:r>
             <a:endParaRPr/>
           </a:p>
@@ -473,7 +473,7 @@
             <a:pPr/>
             <a:r>
               <a:rPr lang="en-US"/>
-              <a:t>I kept the runtime small: responsive HTML, CSS and JavaScript, a local Node service, and JSON persistence. The adapter bounds the agent's operations and requires a fresh read receipt for writes. Editing clears that package's review; new answers stale the continuation and invalidate reviews. The copied submission passed 22 existing Node checks on 11 October, as reported. The 63 browser UI checks are from earlier WorkBuddy reports on 10 October, not a fresh rerun for this submission.</a:t>
+              <a:t>All 25 current Node checks passed in this task; model tests inject fake responses and do not use live credits. The CodeBuddy key is stored locally in plain text at data/.codebuddy-key, not returned by the backend to the browser, and data/ and key filenames are ignored by Git. Public main tree contains no data/ or key files. This is not an encrypted production secret store, and a complete historical secret audit was not performed. Do not confuse CodeBuddy CLI model execution with automatic WorkBuddy desktop execution. No fresh paid AI demo was run.</a:t>
             </a:r>
             <a:endParaRPr/>
           </a:p>
@@ -524,7 +524,7 @@
             <a:pPr/>
             <a:r>
               <a:rPr lang="en-US"/>
-              <a:t>SponsorBridge currently works through preparation and editable package drafts. Business matching, personalised pitches and complete campaign export are next steps, not features I am claiming today. The prototype uses fictional data and manual start and resume, and runs locally for a single user. I have not contacted businesses, secured sponsorship, processed payments or obtained university approval. The public GitHub link is source code, not a hosted web application.</a:t>
+              <a:t>Public source verified accessible: https://github.com/ryuhanbin/sponsorbridge-hackathon. The repository is public and contains the app, README, tests, evidence and pitch deck path. Final slide edits are local until separately committed and pushed. Matching, outreach and complete campaign export remain planned, not built. No sponsors secured or university approval claimed.</a:t>
             </a:r>
             <a:endParaRPr/>
           </a:p>
@@ -855,7 +855,7 @@
   <p:cSld>
     <p:spTree>
       <p:nvGrpSpPr>
-        <p:cNvPr id="1" name="" descr="&lt;Slide notes=&quot;I'm Afiq. I built SponsorBridge to help UPM student organisers turn an event idea into a clear sponsorship request. WorkBuddy does the preparation work through local tools, while students stay in control of the draft. This is a local prototype, not an official UPM service.&quot; style={{width:1280,height:720,padding:'20px 60px',background:'#0E1915',fontFamily:'Arial',color:'#F1F5E9',gap:0}}&gt;&#10;&lt;Box style={{height:100,justifyContent:'center'}}&gt;&lt;Text style={{fontSize:19,color:'#CDEA9F',fontWeight:600,letterSpacing:2}}&gt;SPONSORBRIDGE / HACKATHON 2026&lt;/Text&gt;&lt;/Box&gt;&#10;&lt;Box style={{height:540,flexDirection:'row',gap:48,alignItems:'center'}}&gt;&#10;&lt;Box style={{width:610,height:490,justifyContent:'center',gap:26}}&gt;&#10;&lt;Text style={{fontSize:72,fontWeight:700,lineHeight:1.1}}&gt;SponsorBridge&lt;/Text&gt;&#10;&lt;Text style={{fontSize:36,fontWeight:600,lineHeight:1.25,color:'#CDEA9F'}}&gt;From an event idea&lt;br/&gt;to a clear sponsorship ask.&lt;/Text&gt;&#10;&lt;Text style={{fontSize:25,lineHeight:1.45}}&gt;Helping UPM student organisers&lt;br/&gt;prepare reviewable sponsorship requests.&lt;/Text&gt;&#10;&lt;Box style={{height:64,justifyContent:'center'}}&gt;&lt;Text style={{fontSize:22,fontWeight:600}}&gt;Presenter: Afiq&lt;/Text&gt;&lt;Text style={{fontSize:18}}&gt;Built with WorkBuddy · Local prototype&lt;/Text&gt;&lt;/Box&gt;&#10;&lt;/Box&gt;&#10;&lt;Box style={{width:502,height:490,background:'#1D3328',padding:18,justifyContent:'center',gap:12,borderRadius:12}}&gt;&#10;&lt;Image src=&quot;SponsorBridge-ui-new-request.png&quot; style={{width:466,height:417,objectFit:'contain'}}/&gt;&#10;&lt;Text style={{fontSize:17,color:'#CDEA9F'}}&gt;Actual app screenshot · 10 October 2026&lt;/Text&gt;&#10;&lt;/Box&gt;&lt;/Box&gt;&#10;&lt;Box style={{height:40,flexDirection:'row',justifyContent:'space-between',alignItems:'center'}}&gt;&lt;Text style={{fontSize:15}}&gt;Preparation, not a promise of sponsorship.&lt;/Text&gt;&lt;Text style={{fontSize:15}}&gt;01 / 06&lt;/Text&gt;&lt;/Box&gt;&#10;&lt;/Slide&gt;"/>
+        <p:cNvPr id="1" name=""/>
         <p:cNvGrpSpPr/>
         <p:nvPr/>
       </p:nvGrpSpPr>
@@ -888,7 +888,10 @@
         </p:spPr>
         <p:txBody>
           <a:bodyPr/>
-          <a:p/>
+          <a:p>
+            <a:pPr/>
+            <a:endParaRPr/>
+          </a:p>
         </p:txBody>
       </p:sp>
       <p:sp>
@@ -913,7 +916,7 @@
               </a:lnSpc>
             </a:pPr>
             <a:r>
-              <a:rPr lang="en-US" sz="1425" b="1" spc="150">
+              <a:rPr lang="zh-CN" sz="1425" b="1" spc="150">
                 <a:solidFill>
                   <a:srgbClr val="CDEA9F"/>
                 </a:solidFill>
@@ -922,7 +925,13 @@
               </a:rPr>
               <a:t>SPONSORBRIDGE / HACKATHON 2026</a:t>
             </a:r>
-            <a:endParaRPr/>
+            <a:endParaRPr lang="zh-CN" sz="1425" b="1" spc="150">
+              <a:solidFill>
+                <a:srgbClr val="CDEA9F"/>
+              </a:solidFill>
+              <a:latin typeface="Arial"/>
+              <a:ea typeface="Arial"/>
+            </a:endParaRPr>
           </a:p>
         </p:txBody>
       </p:sp>
@@ -983,34 +992,23 @@
               </a:lnSpc>
             </a:pPr>
             <a:r>
-              <a:rPr lang="en-US" sz="2700" b="1">
+              <a:rPr lang="zh-CN" sz="2600" b="1">
                 <a:solidFill>
                   <a:srgbClr val="CDEA9F"/>
                 </a:solidFill>
                 <a:latin typeface="Arial"/>
                 <a:ea typeface="Arial"/>
               </a:rPr>
-              <a:t>From an event idea</a:t>
-            </a:r>
-            <a:endParaRPr/>
-          </a:p>
-          <a:p>
-            <a:pPr>
-              <a:lnSpc>
-                <a:spcPct val="125000"/>
-              </a:lnSpc>
-            </a:pPr>
-            <a:r>
-              <a:rPr lang="en-US" sz="2700" b="1">
-                <a:solidFill>
-                  <a:srgbClr val="CDEA9F"/>
-                </a:solidFill>
-                <a:latin typeface="Arial"/>
-                <a:ea typeface="Arial"/>
-              </a:rPr>
-              <a:t>to a clear sponsorship ask.</a:t>
-            </a:r>
-            <a:endParaRPr/>
+              <a:t>From an event idea
+to reviewable sponsor cards.</a:t>
+            </a:r>
+            <a:endParaRPr lang="zh-CN" sz="2600" b="1">
+              <a:solidFill>
+                <a:srgbClr val="CDEA9F"/>
+              </a:solidFill>
+              <a:latin typeface="Arial"/>
+              <a:ea typeface="Arial"/>
+            </a:endParaRPr>
           </a:p>
         </p:txBody>
       </p:sp>
@@ -1036,34 +1034,23 @@
               </a:lnSpc>
             </a:pPr>
             <a:r>
-              <a:rPr lang="en-US" sz="1875">
+              <a:rPr lang="zh-CN" sz="2000">
                 <a:solidFill>
                   <a:srgbClr val="F1F5E9"/>
                 </a:solidFill>
                 <a:latin typeface="Arial"/>
                 <a:ea typeface="Arial"/>
               </a:rPr>
-              <a:t>Helping UPM student organisers</a:t>
-            </a:r>
-            <a:endParaRPr/>
-          </a:p>
-          <a:p>
-            <a:pPr>
-              <a:lnSpc>
-                <a:spcPct val="145000"/>
-              </a:lnSpc>
-            </a:pPr>
-            <a:r>
-              <a:rPr lang="en-US" sz="1875">
-                <a:solidFill>
-                  <a:srgbClr val="F1F5E9"/>
-                </a:solidFill>
-                <a:latin typeface="Arial"/>
-                <a:ea typeface="Arial"/>
-              </a:rPr>
-              <a:t>prepare reviewable sponsorship requests.</a:t>
-            </a:r>
-            <a:endParaRPr/>
+              <a:t>A clearer sponsorship request
+for student event organisers.</a:t>
+            </a:r>
+            <a:endParaRPr lang="zh-CN" sz="2000">
+              <a:solidFill>
+                <a:srgbClr val="F1F5E9"/>
+              </a:solidFill>
+              <a:latin typeface="Arial"/>
+              <a:ea typeface="Arial"/>
+            </a:endParaRPr>
           </a:p>
         </p:txBody>
       </p:sp>
@@ -1124,7 +1111,7 @@
               </a:lnSpc>
             </a:pPr>
             <a:r>
-              <a:rPr lang="en-US" sz="1350">
+              <a:rPr lang="zh-CN" sz="1350">
                 <a:solidFill>
                   <a:srgbClr val="F1F5E9"/>
                 </a:solidFill>
@@ -1133,7 +1120,13 @@
               </a:rPr>
               <a:t>Built with WorkBuddy · Local prototype</a:t>
             </a:r>
-            <a:endParaRPr/>
+            <a:endParaRPr lang="zh-CN" sz="1350">
+              <a:solidFill>
+                <a:srgbClr val="F1F5E9"/>
+              </a:solidFill>
+              <a:latin typeface="Arial"/>
+              <a:ea typeface="Arial"/>
+            </a:endParaRPr>
           </a:p>
         </p:txBody>
       </p:sp>
@@ -1160,140 +1153,147 @@
         </p:spPr>
         <p:txBody>
           <a:bodyPr/>
-          <a:p/>
+          <a:p>
+            <a:pPr/>
+            <a:endParaRPr/>
+          </a:p>
+        </p:txBody>
+      </p:sp>
+      <p:sp>
+        <p:nvSpPr>
+          <p:cNvPr id="10" name="" descr="{&quot;isTemplate&quot;:true,&quot;type&quot;:&quot;text&quot;}"/>
+          <p:cNvSpPr txBox="1"/>
+          <p:nvPr/>
+        </p:nvSpPr>
+        <p:spPr>
+          <a:xfrm rot="0" flipH="0" flipV="0">
+            <a:off x="7010400" y="5657850"/>
+            <a:ext cx="4438650" cy="200025"/>
+          </a:xfrm>
+          <a:prstGeom prst="rect"/>
+        </p:spPr>
+        <p:txBody>
+          <a:bodyPr wrap="none" lIns="0" tIns="0" rIns="0" bIns="0"/>
+          <a:p>
+            <a:pPr>
+              <a:lnSpc>
+                <a:spcPct val="100000"/>
+              </a:lnSpc>
+            </a:pPr>
+            <a:r>
+              <a:rPr lang="zh-CN" sz="1200">
+                <a:solidFill>
+                  <a:srgbClr val="CDEA9F"/>
+                </a:solidFill>
+                <a:latin typeface="Arial"/>
+                <a:ea typeface="Arial"/>
+              </a:rPr>
+              <a:t>Current interface · saved fictional example</a:t>
+            </a:r>
+            <a:endParaRPr lang="zh-CN" sz="1200">
+              <a:solidFill>
+                <a:srgbClr val="CDEA9F"/>
+              </a:solidFill>
+              <a:latin typeface="Arial"/>
+              <a:ea typeface="Arial"/>
+            </a:endParaRPr>
+          </a:p>
+        </p:txBody>
+      </p:sp>
+      <p:sp>
+        <p:nvSpPr>
+          <p:cNvPr id="11" name="" descr="{&quot;isTemplate&quot;:true,&quot;type&quot;:&quot;text&quot;}"/>
+          <p:cNvSpPr txBox="1"/>
+          <p:nvPr/>
+        </p:nvSpPr>
+        <p:spPr>
+          <a:xfrm flipH="0" flipV="0">
+            <a:off x="571500" y="6391275"/>
+            <a:ext cx="8890000" cy="171450"/>
+          </a:xfrm>
+          <a:prstGeom prst="rect"/>
+        </p:spPr>
+        <p:txBody>
+          <a:bodyPr wrap="none" lIns="0" tIns="0" rIns="0" bIns="0"/>
+          <a:p>
+            <a:pPr>
+              <a:lnSpc>
+                <a:spcPct val="100000"/>
+              </a:lnSpc>
+            </a:pPr>
+            <a:r>
+              <a:rPr lang="zh-CN" sz="1100">
+                <a:solidFill>
+                  <a:srgbClr val="F1F5E9"/>
+                </a:solidFill>
+                <a:latin typeface="Arial"/>
+                <a:ea typeface="Arial"/>
+              </a:rPr>
+              <a:t>Not an official UPM service. No secured sponsors.</a:t>
+            </a:r>
+            <a:endParaRPr lang="zh-CN" sz="1100">
+              <a:solidFill>
+                <a:srgbClr val="F1F5E9"/>
+              </a:solidFill>
+              <a:latin typeface="Arial"/>
+              <a:ea typeface="Arial"/>
+            </a:endParaRPr>
+          </a:p>
+        </p:txBody>
+      </p:sp>
+      <p:sp>
+        <p:nvSpPr>
+          <p:cNvPr id="12" name="" descr="{&quot;isTemplate&quot;:true,&quot;type&quot;:&quot;text&quot;}"/>
+          <p:cNvSpPr txBox="1"/>
+          <p:nvPr/>
+        </p:nvSpPr>
+        <p:spPr>
+          <a:xfrm rot="0" flipH="0" flipV="0">
+            <a:off x="11182350" y="6391275"/>
+            <a:ext cx="438150" cy="171450"/>
+          </a:xfrm>
+          <a:prstGeom prst="rect"/>
+        </p:spPr>
+        <p:txBody>
+          <a:bodyPr wrap="none" lIns="0" tIns="0" rIns="0" bIns="0"/>
+          <a:p>
+            <a:pPr>
+              <a:lnSpc>
+                <a:spcPct val="100000"/>
+              </a:lnSpc>
+            </a:pPr>
+            <a:r>
+              <a:rPr lang="en-US" sz="1125">
+                <a:solidFill>
+                  <a:srgbClr val="F1F5E9"/>
+                </a:solidFill>
+                <a:latin typeface="Arial"/>
+                <a:ea typeface="Arial"/>
+              </a:rPr>
+              <a:t>01 / 06</a:t>
+            </a:r>
+            <a:endParaRPr/>
+          </a:p>
         </p:txBody>
       </p:sp>
       <p:pic>
         <p:nvPicPr>
-          <p:cNvPr id="10" name=""/>
-          <p:cNvPicPr>
-            <a:picLocks noChangeAspect="1"/>
-          </p:cNvPicPr>
+          <p:cNvPr id="13" name=""/>
+          <p:cNvPicPr/>
           <p:nvPr/>
         </p:nvPicPr>
         <p:blipFill>
           <a:blip r:embed="rId2"/>
-          <a:srcRect l="22" t="0" r="22" b="0"/>
-          <a:stretch>
-            <a:fillRect/>
-          </a:stretch>
+          <a:stretch/>
         </p:blipFill>
         <p:spPr>
-          <a:xfrm rot="0" flipH="0" flipV="0">
-            <a:off x="7010400" y="1571625"/>
-            <a:ext cx="4438650" cy="3971925"/>
-          </a:xfrm>
-          <a:prstGeom prst="rect">
-            <a:avLst/>
-          </a:prstGeom>
-          <a:ln/>
+          <a:xfrm>
+            <a:off x="7010400" y="1574800"/>
+            <a:ext cx="4441371" cy="3238500"/>
+          </a:xfrm>
+          <a:prstGeom prst="rect"/>
         </p:spPr>
       </p:pic>
-      <p:sp>
-        <p:nvSpPr>
-          <p:cNvPr id="11" name="" descr="{&quot;isTemplate&quot;:true,&quot;type&quot;:&quot;text&quot;}"/>
-          <p:cNvSpPr txBox="1"/>
-          <p:nvPr/>
-        </p:nvSpPr>
-        <p:spPr>
-          <a:xfrm rot="0" flipH="0" flipV="0">
-            <a:off x="7010400" y="5657850"/>
-            <a:ext cx="4438650" cy="200025"/>
-          </a:xfrm>
-          <a:prstGeom prst="rect"/>
-        </p:spPr>
-        <p:txBody>
-          <a:bodyPr wrap="none" lIns="0" tIns="0" rIns="0" bIns="0"/>
-          <a:p>
-            <a:pPr>
-              <a:lnSpc>
-                <a:spcPct val="100000"/>
-              </a:lnSpc>
-            </a:pPr>
-            <a:r>
-              <a:rPr lang="en-US" sz="1275">
-                <a:solidFill>
-                  <a:srgbClr val="CDEA9F"/>
-                </a:solidFill>
-                <a:latin typeface="Arial"/>
-                <a:ea typeface="Arial"/>
-              </a:rPr>
-              <a:t>Actual app screenshot · 10 October 2026</a:t>
-            </a:r>
-            <a:endParaRPr/>
-          </a:p>
-        </p:txBody>
-      </p:sp>
-      <p:sp>
-        <p:nvSpPr>
-          <p:cNvPr id="12" name="" descr="{&quot;isTemplate&quot;:true,&quot;type&quot;:&quot;text&quot;}"/>
-          <p:cNvSpPr txBox="1"/>
-          <p:nvPr/>
-        </p:nvSpPr>
-        <p:spPr>
-          <a:xfrm rot="0" flipH="0" flipV="0">
-            <a:off x="571500" y="6391275"/>
-            <a:ext cx="2695575" cy="171450"/>
-          </a:xfrm>
-          <a:prstGeom prst="rect"/>
-        </p:spPr>
-        <p:txBody>
-          <a:bodyPr wrap="none" lIns="0" tIns="0" rIns="0" bIns="0"/>
-          <a:p>
-            <a:pPr>
-              <a:lnSpc>
-                <a:spcPct val="100000"/>
-              </a:lnSpc>
-            </a:pPr>
-            <a:r>
-              <a:rPr lang="en-US" sz="1125">
-                <a:solidFill>
-                  <a:srgbClr val="F1F5E9"/>
-                </a:solidFill>
-                <a:latin typeface="Arial"/>
-                <a:ea typeface="Arial"/>
-              </a:rPr>
-              <a:t>Preparation, not a promise of sponsorship.</a:t>
-            </a:r>
-            <a:endParaRPr/>
-          </a:p>
-        </p:txBody>
-      </p:sp>
-      <p:sp>
-        <p:nvSpPr>
-          <p:cNvPr id="13" name="" descr="{&quot;isTemplate&quot;:true,&quot;type&quot;:&quot;text&quot;}"/>
-          <p:cNvSpPr txBox="1"/>
-          <p:nvPr/>
-        </p:nvSpPr>
-        <p:spPr>
-          <a:xfrm rot="0" flipH="0" flipV="0">
-            <a:off x="11182350" y="6391275"/>
-            <a:ext cx="438150" cy="171450"/>
-          </a:xfrm>
-          <a:prstGeom prst="rect"/>
-        </p:spPr>
-        <p:txBody>
-          <a:bodyPr wrap="none" lIns="0" tIns="0" rIns="0" bIns="0"/>
-          <a:p>
-            <a:pPr>
-              <a:lnSpc>
-                <a:spcPct val="100000"/>
-              </a:lnSpc>
-            </a:pPr>
-            <a:r>
-              <a:rPr lang="en-US" sz="1125">
-                <a:solidFill>
-                  <a:srgbClr val="F1F5E9"/>
-                </a:solidFill>
-                <a:latin typeface="Arial"/>
-                <a:ea typeface="Arial"/>
-              </a:rPr>
-              <a:t>01 / 06</a:t>
-            </a:r>
-            <a:endParaRPr/>
-          </a:p>
-        </p:txBody>
-      </p:sp>
     </p:spTree>
   </p:cSld>
 </p:sld>
@@ -1304,7 +1304,7 @@
   <p:cSld>
     <p:spTree>
       <p:nvGrpSpPr>
-        <p:cNvPr id="14" name="" descr="&lt;Slide notes=&quot;I started with a practical preparation problem: an organiser has an idea, but the request may not yet explain quantities, deadlines or what can safely be offered to a sponsor. I frame this as the motivation for the prototype, not a finding from market statistics or user research. SponsorBridge keeps those unknowns visible and makes the ask reviewable.&quot; style={{width:1280,height:720,padding:'20px 60px',background:'#0E1915',fontFamily:'Arial',color:'#F1F5E9'}}&gt;&#10;&lt;Box style={{height:100,justifyContent:'center',gap:8}}&gt;&lt;Text style={{fontSize:18,color:'#CDEA9F'}}&gt;THE PROBLEM MOTIVATING THE PROTOTYPE&lt;/Text&gt;&lt;Text style={{fontSize:38,fontWeight:700}}&gt;An event idea is not yet a sponsor-ready request.&lt;/Text&gt;&lt;/Box&gt;&#10;&lt;Box style={{height:540,flexDirection:'row',gap:48,alignItems:'center'}}&gt;&#10;&lt;Box style={{width:360,height:490,background:'#1D3328',padding:30,justifyContent:'space-between'}}&gt;&lt;Text style={{fontSize:48,fontWeight:700,lineHeight:1.15,color:'#CDEA9F'}}&gt;Clarify&lt;br/&gt;before&lt;br/&gt;committing.&lt;/Text&gt;&lt;Text style={{fontSize:25,lineHeight:1.45}}&gt;A clearer brief helps students explain the contribution they need and the benefits they can actually offer.&lt;/Text&gt;&lt;/Box&gt;&#10;&lt;Box style={{width:752,height:490,gap:20,justifyContent:'center'}}&gt;&#10;&lt;Box style={{height:140,gap:10}}&gt;&lt;Text style={{fontSize:29,fontWeight:700,color:'#CDEA9F'}}&gt;01  Define the support need&lt;/Text&gt;&lt;Text style={{fontSize:25,lineHeight:1.4}}&gt;Products, services or cash? What quantity,&lt;br/&gt;what deadline, and which details are still unknown?&lt;/Text&gt;&lt;/Box&gt;&#10;&lt;Box style={{height:140,gap:10}}&gt;&lt;Text style={{fontSize:29,fontWeight:700,color:'#CDEA9F'}}&gt;02  Explain authorised sponsor benefits&lt;/Text&gt;&lt;Text style={{fontSize:25,lineHeight:1.4}}&gt;Separate a student-team thank-you from unapproved&lt;br/&gt;logo rights, access or university endorsement.&lt;/Text&gt;&lt;/Box&gt;&#10;&lt;Box style={{height:140,gap:10}}&gt;&lt;Text style={{fontSize:29,fontWeight:700,color:'#CDEA9F'}}&gt;03  Prepare reviewable packages&lt;/Text&gt;&lt;Text style={{fontSize:25,lineHeight:1.4}}&gt;Turn the answers into concrete drafts with source&lt;br/&gt;evidence and outstanding conditions.&lt;/Text&gt;&lt;/Box&gt;&#10;&lt;/Box&gt;&lt;/Box&gt;&#10;&lt;Box style={{height:40,flexDirection:'row',justifyContent:'space-between',alignItems:'center'}}&gt;&lt;Text style={{fontSize:15}}&gt;Problem framing only · No market statistics or user-research claim&lt;/Text&gt;&lt;Text style={{fontSize:15}}&gt;02 / 06&lt;/Text&gt;&lt;/Box&gt;&#10;&lt;/Slide&gt;"/>
+        <p:cNvPr id="14" name=""/>
         <p:cNvGrpSpPr/>
         <p:nvPr/>
       </p:nvGrpSpPr>
@@ -1337,7 +1337,10 @@
         </p:spPr>
         <p:txBody>
           <a:bodyPr/>
-          <a:p/>
+          <a:p>
+            <a:pPr/>
+            <a:endParaRPr/>
+          </a:p>
         </p:txBody>
       </p:sp>
       <p:sp>
@@ -1362,7 +1365,7 @@
               </a:lnSpc>
             </a:pPr>
             <a:r>
-              <a:rPr lang="en-US" sz="1350">
+              <a:rPr lang="zh-CN" sz="1350">
                 <a:solidFill>
                   <a:srgbClr val="CDEA9F"/>
                 </a:solidFill>
@@ -1371,7 +1374,13 @@
               </a:rPr>
               <a:t>THE PROBLEM MOTIVATING THE PROTOTYPE</a:t>
             </a:r>
-            <a:endParaRPr/>
+            <a:endParaRPr lang="zh-CN" sz="1350">
+              <a:solidFill>
+                <a:srgbClr val="CDEA9F"/>
+              </a:solidFill>
+              <a:latin typeface="Arial"/>
+              <a:ea typeface="Arial"/>
+            </a:endParaRPr>
           </a:p>
         </p:txBody>
       </p:sp>
@@ -1397,16 +1406,22 @@
               </a:lnSpc>
             </a:pPr>
             <a:r>
-              <a:rPr lang="en-US" sz="2850" b="1">
+              <a:rPr lang="zh-CN" sz="2850" b="1">
                 <a:solidFill>
                   <a:srgbClr val="F1F5E9"/>
                 </a:solidFill>
                 <a:latin typeface="Arial"/>
                 <a:ea typeface="Arial"/>
               </a:rPr>
-              <a:t>An event idea is not yet a sponsor-ready request.</a:t>
-            </a:r>
-            <a:endParaRPr/>
+              <a:t>An event idea is not yet a clear sponsorship ask.</a:t>
+            </a:r>
+            <a:endParaRPr lang="zh-CN" sz="2850" b="1">
+              <a:solidFill>
+                <a:srgbClr val="F1F5E9"/>
+              </a:solidFill>
+              <a:latin typeface="Arial"/>
+              <a:ea typeface="Arial"/>
+            </a:endParaRPr>
           </a:p>
         </p:txBody>
       </p:sp>
@@ -1431,7 +1446,10 @@
         </p:spPr>
         <p:txBody>
           <a:bodyPr/>
-          <a:p/>
+          <a:p>
+            <a:pPr/>
+            <a:endParaRPr/>
+          </a:p>
         </p:txBody>
       </p:sp>
       <p:sp>
@@ -1609,34 +1627,23 @@
               </a:lnSpc>
             </a:pPr>
             <a:r>
-              <a:rPr lang="en-US" sz="1875">
+              <a:rPr lang="zh-CN" sz="1875">
                 <a:solidFill>
                   <a:srgbClr val="F1F5E9"/>
                 </a:solidFill>
                 <a:latin typeface="Arial"/>
                 <a:ea typeface="Arial"/>
               </a:rPr>
-              <a:t>Products, services or cash? What quantity,</a:t>
-            </a:r>
-            <a:endParaRPr/>
-          </a:p>
-          <a:p>
-            <a:pPr>
-              <a:lnSpc>
-                <a:spcPct val="140000"/>
-              </a:lnSpc>
-            </a:pPr>
-            <a:r>
-              <a:rPr lang="en-US" sz="1875">
-                <a:solidFill>
-                  <a:srgbClr val="F1F5E9"/>
-                </a:solidFill>
-                <a:latin typeface="Arial"/>
-                <a:ea typeface="Arial"/>
-              </a:rPr>
-              <a:t>what deadline, and which details are still unknown?</a:t>
-            </a:r>
-            <a:endParaRPr/>
+              <a:t>Products, services or cash? What quantity,
+what deadline, and what is still unconfirmed?</a:t>
+            </a:r>
+            <a:endParaRPr lang="zh-CN" sz="1875">
+              <a:solidFill>
+                <a:srgbClr val="F1F5E9"/>
+              </a:solidFill>
+              <a:latin typeface="Arial"/>
+              <a:ea typeface="Arial"/>
+            </a:endParaRPr>
           </a:p>
         </p:txBody>
       </p:sp>
@@ -1697,34 +1704,23 @@
               </a:lnSpc>
             </a:pPr>
             <a:r>
-              <a:rPr lang="en-US" sz="1875">
+              <a:rPr lang="zh-CN" sz="1875">
                 <a:solidFill>
                   <a:srgbClr val="F1F5E9"/>
                 </a:solidFill>
                 <a:latin typeface="Arial"/>
                 <a:ea typeface="Arial"/>
               </a:rPr>
-              <a:t>Separate a student-team thank-you from unapproved</a:t>
-            </a:r>
-            <a:endParaRPr/>
-          </a:p>
-          <a:p>
-            <a:pPr>
-              <a:lnSpc>
-                <a:spcPct val="140000"/>
-              </a:lnSpc>
-            </a:pPr>
-            <a:r>
-              <a:rPr lang="en-US" sz="1875">
-                <a:solidFill>
-                  <a:srgbClr val="F1F5E9"/>
-                </a:solidFill>
-                <a:latin typeface="Arial"/>
-                <a:ea typeface="Arial"/>
-              </a:rPr>
-              <a:t>logo rights, access or university endorsement.</a:t>
-            </a:r>
-            <a:endParaRPr/>
+              <a:t>Use organiser-stated benefits, with source evidence.
+Do not invent sponsor rights or endorsement.</a:t>
+            </a:r>
+            <a:endParaRPr lang="zh-CN" sz="1875">
+              <a:solidFill>
+                <a:srgbClr val="F1F5E9"/>
+              </a:solidFill>
+              <a:latin typeface="Arial"/>
+              <a:ea typeface="Arial"/>
+            </a:endParaRPr>
           </a:p>
         </p:txBody>
       </p:sp>
@@ -1750,16 +1746,22 @@
               </a:lnSpc>
             </a:pPr>
             <a:r>
-              <a:rPr lang="en-US" sz="2175" b="1">
+              <a:rPr lang="zh-CN" sz="2175" b="1">
                 <a:solidFill>
                   <a:srgbClr val="CDEA9F"/>
                 </a:solidFill>
                 <a:latin typeface="Arial"/>
                 <a:ea typeface="Arial"/>
               </a:rPr>
-              <a:t>03  Prepare reviewable packages</a:t>
-            </a:r>
-            <a:endParaRPr/>
+              <a:t>03  Create reviewable sponsorship cards</a:t>
+            </a:r>
+            <a:endParaRPr lang="zh-CN" sz="2175" b="1">
+              <a:solidFill>
+                <a:srgbClr val="CDEA9F"/>
+              </a:solidFill>
+              <a:latin typeface="Arial"/>
+              <a:ea typeface="Arial"/>
+            </a:endParaRPr>
           </a:p>
         </p:txBody>
       </p:sp>
@@ -1785,34 +1787,23 @@
               </a:lnSpc>
             </a:pPr>
             <a:r>
-              <a:rPr lang="en-US" sz="1875">
+              <a:rPr lang="zh-CN" sz="1875">
                 <a:solidFill>
                   <a:srgbClr val="F1F5E9"/>
                 </a:solidFill>
                 <a:latin typeface="Arial"/>
                 <a:ea typeface="Arial"/>
               </a:rPr>
-              <a:t>Turn the answers into concrete drafts with source</a:t>
-            </a:r>
-            <a:endParaRPr/>
-          </a:p>
-          <a:p>
-            <a:pPr>
-              <a:lnSpc>
-                <a:spcPct val="140000"/>
-              </a:lnSpc>
-            </a:pPr>
-            <a:r>
-              <a:rPr lang="en-US" sz="1875">
-                <a:solidFill>
-                  <a:srgbClr val="F1F5E9"/>
-                </a:solidFill>
-                <a:latin typeface="Arial"/>
-                <a:ea typeface="Arial"/>
-              </a:rPr>
-              <a:t>evidence and outstanding conditions.</a:t>
-            </a:r>
-            <a:endParaRPr/>
+              <a:t>Turn the answers into saved drafts with
+contributions, timing and outstanding conditions.</a:t>
+            </a:r>
+            <a:endParaRPr lang="zh-CN" sz="1875">
+              <a:solidFill>
+                <a:srgbClr val="F1F5E9"/>
+              </a:solidFill>
+              <a:latin typeface="Arial"/>
+              <a:ea typeface="Arial"/>
+            </a:endParaRPr>
           </a:p>
         </p:txBody>
       </p:sp>
@@ -1892,11 +1883,11 @@
 </file>
 
 <file path=ppt/slides/slide3.xml><?xml version="1.0" encoding="utf-8"?>
-<p:sld xmlns:p="http://schemas.openxmlformats.org/presentationml/2006/main" xmlns:a="http://schemas.openxmlformats.org/drawingml/2006/main">
+<p:sld xmlns:p="http://schemas.openxmlformats.org/presentationml/2006/main" xmlns:a="http://schemas.openxmlformats.org/drawingml/2006/main" xmlns:r="http://schemas.openxmlformats.org/officeDocument/2006/relationships">
   <p:cSld>
     <p:spTree>
       <p:nvGrpSpPr>
-        <p:cNvPr id="29" name="" descr="&lt;Slide notes=&quot;WorkBuddy did more than help me code. In the recorded demonstration, I manually started it, it read the saved request through the local adapter, interpreted the inputs and saved a plan and clarification output. After browser-saved answers and my explicit resume, it reread the latest state and saved package drafts. Students then edited and reviewed content. Saving on the website never automatically launches the agent.&quot; style={{width:1280,height:720,padding:'20px 60px',background:'#0E1915',fontFamily:'Arial',color:'#F1F5E9'}}&gt;&#10;&lt;Box style={{height:100,justifyContent:'center',gap:8}}&gt;&lt;Text style={{fontSize:18,color:'#CDEA9F'}}&gt;ACTUAL WORKBUDDY WORKFLOW&lt;/Text&gt;&lt;Text style={{fontSize:38,fontWeight:700}}&gt;The agent reads, interprets and saves real results.&lt;/Text&gt;&lt;/Box&gt;&#10;&lt;Box style={{height:540,gap:22,justifyContent:'center'}}&gt;&#10;&lt;Box style={{height:328,flexDirection:'row',gap:36}}&gt;&#10;&lt;Box style={{width:550,height:328,background:'#1D3328',padding:26,gap:18}}&gt;&lt;Text style={{fontSize:26,fontWeight:700,color:'#CDEA9F'}}&gt;1–4  From proposal to clarification&lt;/Text&gt;&lt;Text style={{fontSize:25,lineHeight:1.55}}&gt;1. Browser saves proposal + goal&lt;br/&gt;→ 2. User starts WorkBuddy manually&lt;br/&gt;→ 3. WorkBuddy reads via local adapter&lt;br/&gt;→ 4. Agent saves plan + clarification&lt;/Text&gt;&lt;/Box&gt;&#10;&lt;Box style={{width:574,height:328,padding:26,gap:18}}&gt;&lt;Text style={{fontSize:26,fontWeight:700,color:'#CDEA9F'}}&gt;5–7  From answers to reviewed drafts&lt;/Text&gt;&lt;Text style={{fontSize:25,lineHeight:1.55}}&gt;5. Student saves answers in browser&lt;br/&gt;→ 6. Explicit resume + reread + drafts&lt;br/&gt;→ 7. Student edits and reviews content&lt;/Text&gt;&lt;Text style={{fontSize:21,lineHeight:1.4}}&gt;Browser polling displays actual saved outputs.&lt;br/&gt;Review remains separate from approval.&lt;/Text&gt;&lt;/Box&gt;&#10;&lt;/Box&gt;&#10;&lt;Box style={{height:148,background:'#1D3328',padding:22,gap:10}}&gt;&lt;Text style={{fontSize:26,fontWeight:700,color:'#CDEA9F'}}&gt;Execution evidence, not just coding assistance&lt;/Text&gt;&lt;Text style={{fontSize:23,lineHeight:1.4}}&gt;Recorded local adapter actions: read → plan → preparation → continuation.&lt;br/&gt;Reads precede validated writes; saved answers are reread on explicit resume.&lt;/Text&gt;&lt;/Box&gt;&#10;&lt;/Box&gt;&#10;&lt;Box style={{height:40,flexDirection:'row',justifyContent:'space-between',alignItems:'center'}}&gt;&lt;Text style={{fontSize:15}}&gt;Historical WorkBuddy execution · No automatic website dispatch&lt;/Text&gt;&lt;Text style={{fontSize:15}}&gt;03 / 06&lt;/Text&gt;&lt;/Box&gt;&#10;&lt;/Slide&gt;"/>
+        <p:cNvPr id="29" name=""/>
         <p:cNvGrpSpPr/>
         <p:nvPr/>
       </p:nvGrpSpPr>
@@ -1929,7 +1920,10 @@
         </p:spPr>
         <p:txBody>
           <a:bodyPr/>
-          <a:p/>
+          <a:p>
+            <a:pPr/>
+            <a:endParaRPr/>
+          </a:p>
         </p:txBody>
       </p:sp>
       <p:sp>
@@ -1954,16 +1948,22 @@
               </a:lnSpc>
             </a:pPr>
             <a:r>
-              <a:rPr lang="en-US" sz="1350">
+              <a:rPr lang="zh-CN" sz="1350">
                 <a:solidFill>
                   <a:srgbClr val="CDEA9F"/>
                 </a:solidFill>
                 <a:latin typeface="Arial"/>
                 <a:ea typeface="Arial"/>
               </a:rPr>
-              <a:t>ACTUAL WORKBUDDY WORKFLOW</a:t>
-            </a:r>
-            <a:endParaRPr/>
+              <a:t>SIMPLIFIED DRAFTING INTERFACE</a:t>
+            </a:r>
+            <a:endParaRPr lang="zh-CN" sz="1350">
+              <a:solidFill>
+                <a:srgbClr val="CDEA9F"/>
+              </a:solidFill>
+              <a:latin typeface="Arial"/>
+              <a:ea typeface="Arial"/>
+            </a:endParaRPr>
           </a:p>
         </p:txBody>
       </p:sp>
@@ -1989,37 +1989,141 @@
               </a:lnSpc>
             </a:pPr>
             <a:r>
-              <a:rPr lang="en-US" sz="2850" b="1">
+              <a:rPr lang="zh-CN" sz="2850" b="1">
                 <a:solidFill>
                   <a:srgbClr val="F1F5E9"/>
                 </a:solidFill>
                 <a:latin typeface="Arial"/>
                 <a:ea typeface="Arial"/>
               </a:rPr>
-              <a:t>The agent reads, interprets and saves real results.</a:t>
+              <a:t>Prepare questions first. Draft cards after answers.</a:t>
+            </a:r>
+            <a:endParaRPr lang="zh-CN" sz="2850" b="1">
+              <a:solidFill>
+                <a:srgbClr val="F1F5E9"/>
+              </a:solidFill>
+              <a:latin typeface="Arial"/>
+              <a:ea typeface="Arial"/>
+            </a:endParaRPr>
+          </a:p>
+        </p:txBody>
+      </p:sp>
+      <p:sp>
+        <p:nvSpPr>
+          <p:cNvPr id="33" name="" descr="{&quot;isTemplate&quot;:true,&quot;type&quot;:&quot;text&quot;}"/>
+          <p:cNvSpPr txBox="1"/>
+          <p:nvPr/>
+        </p:nvSpPr>
+        <p:spPr>
+          <a:xfrm rot="0" flipH="0" flipV="0">
+            <a:off x="571500" y="6391275"/>
+            <a:ext cx="4086225" cy="171450"/>
+          </a:xfrm>
+          <a:prstGeom prst="rect"/>
+        </p:spPr>
+        <p:txBody>
+          <a:bodyPr wrap="none" lIns="0" tIns="0" rIns="0" bIns="0"/>
+          <a:p>
+            <a:pPr>
+              <a:lnSpc>
+                <a:spcPct val="100000"/>
+              </a:lnSpc>
+            </a:pPr>
+            <a:r>
+              <a:rPr lang="zh-CN" sz="1125">
+                <a:solidFill>
+                  <a:srgbClr val="F1F5E9"/>
+                </a:solidFill>
+                <a:latin typeface="Arial"/>
+                <a:ea typeface="Arial"/>
+              </a:rPr>
+              <a:t>Explicit runs · Saving answers alone does not start AI</a:t>
+            </a:r>
+            <a:endParaRPr lang="zh-CN" sz="1125">
+              <a:solidFill>
+                <a:srgbClr val="F1F5E9"/>
+              </a:solidFill>
+              <a:latin typeface="Arial"/>
+              <a:ea typeface="Arial"/>
+            </a:endParaRPr>
+          </a:p>
+        </p:txBody>
+      </p:sp>
+      <p:sp>
+        <p:nvSpPr>
+          <p:cNvPr id="34" name="" descr="{&quot;isTemplate&quot;:true,&quot;type&quot;:&quot;text&quot;}"/>
+          <p:cNvSpPr txBox="1"/>
+          <p:nvPr/>
+        </p:nvSpPr>
+        <p:spPr>
+          <a:xfrm rot="0" flipH="0" flipV="0">
+            <a:off x="11182350" y="6391275"/>
+            <a:ext cx="438150" cy="171450"/>
+          </a:xfrm>
+          <a:prstGeom prst="rect"/>
+        </p:spPr>
+        <p:txBody>
+          <a:bodyPr wrap="none" lIns="0" tIns="0" rIns="0" bIns="0"/>
+          <a:p>
+            <a:pPr>
+              <a:lnSpc>
+                <a:spcPct val="100000"/>
+              </a:lnSpc>
+            </a:pPr>
+            <a:r>
+              <a:rPr lang="en-US" sz="1125">
+                <a:solidFill>
+                  <a:srgbClr val="F1F5E9"/>
+                </a:solidFill>
+                <a:latin typeface="Arial"/>
+                <a:ea typeface="Arial"/>
+              </a:rPr>
+              <a:t>03 / 06</a:t>
             </a:r>
             <a:endParaRPr/>
           </a:p>
         </p:txBody>
       </p:sp>
-      <p:sp>
-        <p:nvSpPr>
-          <p:cNvPr id="33" name=""/>
+      <p:pic>
+        <p:nvPicPr>
+          <p:cNvPr id="35" name=""/>
+          <p:cNvPicPr/>
+          <p:nvPr/>
+        </p:nvPicPr>
+        <p:blipFill>
+          <a:blip r:embed="rId2"/>
+          <a:stretch/>
+        </p:blipFill>
+        <p:spPr>
+          <a:xfrm>
+            <a:off x="571500" y="1371600"/>
+            <a:ext cx="11030272" cy="2362200"/>
+          </a:xfrm>
+          <a:prstGeom prst="rect"/>
+        </p:spPr>
+      </p:pic>
+      <p:sp>
+        <p:nvSpPr>
+          <p:cNvPr id="36" name=""/>
           <p:cNvSpPr/>
           <p:nvPr/>
         </p:nvSpPr>
         <p:spPr>
-          <a:xfrm rot="0" flipH="0" flipV="0">
-            <a:off x="571500" y="1343025"/>
-            <a:ext cx="5238750" cy="3124200"/>
-          </a:xfrm>
-          <a:prstGeom prst="rect">
-            <a:avLst/>
+          <a:xfrm>
+            <a:off x="571500" y="4000500"/>
+            <a:ext cx="3429000" cy="1917700"/>
+          </a:xfrm>
+          <a:prstGeom prst="roundRect">
+            <a:avLst>
+              <a:gd name="adj" fmla="val 4376"/>
+            </a:avLst>
           </a:prstGeom>
           <a:solidFill>
             <a:srgbClr val="1D3328"/>
           </a:solidFill>
-          <a:ln/>
+          <a:ln>
+            <a:noFill/>
+          </a:ln>
         </p:spPr>
         <p:txBody>
           <a:bodyPr/>
@@ -2028,305 +2132,26 @@
       </p:sp>
       <p:sp>
         <p:nvSpPr>
-          <p:cNvPr id="34" name="" descr="{&quot;isTemplate&quot;:true,&quot;type&quot;:&quot;text&quot;}"/>
-          <p:cNvSpPr txBox="1"/>
-          <p:nvPr/>
-        </p:nvSpPr>
-        <p:spPr>
-          <a:xfrm rot="0" flipH="0" flipV="0">
-            <a:off x="819150" y="1590675"/>
-            <a:ext cx="4743450" cy="304800"/>
-          </a:xfrm>
-          <a:prstGeom prst="rect"/>
-        </p:spPr>
-        <p:txBody>
-          <a:bodyPr wrap="none" lIns="0" tIns="0" rIns="0" bIns="0"/>
-          <a:p>
-            <a:pPr>
-              <a:lnSpc>
-                <a:spcPct val="100000"/>
-              </a:lnSpc>
-            </a:pPr>
-            <a:r>
-              <a:rPr lang="en-US" sz="1950" b="1">
-                <a:solidFill>
-                  <a:srgbClr val="CDEA9F"/>
-                </a:solidFill>
-                <a:latin typeface="Arial"/>
-                <a:ea typeface="Arial"/>
-              </a:rPr>
-              <a:t>1–4  From proposal to clarification</a:t>
-            </a:r>
-            <a:endParaRPr/>
-          </a:p>
-        </p:txBody>
-      </p:sp>
-      <p:sp>
-        <p:nvSpPr>
-          <p:cNvPr id="35" name="" descr="{&quot;isTemplate&quot;:true,&quot;type&quot;:&quot;text&quot;}"/>
-          <p:cNvSpPr txBox="1"/>
-          <p:nvPr/>
-        </p:nvSpPr>
-        <p:spPr>
-          <a:xfrm rot="0" flipH="0" flipV="0">
-            <a:off x="819150" y="2066925"/>
-            <a:ext cx="4743450" cy="1771650"/>
-          </a:xfrm>
-          <a:prstGeom prst="rect"/>
-        </p:spPr>
-        <p:txBody>
-          <a:bodyPr wrap="none" lIns="0" tIns="0" rIns="0" bIns="0"/>
-          <a:p>
-            <a:pPr>
-              <a:lnSpc>
-                <a:spcPct val="155000"/>
-              </a:lnSpc>
-            </a:pPr>
-            <a:r>
-              <a:rPr lang="en-US" sz="1875">
-                <a:solidFill>
-                  <a:srgbClr val="F1F5E9"/>
-                </a:solidFill>
-                <a:latin typeface="Arial"/>
-                <a:ea typeface="Arial"/>
-              </a:rPr>
-              <a:t>1. Browser saves proposal + goal</a:t>
-            </a:r>
-            <a:endParaRPr/>
-          </a:p>
-          <a:p>
-            <a:pPr>
-              <a:lnSpc>
-                <a:spcPct val="155000"/>
-              </a:lnSpc>
-            </a:pPr>
-            <a:r>
-              <a:rPr lang="en-US" sz="1875">
-                <a:solidFill>
-                  <a:srgbClr val="F1F5E9"/>
-                </a:solidFill>
-                <a:latin typeface="Arial"/>
-                <a:ea typeface="Arial"/>
-              </a:rPr>
-              <a:t>→ 2. User starts WorkBuddy manually</a:t>
-            </a:r>
-            <a:endParaRPr/>
-          </a:p>
-          <a:p>
-            <a:pPr>
-              <a:lnSpc>
-                <a:spcPct val="155000"/>
-              </a:lnSpc>
-            </a:pPr>
-            <a:r>
-              <a:rPr lang="en-US" sz="1875">
-                <a:solidFill>
-                  <a:srgbClr val="F1F5E9"/>
-                </a:solidFill>
-                <a:latin typeface="Arial"/>
-                <a:ea typeface="Arial"/>
-              </a:rPr>
-              <a:t>→ 3. WorkBuddy reads via local adapter</a:t>
-            </a:r>
-            <a:endParaRPr/>
-          </a:p>
-          <a:p>
-            <a:pPr>
-              <a:lnSpc>
-                <a:spcPct val="155000"/>
-              </a:lnSpc>
-            </a:pPr>
-            <a:r>
-              <a:rPr lang="en-US" sz="1875">
-                <a:solidFill>
-                  <a:srgbClr val="F1F5E9"/>
-                </a:solidFill>
-                <a:latin typeface="Arial"/>
-                <a:ea typeface="Arial"/>
-              </a:rPr>
-              <a:t>→ 4. Agent saves plan + clarification</a:t>
-            </a:r>
-            <a:endParaRPr/>
-          </a:p>
-        </p:txBody>
-      </p:sp>
-      <p:sp>
-        <p:nvSpPr>
-          <p:cNvPr id="36" name="" descr="{&quot;isTemplate&quot;:true,&quot;type&quot;:&quot;text&quot;}"/>
-          <p:cNvSpPr txBox="1"/>
-          <p:nvPr/>
-        </p:nvSpPr>
-        <p:spPr>
-          <a:xfrm rot="0" flipH="0" flipV="0">
-            <a:off x="6400800" y="1590675"/>
-            <a:ext cx="4972050" cy="304800"/>
-          </a:xfrm>
-          <a:prstGeom prst="rect"/>
-        </p:spPr>
-        <p:txBody>
-          <a:bodyPr wrap="none" lIns="0" tIns="0" rIns="0" bIns="0"/>
-          <a:p>
-            <a:pPr>
-              <a:lnSpc>
-                <a:spcPct val="100000"/>
-              </a:lnSpc>
-            </a:pPr>
-            <a:r>
-              <a:rPr lang="en-US" sz="1950" b="1">
-                <a:solidFill>
-                  <a:srgbClr val="CDEA9F"/>
-                </a:solidFill>
-                <a:latin typeface="Arial"/>
-                <a:ea typeface="Arial"/>
-              </a:rPr>
-              <a:t>5–7  From answers to reviewed drafts</a:t>
-            </a:r>
-            <a:endParaRPr/>
-          </a:p>
-        </p:txBody>
-      </p:sp>
-      <p:sp>
-        <p:nvSpPr>
-          <p:cNvPr id="37" name="" descr="{&quot;isTemplate&quot;:true,&quot;type&quot;:&quot;text&quot;}"/>
-          <p:cNvSpPr txBox="1"/>
-          <p:nvPr/>
-        </p:nvSpPr>
-        <p:spPr>
-          <a:xfrm rot="0" flipH="0" flipV="0">
-            <a:off x="6400800" y="2066925"/>
-            <a:ext cx="4972050" cy="1333500"/>
-          </a:xfrm>
-          <a:prstGeom prst="rect"/>
-        </p:spPr>
-        <p:txBody>
-          <a:bodyPr wrap="none" lIns="0" tIns="0" rIns="0" bIns="0"/>
-          <a:p>
-            <a:pPr>
-              <a:lnSpc>
-                <a:spcPct val="155000"/>
-              </a:lnSpc>
-            </a:pPr>
-            <a:r>
-              <a:rPr lang="en-US" sz="1875">
-                <a:solidFill>
-                  <a:srgbClr val="F1F5E9"/>
-                </a:solidFill>
-                <a:latin typeface="Arial"/>
-                <a:ea typeface="Arial"/>
-              </a:rPr>
-              <a:t>5. Student saves answers in browser</a:t>
-            </a:r>
-            <a:endParaRPr/>
-          </a:p>
-          <a:p>
-            <a:pPr>
-              <a:lnSpc>
-                <a:spcPct val="155000"/>
-              </a:lnSpc>
-            </a:pPr>
-            <a:r>
-              <a:rPr lang="en-US" sz="1875">
-                <a:solidFill>
-                  <a:srgbClr val="F1F5E9"/>
-                </a:solidFill>
-                <a:latin typeface="Arial"/>
-                <a:ea typeface="Arial"/>
-              </a:rPr>
-              <a:t>→ 6. Explicit resume + reread + drafts</a:t>
-            </a:r>
-            <a:endParaRPr/>
-          </a:p>
-          <a:p>
-            <a:pPr>
-              <a:lnSpc>
-                <a:spcPct val="155000"/>
-              </a:lnSpc>
-            </a:pPr>
-            <a:r>
-              <a:rPr lang="en-US" sz="1875">
-                <a:solidFill>
-                  <a:srgbClr val="F1F5E9"/>
-                </a:solidFill>
-                <a:latin typeface="Arial"/>
-                <a:ea typeface="Arial"/>
-              </a:rPr>
-              <a:t>→ 7. Student edits and reviews content</a:t>
-            </a:r>
-            <a:endParaRPr/>
-          </a:p>
-        </p:txBody>
-      </p:sp>
-      <p:sp>
-        <p:nvSpPr>
-          <p:cNvPr id="38" name="" descr="{&quot;isTemplate&quot;:true,&quot;type&quot;:&quot;text&quot;}"/>
-          <p:cNvSpPr txBox="1"/>
-          <p:nvPr/>
-        </p:nvSpPr>
-        <p:spPr>
-          <a:xfrm rot="0" flipH="0" flipV="0">
-            <a:off x="6400800" y="3571875"/>
-            <a:ext cx="4972050" cy="676275"/>
-          </a:xfrm>
-          <a:prstGeom prst="rect"/>
-        </p:spPr>
-        <p:txBody>
-          <a:bodyPr wrap="none" lIns="0" tIns="0" rIns="0" bIns="0"/>
-          <a:p>
-            <a:pPr>
-              <a:lnSpc>
-                <a:spcPct val="140000"/>
-              </a:lnSpc>
-            </a:pPr>
-            <a:r>
-              <a:rPr lang="en-US" sz="1575">
-                <a:solidFill>
-                  <a:srgbClr val="F1F5E9"/>
-                </a:solidFill>
-                <a:latin typeface="Arial"/>
-                <a:ea typeface="Arial"/>
-              </a:rPr>
-              <a:t>Browser polling displays actual saved outputs.</a:t>
-            </a:r>
-            <a:endParaRPr/>
-          </a:p>
-          <a:p>
-            <a:pPr>
-              <a:lnSpc>
-                <a:spcPct val="140000"/>
-              </a:lnSpc>
-            </a:pPr>
-            <a:r>
-              <a:rPr lang="en-US" sz="1575">
-                <a:solidFill>
-                  <a:srgbClr val="F1F5E9"/>
-                </a:solidFill>
-                <a:latin typeface="Arial"/>
-                <a:ea typeface="Arial"/>
-              </a:rPr>
-              <a:t>Review remains separate from approval.</a:t>
-            </a:r>
-            <a:endParaRPr/>
-          </a:p>
-        </p:txBody>
-      </p:sp>
-      <p:sp>
-        <p:nvSpPr>
-          <p:cNvPr id="39" name=""/>
+          <p:cNvPr id="37" name=""/>
           <p:cNvSpPr/>
           <p:nvPr/>
         </p:nvSpPr>
         <p:spPr>
-          <a:xfrm rot="0" flipH="0" flipV="0">
-            <a:off x="571500" y="4676775"/>
-            <a:ext cx="11049000" cy="1409700"/>
-          </a:xfrm>
-          <a:prstGeom prst="rect">
-            <a:avLst/>
+          <a:xfrm>
+            <a:off x="4381500" y="4000500"/>
+            <a:ext cx="3429000" cy="1917700"/>
+          </a:xfrm>
+          <a:prstGeom prst="roundRect">
+            <a:avLst>
+              <a:gd name="adj" fmla="val 4376"/>
+            </a:avLst>
           </a:prstGeom>
           <a:solidFill>
             <a:srgbClr val="1D3328"/>
           </a:solidFill>
-          <a:ln/>
+          <a:ln>
+            <a:noFill/>
+          </a:ln>
         </p:spPr>
         <p:txBody>
           <a:bodyPr/>
@@ -2335,34 +2160,64 @@
       </p:sp>
       <p:sp>
         <p:nvSpPr>
-          <p:cNvPr id="40" name="" descr="{&quot;isTemplate&quot;:true,&quot;type&quot;:&quot;text&quot;}"/>
-          <p:cNvSpPr txBox="1"/>
-          <p:nvPr/>
-        </p:nvSpPr>
-        <p:spPr>
-          <a:xfrm rot="0" flipH="0" flipV="0">
-            <a:off x="781050" y="4886325"/>
-            <a:ext cx="10629900" cy="304800"/>
-          </a:xfrm>
-          <a:prstGeom prst="rect"/>
-        </p:spPr>
-        <p:txBody>
-          <a:bodyPr wrap="none" lIns="0" tIns="0" rIns="0" bIns="0"/>
-          <a:p>
-            <a:pPr>
-              <a:lnSpc>
-                <a:spcPct val="100000"/>
-              </a:lnSpc>
-            </a:pPr>
-            <a:r>
-              <a:rPr lang="en-US" sz="1950" b="1">
+          <p:cNvPr id="38" name=""/>
+          <p:cNvSpPr/>
+          <p:nvPr/>
+        </p:nvSpPr>
+        <p:spPr>
+          <a:xfrm>
+            <a:off x="8191500" y="4000500"/>
+            <a:ext cx="3429000" cy="1917700"/>
+          </a:xfrm>
+          <a:prstGeom prst="roundRect">
+            <a:avLst>
+              <a:gd name="adj" fmla="val 4376"/>
+            </a:avLst>
+          </a:prstGeom>
+          <a:solidFill>
+            <a:srgbClr val="1D3328"/>
+          </a:solidFill>
+          <a:ln>
+            <a:noFill/>
+          </a:ln>
+        </p:spPr>
+        <p:txBody>
+          <a:bodyPr/>
+          <a:p/>
+        </p:txBody>
+      </p:sp>
+      <p:sp>
+        <p:nvSpPr>
+          <p:cNvPr id="39" name=""/>
+          <p:cNvSpPr/>
+          <p:nvPr/>
+        </p:nvSpPr>
+        <p:spPr>
+          <a:xfrm>
+            <a:off x="787400" y="4203700"/>
+            <a:ext cx="2997200" cy="317500"/>
+          </a:xfrm>
+          <a:prstGeom prst="rect">
+            <a:avLst/>
+          </a:prstGeom>
+          <a:noFill/>
+          <a:ln>
+            <a:noFill/>
+          </a:ln>
+        </p:spPr>
+        <p:txBody>
+          <a:bodyPr/>
+          <a:p>
+            <a:pPr/>
+            <a:r>
+              <a:rPr lang="zh-CN" sz="2100">
                 <a:solidFill>
                   <a:srgbClr val="CDEA9F"/>
                 </a:solidFill>
                 <a:latin typeface="Arial"/>
                 <a:ea typeface="Arial"/>
               </a:rPr>
-              <a:t>Execution evidence, not just coding assistance</a:t>
+              <a:t>01  First run</a:t>
             </a:r>
             <a:endParaRPr/>
           </a:p>
@@ -2370,52 +2225,114 @@
       </p:sp>
       <p:sp>
         <p:nvSpPr>
-          <p:cNvPr id="41" name="" descr="{&quot;isTemplate&quot;:true,&quot;type&quot;:&quot;text&quot;}"/>
-          <p:cNvSpPr txBox="1"/>
-          <p:nvPr/>
-        </p:nvSpPr>
-        <p:spPr>
-          <a:xfrm rot="0" flipH="0" flipV="0">
-            <a:off x="781050" y="5286375"/>
-            <a:ext cx="10629900" cy="742950"/>
-          </a:xfrm>
-          <a:prstGeom prst="rect"/>
-        </p:spPr>
-        <p:txBody>
-          <a:bodyPr wrap="none" lIns="0" tIns="0" rIns="0" bIns="0"/>
-          <a:p>
-            <a:pPr>
-              <a:lnSpc>
-                <a:spcPct val="140000"/>
-              </a:lnSpc>
-            </a:pPr>
-            <a:r>
-              <a:rPr lang="en-US" sz="1725">
+          <p:cNvPr id="40" name=""/>
+          <p:cNvSpPr/>
+          <p:nvPr/>
+        </p:nvSpPr>
+        <p:spPr>
+          <a:xfrm>
+            <a:off x="787400" y="4686300"/>
+            <a:ext cx="2997200" cy="977900"/>
+          </a:xfrm>
+          <a:prstGeom prst="rect">
+            <a:avLst/>
+          </a:prstGeom>
+          <a:noFill/>
+          <a:ln>
+            <a:noFill/>
+          </a:ln>
+        </p:spPr>
+        <p:txBody>
+          <a:bodyPr/>
+          <a:p>
+            <a:pPr/>
+            <a:r>
+              <a:rPr lang="zh-CN" sz="1800">
                 <a:solidFill>
                   <a:srgbClr val="F1F5E9"/>
                 </a:solidFill>
                 <a:latin typeface="Arial"/>
                 <a:ea typeface="Arial"/>
               </a:rPr>
-              <a:t>Recorded local adapter actions: read → plan → preparation → continuation.</a:t>
+              <a:t>Reads the proposal and goal.
+Prepares details and
+clarification questions.</a:t>
             </a:r>
             <a:endParaRPr/>
           </a:p>
-          <a:p>
-            <a:pPr>
-              <a:lnSpc>
-                <a:spcPct val="140000"/>
-              </a:lnSpc>
-            </a:pPr>
-            <a:r>
-              <a:rPr lang="en-US" sz="1725">
+        </p:txBody>
+      </p:sp>
+      <p:sp>
+        <p:nvSpPr>
+          <p:cNvPr id="41" name=""/>
+          <p:cNvSpPr/>
+          <p:nvPr/>
+        </p:nvSpPr>
+        <p:spPr>
+          <a:xfrm>
+            <a:off x="4597400" y="4203700"/>
+            <a:ext cx="2997200" cy="317500"/>
+          </a:xfrm>
+          <a:prstGeom prst="rect">
+            <a:avLst/>
+          </a:prstGeom>
+          <a:noFill/>
+          <a:ln>
+            <a:noFill/>
+          </a:ln>
+        </p:spPr>
+        <p:txBody>
+          <a:bodyPr/>
+          <a:p>
+            <a:pPr/>
+            <a:r>
+              <a:rPr lang="zh-CN" sz="2100">
+                <a:solidFill>
+                  <a:srgbClr val="CDEA9F"/>
+                </a:solidFill>
+                <a:latin typeface="Arial"/>
+                <a:ea typeface="Arial"/>
+              </a:rPr>
+              <a:t>02  Organiser answers</a:t>
+            </a:r>
+            <a:endParaRPr/>
+          </a:p>
+        </p:txBody>
+      </p:sp>
+      <p:sp>
+        <p:nvSpPr>
+          <p:cNvPr id="42" name=""/>
+          <p:cNvSpPr/>
+          <p:nvPr/>
+        </p:nvSpPr>
+        <p:spPr>
+          <a:xfrm>
+            <a:off x="4597400" y="4686300"/>
+            <a:ext cx="2997200" cy="977900"/>
+          </a:xfrm>
+          <a:prstGeom prst="rect">
+            <a:avLst/>
+          </a:prstGeom>
+          <a:noFill/>
+          <a:ln>
+            <a:noFill/>
+          </a:ln>
+        </p:spPr>
+        <p:txBody>
+          <a:bodyPr/>
+          <a:p>
+            <a:pPr/>
+            <a:r>
+              <a:rPr lang="zh-CN" sz="1800">
                 <a:solidFill>
                   <a:srgbClr val="F1F5E9"/>
                 </a:solidFill>
                 <a:latin typeface="Arial"/>
                 <a:ea typeface="Arial"/>
               </a:rPr>
-              <a:t>Reads precede validated writes; saved answers are reread on explicit resume.</a:t>
+              <a:t>Save the supplied answers.
+Unknowns remain unconfirmed.
+No automatic second run.</a:t>
             </a:r>
             <a:endParaRPr/>
           </a:p>
@@ -2423,69 +2340,75 @@
       </p:sp>
       <p:sp>
         <p:nvSpPr>
-          <p:cNvPr id="42" name="" descr="{&quot;isTemplate&quot;:true,&quot;type&quot;:&quot;text&quot;}"/>
-          <p:cNvSpPr txBox="1"/>
-          <p:nvPr/>
-        </p:nvSpPr>
-        <p:spPr>
-          <a:xfrm rot="0" flipH="0" flipV="0">
-            <a:off x="571500" y="6391275"/>
-            <a:ext cx="4086225" cy="171450"/>
-          </a:xfrm>
-          <a:prstGeom prst="rect"/>
-        </p:spPr>
-        <p:txBody>
-          <a:bodyPr wrap="none" lIns="0" tIns="0" rIns="0" bIns="0"/>
-          <a:p>
-            <a:pPr>
-              <a:lnSpc>
-                <a:spcPct val="100000"/>
-              </a:lnSpc>
-            </a:pPr>
-            <a:r>
-              <a:rPr lang="en-US" sz="1125">
+          <p:cNvPr id="43" name=""/>
+          <p:cNvSpPr/>
+          <p:nvPr/>
+        </p:nvSpPr>
+        <p:spPr>
+          <a:xfrm>
+            <a:off x="8407400" y="4203700"/>
+            <a:ext cx="2997200" cy="317500"/>
+          </a:xfrm>
+          <a:prstGeom prst="rect">
+            <a:avLst/>
+          </a:prstGeom>
+          <a:noFill/>
+          <a:ln>
+            <a:noFill/>
+          </a:ln>
+        </p:spPr>
+        <p:txBody>
+          <a:bodyPr/>
+          <a:p>
+            <a:pPr/>
+            <a:r>
+              <a:rPr lang="zh-CN" sz="2100">
+                <a:solidFill>
+                  <a:srgbClr val="CDEA9F"/>
+                </a:solidFill>
+                <a:latin typeface="Arial"/>
+                <a:ea typeface="Arial"/>
+              </a:rPr>
+              <a:t>03  Later explicit run</a:t>
+            </a:r>
+            <a:endParaRPr/>
+          </a:p>
+        </p:txBody>
+      </p:sp>
+      <p:sp>
+        <p:nvSpPr>
+          <p:cNvPr id="44" name=""/>
+          <p:cNvSpPr/>
+          <p:nvPr/>
+        </p:nvSpPr>
+        <p:spPr>
+          <a:xfrm>
+            <a:off x="8407400" y="4686300"/>
+            <a:ext cx="2997200" cy="977900"/>
+          </a:xfrm>
+          <a:prstGeom prst="rect">
+            <a:avLst/>
+          </a:prstGeom>
+          <a:noFill/>
+          <a:ln>
+            <a:noFill/>
+          </a:ln>
+        </p:spPr>
+        <p:txBody>
+          <a:bodyPr/>
+          <a:p>
+            <a:pPr/>
+            <a:r>
+              <a:rPr lang="zh-CN" sz="1800">
                 <a:solidFill>
                   <a:srgbClr val="F1F5E9"/>
                 </a:solidFill>
                 <a:latin typeface="Arial"/>
                 <a:ea typeface="Arial"/>
               </a:rPr>
-              <a:t>Historical WorkBuddy execution · No automatic website dispatch</a:t>
-            </a:r>
-            <a:endParaRPr/>
-          </a:p>
-        </p:txBody>
-      </p:sp>
-      <p:sp>
-        <p:nvSpPr>
-          <p:cNvPr id="43" name="" descr="{&quot;isTemplate&quot;:true,&quot;type&quot;:&quot;text&quot;}"/>
-          <p:cNvSpPr txBox="1"/>
-          <p:nvPr/>
-        </p:nvSpPr>
-        <p:spPr>
-          <a:xfrm rot="0" flipH="0" flipV="0">
-            <a:off x="11182350" y="6391275"/>
-            <a:ext cx="438150" cy="171450"/>
-          </a:xfrm>
-          <a:prstGeom prst="rect"/>
-        </p:spPr>
-        <p:txBody>
-          <a:bodyPr wrap="none" lIns="0" tIns="0" rIns="0" bIns="0"/>
-          <a:p>
-            <a:pPr>
-              <a:lnSpc>
-                <a:spcPct val="100000"/>
-              </a:lnSpc>
-            </a:pPr>
-            <a:r>
-              <a:rPr lang="en-US" sz="1125">
-                <a:solidFill>
-                  <a:srgbClr val="F1F5E9"/>
-                </a:solidFill>
-                <a:latin typeface="Arial"/>
-                <a:ea typeface="Arial"/>
-              </a:rPr>
-              <a:t>03 / 06</a:t>
+              <a:t>Draft source-linked cards.
+Organiser edits and reviews.
+Review is not approval.</a:t>
             </a:r>
             <a:endParaRPr/>
           </a:p>
@@ -2501,7 +2424,7 @@
   <p:cSld>
     <p:spTree>
       <p:nvGrpSpPr>
-        <p:cNvPr id="44" name="" descr="&lt;Slide notes=&quot;Our fictional Blue Lane group proposes First Splash Swimming Clinic for beginner students. The drafts request 48 sealed 500 millilitre bottles, a loan of 12 kickboards, and one coach for three hours. Only a written student-team thank-you is offered. The 7 November date and 24-person estimate are proposed; Demo Training Pool access and permissions remain unconfirmed. No contribution is secured, and coaching qualifications and supervision have not been verified.&quot; style={{width:1280,height:720,padding:'20px 60px',background:'#0E1915',fontFamily:'Arial',color:'#F1F5E9'}}&gt;&#10;&lt;Box style={{height:100,justifyContent:'center',gap:8}}&gt;&lt;Text style={{fontSize:18,color:'#CDEA9F'}}&gt;FICTIONAL SWIMMING-CLINIC DEMO&lt;/Text&gt;&lt;Text style={{fontSize:38,fontWeight:700}}&gt;Three concrete requests. No invented commitments.&lt;/Text&gt;&lt;/Box&gt;&#10;&lt;Box style={{height:540,flexDirection:'row',gap:38,alignItems:'center'}}&gt;&#10;&lt;Box style={{width:710,height:512,justifyContent:'center',gap:8}}&gt;&lt;Image src=&quot;SponsorBridge-ui-package-card.png&quot; style={{width:710,height:510,objectFit:'contain'}}/&gt;&lt;/Box&gt;&#10;&lt;Box style={{width:412,height:512,gap:12,justifyContent:'center'}}&gt;&#10;&lt;Text style={{fontSize:52,fontWeight:700,color:'#CDEA9F'}}&gt;48 bottles&lt;/Text&gt;&lt;Text style={{fontSize:25,lineHeight:1.3}}&gt;Sealed 500 ml drinking water&lt;/Text&gt;&#10;&lt;Text style={{fontSize:28,fontWeight:700}}&gt;12 kickboards on loan&lt;/Text&gt;&lt;Text style={{fontSize:28,fontWeight:700}}&gt;1 coach × 3 hours&lt;/Text&gt;&#10;&lt;Box style={{height:130,background:'#1D3328',padding:18,gap:8}}&gt;&lt;Text style={{fontSize:24,fontWeight:700,color:'#CDEA9F'}}&gt;Thank-you only&lt;/Text&gt;&lt;Text style={{fontSize:21,lineHeight:1.35}}&gt;Written by the student team.&lt;br/&gt;No extra rights or endorsement.&lt;/Text&gt;&lt;/Box&gt;&#10;&lt;Text style={{fontSize:20,lineHeight:1.45}}&gt;Proposed: 7 Nov 2026, 09:00–12:00.&lt;br/&gt;24 participants is a planning estimate.&lt;br/&gt;Venue, permissions and acceptance&lt;br/&gt;remain unconfirmed.&lt;/Text&gt;&#10;&lt;/Box&gt;&lt;/Box&gt;&#10;&lt;Box style={{height:40,flexDirection:'row',justifyContent:'space-between',alignItems:'center'}}&gt;&lt;Text style={{fontSize:15}}&gt;Historical screenshot · Fictional test material · Review is not approval&lt;/Text&gt;&lt;Text style={{fontSize:15}}&gt;04 / 06&lt;/Text&gt;&lt;/Box&gt;&#10;&lt;/Slide&gt;"/>
+        <p:cNvPr id="45" name=""/>
         <p:cNvGrpSpPr/>
         <p:nvPr/>
       </p:nvGrpSpPr>
@@ -2515,7 +2438,7 @@
       </p:grpSpPr>
       <p:sp>
         <p:nvSpPr>
-          <p:cNvPr id="45" name=""/>
+          <p:cNvPr id="46" name=""/>
           <p:cNvSpPr/>
           <p:nvPr/>
         </p:nvSpPr>
@@ -2534,12 +2457,15 @@
         </p:spPr>
         <p:txBody>
           <a:bodyPr/>
-          <a:p/>
-        </p:txBody>
-      </p:sp>
-      <p:sp>
-        <p:nvSpPr>
-          <p:cNvPr id="46" name="" descr="{&quot;isTemplate&quot;:true,&quot;type&quot;:&quot;text&quot;}"/>
+          <a:p>
+            <a:pPr/>
+            <a:endParaRPr/>
+          </a:p>
+        </p:txBody>
+      </p:sp>
+      <p:sp>
+        <p:nvSpPr>
+          <p:cNvPr id="47" name="" descr="{&quot;isTemplate&quot;:true,&quot;type&quot;:&quot;text&quot;}"/>
           <p:cNvSpPr txBox="1"/>
           <p:nvPr/>
         </p:nvSpPr>
@@ -2559,22 +2485,28 @@
               </a:lnSpc>
             </a:pPr>
             <a:r>
-              <a:rPr lang="en-US" sz="1350">
+              <a:rPr lang="zh-CN" sz="1350">
                 <a:solidFill>
                   <a:srgbClr val="CDEA9F"/>
                 </a:solidFill>
                 <a:latin typeface="Arial"/>
                 <a:ea typeface="Arial"/>
               </a:rPr>
-              <a:t>FICTIONAL SWIMMING-CLINIC DEMO</a:t>
-            </a:r>
-            <a:endParaRPr/>
-          </a:p>
-        </p:txBody>
-      </p:sp>
-      <p:sp>
-        <p:nvSpPr>
-          <p:cNvPr id="47" name="" descr="{&quot;isTemplate&quot;:true,&quot;type&quot;:&quot;text&quot;}"/>
+              <a:t>SAVED FICTIONAL CAMPUS SUSTAINABILITY FAIR</a:t>
+            </a:r>
+            <a:endParaRPr lang="zh-CN" sz="1350">
+              <a:solidFill>
+                <a:srgbClr val="CDEA9F"/>
+              </a:solidFill>
+              <a:latin typeface="Arial"/>
+              <a:ea typeface="Arial"/>
+            </a:endParaRPr>
+          </a:p>
+        </p:txBody>
+      </p:sp>
+      <p:sp>
+        <p:nvSpPr>
+          <p:cNvPr id="48" name="" descr="{&quot;isTemplate&quot;:true,&quot;type&quot;:&quot;text&quot;}"/>
           <p:cNvSpPr txBox="1"/>
           <p:nvPr/>
         </p:nvSpPr>
@@ -2594,14 +2526,96 @@
               </a:lnSpc>
             </a:pPr>
             <a:r>
-              <a:rPr lang="en-US" sz="2850" b="1">
+              <a:rPr lang="zh-CN" sz="2850" b="1">
                 <a:solidFill>
                   <a:srgbClr val="F1F5E9"/>
                 </a:solidFill>
                 <a:latin typeface="Arial"/>
                 <a:ea typeface="Arial"/>
               </a:rPr>
-              <a:t>Three concrete requests. No invented commitments.</a:t>
+              <a:t>Two in-kind cards. Unknowns stay unconfirmed.</a:t>
+            </a:r>
+            <a:endParaRPr lang="zh-CN" sz="2850" b="1">
+              <a:solidFill>
+                <a:srgbClr val="F1F5E9"/>
+              </a:solidFill>
+              <a:latin typeface="Arial"/>
+              <a:ea typeface="Arial"/>
+            </a:endParaRPr>
+          </a:p>
+        </p:txBody>
+      </p:sp>
+      <p:sp>
+        <p:nvSpPr>
+          <p:cNvPr id="49" name="" descr="{&quot;isTemplate&quot;:true,&quot;type&quot;:&quot;text&quot;}"/>
+          <p:cNvSpPr txBox="1"/>
+          <p:nvPr/>
+        </p:nvSpPr>
+        <p:spPr>
+          <a:xfrm rot="0" flipH="0" flipV="0">
+            <a:off x="571500" y="6391275"/>
+            <a:ext cx="4371975" cy="171450"/>
+          </a:xfrm>
+          <a:prstGeom prst="rect"/>
+        </p:spPr>
+        <p:txBody>
+          <a:bodyPr wrap="none" lIns="0" tIns="0" rIns="0" bIns="0"/>
+          <a:p>
+            <a:pPr>
+              <a:lnSpc>
+                <a:spcPct val="100000"/>
+              </a:lnSpc>
+            </a:pPr>
+            <a:r>
+              <a:rPr lang="zh-CN" sz="1100">
+                <a:solidFill>
+                  <a:srgbClr val="F1F5E9"/>
+                </a:solidFill>
+                <a:latin typeface="Arial"/>
+                <a:ea typeface="Arial"/>
+              </a:rPr>
+              <a:t>Recovered live CodeBuddy content · Validated and saved · Not a fresh live run</a:t>
+            </a:r>
+            <a:endParaRPr lang="zh-CN" sz="1100">
+              <a:solidFill>
+                <a:srgbClr val="F1F5E9"/>
+              </a:solidFill>
+              <a:latin typeface="Arial"/>
+              <a:ea typeface="Arial"/>
+            </a:endParaRPr>
+          </a:p>
+        </p:txBody>
+      </p:sp>
+      <p:sp>
+        <p:nvSpPr>
+          <p:cNvPr id="50" name="" descr="{&quot;isTemplate&quot;:true,&quot;type&quot;:&quot;text&quot;}"/>
+          <p:cNvSpPr txBox="1"/>
+          <p:nvPr/>
+        </p:nvSpPr>
+        <p:spPr>
+          <a:xfrm rot="0" flipH="0" flipV="0">
+            <a:off x="11182350" y="6391275"/>
+            <a:ext cx="438150" cy="171450"/>
+          </a:xfrm>
+          <a:prstGeom prst="rect"/>
+        </p:spPr>
+        <p:txBody>
+          <a:bodyPr wrap="none" lIns="0" tIns="0" rIns="0" bIns="0"/>
+          <a:p>
+            <a:pPr>
+              <a:lnSpc>
+                <a:spcPct val="100000"/>
+              </a:lnSpc>
+            </a:pPr>
+            <a:r>
+              <a:rPr lang="en-US" sz="1125">
+                <a:solidFill>
+                  <a:srgbClr val="F1F5E9"/>
+                </a:solidFill>
+                <a:latin typeface="Arial"/>
+                <a:ea typeface="Arial"/>
+              </a:rPr>
+              <a:t>04 / 06</a:t>
             </a:r>
             <a:endParaRPr/>
           </a:p>
@@ -2609,60 +2623,73 @@
       </p:sp>
       <p:pic>
         <p:nvPicPr>
-          <p:cNvPr id="48" name=""/>
-          <p:cNvPicPr>
-            <a:picLocks noChangeAspect="1"/>
-          </p:cNvPicPr>
+          <p:cNvPr id="51" name=""/>
+          <p:cNvPicPr/>
           <p:nvPr/>
         </p:nvPicPr>
         <p:blipFill>
           <a:blip r:embed="rId2"/>
-          <a:srcRect l="0" t="89" r="0" b="89"/>
-          <a:stretch>
-            <a:fillRect/>
-          </a:stretch>
+          <a:stretch/>
         </p:blipFill>
         <p:spPr>
-          <a:xfrm rot="0" flipH="0" flipV="0">
-            <a:off x="571500" y="1285875"/>
-            <a:ext cx="6762750" cy="4857750"/>
+          <a:xfrm>
+            <a:off x="571500" y="1295400"/>
+            <a:ext cx="3296786" cy="4622800"/>
+          </a:xfrm>
+          <a:prstGeom prst="rect"/>
+        </p:spPr>
+      </p:pic>
+      <p:pic>
+        <p:nvPicPr>
+          <p:cNvPr id="52" name=""/>
+          <p:cNvPicPr/>
+          <p:nvPr/>
+        </p:nvPicPr>
+        <p:blipFill>
+          <a:blip r:embed="rId3"/>
+          <a:stretch/>
+        </p:blipFill>
+        <p:spPr>
+          <a:xfrm>
+            <a:off x="4191000" y="1295400"/>
+            <a:ext cx="3296786" cy="4622800"/>
+          </a:xfrm>
+          <a:prstGeom prst="rect"/>
+        </p:spPr>
+      </p:pic>
+      <p:sp>
+        <p:nvSpPr>
+          <p:cNvPr id="53" name=""/>
+          <p:cNvSpPr/>
+          <p:nvPr/>
+        </p:nvSpPr>
+        <p:spPr>
+          <a:xfrm>
+            <a:off x="7874000" y="1384300"/>
+            <a:ext cx="3746500" cy="635000"/>
           </a:xfrm>
           <a:prstGeom prst="rect">
             <a:avLst/>
           </a:prstGeom>
-          <a:ln/>
-        </p:spPr>
-      </p:pic>
-      <p:sp>
-        <p:nvSpPr>
-          <p:cNvPr id="49" name="" descr="{&quot;isTemplate&quot;:true,&quot;type&quot;:&quot;text&quot;}"/>
-          <p:cNvSpPr txBox="1"/>
-          <p:nvPr/>
-        </p:nvSpPr>
-        <p:spPr>
-          <a:xfrm rot="0" flipH="0" flipV="0">
-            <a:off x="7696200" y="1333500"/>
-            <a:ext cx="3924300" cy="600075"/>
-          </a:xfrm>
-          <a:prstGeom prst="rect"/>
-        </p:spPr>
-        <p:txBody>
-          <a:bodyPr wrap="none" lIns="0" tIns="0" rIns="0" bIns="0"/>
-          <a:p>
-            <a:pPr>
-              <a:lnSpc>
-                <a:spcPct val="100000"/>
-              </a:lnSpc>
-            </a:pPr>
-            <a:r>
-              <a:rPr lang="en-US" sz="3900" b="1">
+          <a:noFill/>
+          <a:ln>
+            <a:noFill/>
+          </a:ln>
+        </p:spPr>
+        <p:txBody>
+          <a:bodyPr/>
+          <a:p>
+            <a:pPr/>
+            <a:r>
+              <a:rPr lang="zh-CN" sz="2200">
                 <a:solidFill>
                   <a:srgbClr val="CDEA9F"/>
                 </a:solidFill>
                 <a:latin typeface="Arial"/>
                 <a:ea typeface="Arial"/>
               </a:rPr>
-              <a:t>48 bottles</a:t>
+              <a:t>Reusable bottles +
+repair-workshop materials</a:t>
             </a:r>
             <a:endParaRPr/>
           </a:p>
@@ -2670,163 +2697,36 @@
       </p:sp>
       <p:sp>
         <p:nvSpPr>
-          <p:cNvPr id="50" name="" descr="{&quot;isTemplate&quot;:true,&quot;type&quot;:&quot;text&quot;}"/>
-          <p:cNvSpPr txBox="1"/>
-          <p:nvPr/>
-        </p:nvSpPr>
-        <p:spPr>
-          <a:xfrm rot="0" flipH="0" flipV="0">
-            <a:off x="7696200" y="2047875"/>
-            <a:ext cx="3924300" cy="371475"/>
-          </a:xfrm>
-          <a:prstGeom prst="rect"/>
-        </p:spPr>
-        <p:txBody>
-          <a:bodyPr wrap="none" lIns="0" tIns="0" rIns="0" bIns="0"/>
-          <a:p>
-            <a:pPr>
-              <a:lnSpc>
-                <a:spcPct val="130000"/>
-              </a:lnSpc>
-            </a:pPr>
-            <a:r>
-              <a:rPr lang="en-US" sz="1875">
-                <a:solidFill>
-                  <a:srgbClr val="F1F5E9"/>
-                </a:solidFill>
-                <a:latin typeface="Arial"/>
-                <a:ea typeface="Arial"/>
-              </a:rPr>
-              <a:t>Sealed 500 ml drinking water</a:t>
-            </a:r>
-            <a:endParaRPr/>
-          </a:p>
-        </p:txBody>
-      </p:sp>
-      <p:sp>
-        <p:nvSpPr>
-          <p:cNvPr id="51" name="" descr="{&quot;isTemplate&quot;:true,&quot;type&quot;:&quot;text&quot;}"/>
-          <p:cNvSpPr txBox="1"/>
-          <p:nvPr/>
-        </p:nvSpPr>
-        <p:spPr>
-          <a:xfrm rot="0" flipH="0" flipV="0">
-            <a:off x="7696200" y="2533650"/>
-            <a:ext cx="3924300" cy="323850"/>
-          </a:xfrm>
-          <a:prstGeom prst="rect"/>
-        </p:spPr>
-        <p:txBody>
-          <a:bodyPr wrap="none" lIns="0" tIns="0" rIns="0" bIns="0"/>
-          <a:p>
-            <a:pPr>
-              <a:lnSpc>
-                <a:spcPct val="100000"/>
-              </a:lnSpc>
-            </a:pPr>
-            <a:r>
-              <a:rPr lang="en-US" sz="2100" b="1">
-                <a:solidFill>
-                  <a:srgbClr val="F1F5E9"/>
-                </a:solidFill>
-                <a:latin typeface="Arial"/>
-                <a:ea typeface="Arial"/>
-              </a:rPr>
-              <a:t>12 kickboards on loan</a:t>
-            </a:r>
-            <a:endParaRPr/>
-          </a:p>
-        </p:txBody>
-      </p:sp>
-      <p:sp>
-        <p:nvSpPr>
-          <p:cNvPr id="52" name="" descr="{&quot;isTemplate&quot;:true,&quot;type&quot;:&quot;text&quot;}"/>
-          <p:cNvSpPr txBox="1"/>
-          <p:nvPr/>
-        </p:nvSpPr>
-        <p:spPr>
-          <a:xfrm rot="0" flipH="0" flipV="0">
-            <a:off x="7696200" y="2971800"/>
-            <a:ext cx="3924300" cy="323850"/>
-          </a:xfrm>
-          <a:prstGeom prst="rect"/>
-        </p:spPr>
-        <p:txBody>
-          <a:bodyPr wrap="none" lIns="0" tIns="0" rIns="0" bIns="0"/>
-          <a:p>
-            <a:pPr>
-              <a:lnSpc>
-                <a:spcPct val="100000"/>
-              </a:lnSpc>
-            </a:pPr>
-            <a:r>
-              <a:rPr lang="en-US" sz="2100" b="1">
-                <a:solidFill>
-                  <a:srgbClr val="F1F5E9"/>
-                </a:solidFill>
-                <a:latin typeface="Arial"/>
-                <a:ea typeface="Arial"/>
-              </a:rPr>
-              <a:t>1 coach × 3 hours</a:t>
-            </a:r>
-            <a:endParaRPr/>
-          </a:p>
-        </p:txBody>
-      </p:sp>
-      <p:sp>
-        <p:nvSpPr>
-          <p:cNvPr id="53" name=""/>
+          <p:cNvPr id="54" name=""/>
           <p:cNvSpPr/>
           <p:nvPr/>
         </p:nvSpPr>
         <p:spPr>
-          <a:xfrm rot="0" flipH="0" flipV="0">
-            <a:off x="7696200" y="3409950"/>
-            <a:ext cx="3924300" cy="1238250"/>
+          <a:xfrm>
+            <a:off x="7874000" y="2260600"/>
+            <a:ext cx="3746500" cy="304800"/>
           </a:xfrm>
           <a:prstGeom prst="rect">
             <a:avLst/>
           </a:prstGeom>
-          <a:solidFill>
-            <a:srgbClr val="1D3328"/>
-          </a:solidFill>
-          <a:ln/>
+          <a:noFill/>
+          <a:ln>
+            <a:noFill/>
+          </a:ln>
         </p:spPr>
         <p:txBody>
           <a:bodyPr/>
-          <a:p/>
-        </p:txBody>
-      </p:sp>
-      <p:sp>
-        <p:nvSpPr>
-          <p:cNvPr id="54" name="" descr="{&quot;isTemplate&quot;:true,&quot;type&quot;:&quot;text&quot;}"/>
-          <p:cNvSpPr txBox="1"/>
-          <p:nvPr/>
-        </p:nvSpPr>
-        <p:spPr>
-          <a:xfrm rot="0" flipH="0" flipV="0">
-            <a:off x="7867650" y="3581400"/>
-            <a:ext cx="3581400" cy="276225"/>
-          </a:xfrm>
-          <a:prstGeom prst="rect"/>
-        </p:spPr>
-        <p:txBody>
-          <a:bodyPr wrap="none" lIns="0" tIns="0" rIns="0" bIns="0"/>
-          <a:p>
-            <a:pPr>
-              <a:lnSpc>
-                <a:spcPct val="100000"/>
-              </a:lnSpc>
-            </a:pPr>
-            <a:r>
-              <a:rPr lang="en-US" sz="1800" b="1">
+          <a:p>
+            <a:pPr/>
+            <a:r>
+              <a:rPr lang="zh-CN" sz="1700">
                 <a:solidFill>
                   <a:srgbClr val="CDEA9F"/>
                 </a:solidFill>
                 <a:latin typeface="Arial"/>
                 <a:ea typeface="Arial"/>
               </a:rPr>
-              <a:t>Thank-you only</a:t>
+              <a:t>Organiser-stated draft benefits</a:t>
             </a:r>
             <a:endParaRPr/>
           </a:p>
@@ -2834,211 +2734,115 @@
       </p:sp>
       <p:sp>
         <p:nvSpPr>
-          <p:cNvPr id="55" name="" descr="{&quot;isTemplate&quot;:true,&quot;type&quot;:&quot;text&quot;}"/>
-          <p:cNvSpPr txBox="1"/>
-          <p:nvPr/>
-        </p:nvSpPr>
-        <p:spPr>
-          <a:xfrm rot="0" flipH="0" flipV="0">
-            <a:off x="7867650" y="3933825"/>
-            <a:ext cx="3581400" cy="657225"/>
-          </a:xfrm>
-          <a:prstGeom prst="rect"/>
-        </p:spPr>
-        <p:txBody>
-          <a:bodyPr wrap="none" lIns="0" tIns="0" rIns="0" bIns="0"/>
-          <a:p>
-            <a:pPr>
-              <a:lnSpc>
-                <a:spcPct val="135000"/>
-              </a:lnSpc>
-            </a:pPr>
-            <a:r>
-              <a:rPr lang="en-US" sz="1575">
+          <p:cNvPr id="55" name=""/>
+          <p:cNvSpPr/>
+          <p:nvPr/>
+        </p:nvSpPr>
+        <p:spPr>
+          <a:xfrm>
+            <a:off x="7874000" y="2679700"/>
+            <a:ext cx="3746500" cy="927100"/>
+          </a:xfrm>
+          <a:prstGeom prst="rect">
+            <a:avLst/>
+          </a:prstGeom>
+          <a:noFill/>
+          <a:ln>
+            <a:noFill/>
+          </a:ln>
+        </p:spPr>
+        <p:txBody>
+          <a:bodyPr/>
+          <a:p>
+            <a:pPr/>
+            <a:r>
+              <a:rPr lang="zh-CN" sz="1900">
                 <a:solidFill>
                   <a:srgbClr val="F1F5E9"/>
                 </a:solidFill>
                 <a:latin typeface="Arial"/>
                 <a:ea typeface="Arial"/>
               </a:rPr>
-              <a:t>Written by the student team.</a:t>
+              <a:t>Logo on the event page.
+Verbal thank-you during
+opening remarks.</a:t>
             </a:r>
             <a:endParaRPr/>
           </a:p>
-          <a:p>
-            <a:pPr>
-              <a:lnSpc>
-                <a:spcPct val="135000"/>
-              </a:lnSpc>
-            </a:pPr>
-            <a:r>
-              <a:rPr lang="en-US" sz="1575">
+        </p:txBody>
+      </p:sp>
+      <p:sp>
+        <p:nvSpPr>
+          <p:cNvPr id="56" name=""/>
+          <p:cNvSpPr/>
+          <p:nvPr/>
+        </p:nvSpPr>
+        <p:spPr>
+          <a:xfrm>
+            <a:off x="7874000" y="3835400"/>
+            <a:ext cx="3746500" cy="317500"/>
+          </a:xfrm>
+          <a:prstGeom prst="rect">
+            <a:avLst/>
+          </a:prstGeom>
+          <a:noFill/>
+          <a:ln>
+            <a:noFill/>
+          </a:ln>
+        </p:spPr>
+        <p:txBody>
+          <a:bodyPr/>
+          <a:p>
+            <a:pPr/>
+            <a:r>
+              <a:rPr lang="zh-CN" sz="1800">
+                <a:solidFill>
+                  <a:srgbClr val="CDEA9F"/>
+                </a:solidFill>
+                <a:latin typeface="Arial"/>
+                <a:ea typeface="Arial"/>
+              </a:rPr>
+              <a:t>Still unconfirmed</a:t>
+            </a:r>
+            <a:endParaRPr/>
+          </a:p>
+        </p:txBody>
+      </p:sp>
+      <p:sp>
+        <p:nvSpPr>
+          <p:cNvPr id="57" name=""/>
+          <p:cNvSpPr/>
+          <p:nvPr/>
+        </p:nvSpPr>
+        <p:spPr>
+          <a:xfrm>
+            <a:off x="7874000" y="4279900"/>
+            <a:ext cx="3746500" cy="1422400"/>
+          </a:xfrm>
+          <a:prstGeom prst="rect">
+            <a:avLst/>
+          </a:prstGeom>
+          <a:noFill/>
+          <a:ln>
+            <a:noFill/>
+          </a:ln>
+        </p:spPr>
+        <p:txBody>
+          <a:bodyPr/>
+          <a:p>
+            <a:pPr/>
+            <a:r>
+              <a:rPr lang="zh-CN" sz="1800">
                 <a:solidFill>
                   <a:srgbClr val="F1F5E9"/>
                 </a:solidFill>
                 <a:latin typeface="Arial"/>
                 <a:ea typeface="Arial"/>
               </a:rPr>
-              <a:t>No extra rights or endorsement.</a:t>
-            </a:r>
-            <a:endParaRPr/>
-          </a:p>
-        </p:txBody>
-      </p:sp>
-      <p:sp>
-        <p:nvSpPr>
-          <p:cNvPr id="56" name="" descr="{&quot;isTemplate&quot;:true,&quot;type&quot;:&quot;text&quot;}"/>
-          <p:cNvSpPr txBox="1"/>
-          <p:nvPr/>
-        </p:nvSpPr>
-        <p:spPr>
-          <a:xfrm rot="0" flipH="0" flipV="0">
-            <a:off x="7696200" y="4762500"/>
-            <a:ext cx="3924300" cy="1333500"/>
-          </a:xfrm>
-          <a:prstGeom prst="rect"/>
-        </p:spPr>
-        <p:txBody>
-          <a:bodyPr wrap="none" lIns="0" tIns="0" rIns="0" bIns="0"/>
-          <a:p>
-            <a:pPr>
-              <a:lnSpc>
-                <a:spcPct val="145000"/>
-              </a:lnSpc>
-            </a:pPr>
-            <a:r>
-              <a:rPr lang="en-US" sz="1500">
-                <a:solidFill>
-                  <a:srgbClr val="F1F5E9"/>
-                </a:solidFill>
-                <a:latin typeface="Arial"/>
-                <a:ea typeface="Arial"/>
-              </a:rPr>
-              <a:t>Proposed: 7 Nov 2026, 09:00–12:00.</a:t>
-            </a:r>
-            <a:endParaRPr/>
-          </a:p>
-          <a:p>
-            <a:pPr>
-              <a:lnSpc>
-                <a:spcPct val="145000"/>
-              </a:lnSpc>
-            </a:pPr>
-            <a:r>
-              <a:rPr lang="en-US" sz="1500">
-                <a:solidFill>
-                  <a:srgbClr val="F1F5E9"/>
-                </a:solidFill>
-                <a:latin typeface="Arial"/>
-                <a:ea typeface="Arial"/>
-              </a:rPr>
-              <a:t>24 participants is a planning estimate.</a:t>
-            </a:r>
-            <a:endParaRPr/>
-          </a:p>
-          <a:p>
-            <a:pPr>
-              <a:lnSpc>
-                <a:spcPct val="145000"/>
-              </a:lnSpc>
-            </a:pPr>
-            <a:r>
-              <a:rPr lang="en-US" sz="1500">
-                <a:solidFill>
-                  <a:srgbClr val="F1F5E9"/>
-                </a:solidFill>
-                <a:latin typeface="Arial"/>
-                <a:ea typeface="Arial"/>
-              </a:rPr>
-              <a:t>Venue, permissions and acceptance</a:t>
-            </a:r>
-            <a:endParaRPr/>
-          </a:p>
-          <a:p>
-            <a:pPr>
-              <a:lnSpc>
-                <a:spcPct val="145000"/>
-              </a:lnSpc>
-            </a:pPr>
-            <a:r>
-              <a:rPr lang="en-US" sz="1500">
-                <a:solidFill>
-                  <a:srgbClr val="F1F5E9"/>
-                </a:solidFill>
-                <a:latin typeface="Arial"/>
-                <a:ea typeface="Arial"/>
-              </a:rPr>
-              <a:t>remain unconfirmed.</a:t>
-            </a:r>
-            <a:endParaRPr/>
-          </a:p>
-        </p:txBody>
-      </p:sp>
-      <p:sp>
-        <p:nvSpPr>
-          <p:cNvPr id="57" name="" descr="{&quot;isTemplate&quot;:true,&quot;type&quot;:&quot;text&quot;}"/>
-          <p:cNvSpPr txBox="1"/>
-          <p:nvPr/>
-        </p:nvSpPr>
-        <p:spPr>
-          <a:xfrm rot="0" flipH="0" flipV="0">
-            <a:off x="571500" y="6391275"/>
-            <a:ext cx="4371975" cy="171450"/>
-          </a:xfrm>
-          <a:prstGeom prst="rect"/>
-        </p:spPr>
-        <p:txBody>
-          <a:bodyPr wrap="none" lIns="0" tIns="0" rIns="0" bIns="0"/>
-          <a:p>
-            <a:pPr>
-              <a:lnSpc>
-                <a:spcPct val="100000"/>
-              </a:lnSpc>
-            </a:pPr>
-            <a:r>
-              <a:rPr lang="en-US" sz="1125">
-                <a:solidFill>
-                  <a:srgbClr val="F1F5E9"/>
-                </a:solidFill>
-                <a:latin typeface="Arial"/>
-                <a:ea typeface="Arial"/>
-              </a:rPr>
-              <a:t>Historical screenshot · Fictional test material · Review is not approval</a:t>
-            </a:r>
-            <a:endParaRPr/>
-          </a:p>
-        </p:txBody>
-      </p:sp>
-      <p:sp>
-        <p:nvSpPr>
-          <p:cNvPr id="58" name="" descr="{&quot;isTemplate&quot;:true,&quot;type&quot;:&quot;text&quot;}"/>
-          <p:cNvSpPr txBox="1"/>
-          <p:nvPr/>
-        </p:nvSpPr>
-        <p:spPr>
-          <a:xfrm rot="0" flipH="0" flipV="0">
-            <a:off x="11182350" y="6391275"/>
-            <a:ext cx="438150" cy="171450"/>
-          </a:xfrm>
-          <a:prstGeom prst="rect"/>
-        </p:spPr>
-        <p:txBody>
-          <a:bodyPr wrap="none" lIns="0" tIns="0" rIns="0" bIns="0"/>
-          <a:p>
-            <a:pPr>
-              <a:lnSpc>
-                <a:spcPct val="100000"/>
-              </a:lnSpc>
-            </a:pPr>
-            <a:r>
-              <a:rPr lang="en-US" sz="1125">
-                <a:solidFill>
-                  <a:srgbClr val="F1F5E9"/>
-                </a:solidFill>
-                <a:latin typeface="Arial"/>
-                <a:ea typeface="Arial"/>
-              </a:rPr>
-              <a:t>04 / 06</a:t>
+              <a:t>Items / quantities and timing.
+Venue and event permissions.
+Both cards await content review.
+No sponsor acceptance.</a:t>
             </a:r>
             <a:endParaRPr/>
           </a:p>
@@ -3054,7 +2858,7 @@
   <p:cSld>
     <p:spTree>
       <p:nvGrpSpPr>
-        <p:cNvPr id="59" name="" descr="&lt;Slide notes=&quot;I kept the runtime small: responsive HTML, CSS and JavaScript, a local Node service, and JSON persistence. The adapter bounds the agent's operations and requires a fresh read receipt for writes. Editing clears that package's review; new answers stale the continuation and invalidate reviews. The copied submission passed 22 existing Node checks on 11 October, as reported. The 63 browser UI checks are from earlier WorkBuddy reports on 10 October, not a fresh rerun for this submission.&quot; style={{width:1280,height:720,padding:'20px 60px',background:'#0E1915',fontFamily:'Arial',color:'#F1F5E9'}}&gt;&#10;&lt;Box style={{height:100,justifyContent:'center',gap:8}}&gt;&lt;Text style={{fontSize:18,color:'#CDEA9F'}}&gt;IMPLEMENTATION AND EVIDENCE&lt;/Text&gt;&lt;Text style={{fontSize:38,fontWeight:700}}&gt;Small local stack. Persistent, reviewable outputs.&lt;/Text&gt;&lt;/Box&gt;&#10;&lt;Box style={{height:540,flexDirection:'row',gap:42,alignItems:'center'}}&gt;&#10;&lt;Box style={{width:650,height:510,gap:16,justifyContent:'center'}}&gt;&#10;&lt;Box style={{height:205,background:'#1D3328',padding:24,gap:12}}&gt;&lt;Text style={{fontSize:28,fontWeight:700,color:'#CDEA9F'}}&gt;Browser → Node → local JSON&lt;/Text&gt;&lt;Text style={{fontSize:24,lineHeight:1.5}}&gt;Responsive HTML / CSS / JavaScript&lt;br/&gt;Node 22+ service · no runtime npm dependencies&lt;br/&gt;Immutable inputs + numbered saved revisions&lt;/Text&gt;&lt;/Box&gt;&#10;&lt;Text style={{fontSize:25,fontWeight:700,color:'#CDEA9F'}}&gt;Bounded local adapter operations&lt;/Text&gt;&lt;Text style={{fontSize:23,lineHeight:1.4}}&gt;read, ack, plan, preparation, continuation.&lt;br/&gt;Writes require a fresh request/revision-bound receipt.&lt;/Text&gt;&#10;&lt;Text style={{fontSize:25,fontWeight:700,color:'#CDEA9F'}}&gt;Reviews cannot silently stay current&lt;/Text&gt;&lt;Text style={{fontSize:23,lineHeight:1.4}}&gt;Edit → clear affected review.&lt;br/&gt;New answers → stale continuation + invalidated reviews.&lt;/Text&gt;&#10;&lt;/Box&gt;&#10;&lt;Box style={{width:468,height:496,gap:24,justifyContent:'center'}}&gt;&#10;&lt;Box style={{height:224,background:'#1D3328',padding:16,gap:10}}&gt;&lt;Text style={{fontSize:70,fontWeight:700,color:'#CDEA9F'}}&gt;22&lt;/Text&gt;&lt;Text style={{fontSize:25,fontWeight:700}}&gt;Existing Node checks passed&lt;/Text&gt;&lt;Text style={{fontSize:20,lineHeight:1.4}}&gt;Copied submission · 11 Oct 2026&lt;br/&gt;Reported result; not rerun for this deck.&lt;/Text&gt;&lt;/Box&gt;&#10;&lt;Box style={{height:246,padding:16,gap:8}}&gt;&lt;Text style={{fontSize:64,fontWeight:700,color:'#CDEA9F'}}&gt;63&lt;/Text&gt;&lt;Text style={{fontSize:25,fontWeight:700}}&gt;Earlier browser UI checks&lt;/Text&gt;&lt;Text style={{fontSize:20,lineHeight:1.4}}&gt;WorkBuddy reports · 10 Oct 2026&lt;br/&gt;Historical, not freshly rerun.&lt;br/&gt;Includes isolated in-memory UI mocks.&lt;/Text&gt;&lt;/Box&gt;&#10;&lt;/Box&gt;&lt;/Box&gt;&#10;&lt;Box style={{height:40,flexDirection:'row',justifyContent:'space-between',alignItems:'center'}}&gt;&lt;Text style={{fontSize:15}}&gt;Test provenance is explicit · No usability-study or production-readiness claim&lt;/Text&gt;&lt;Text style={{fontSize:15}}&gt;05 / 06&lt;/Text&gt;&lt;/Box&gt;&#10;&lt;/Slide&gt;"/>
+        <p:cNvPr id="58" name=""/>
         <p:cNvGrpSpPr/>
         <p:nvPr/>
       </p:nvGrpSpPr>
@@ -3068,7 +2872,7 @@
       </p:grpSpPr>
       <p:sp>
         <p:nvSpPr>
-          <p:cNvPr id="60" name=""/>
+          <p:cNvPr id="59" name=""/>
           <p:cNvSpPr/>
           <p:nvPr/>
         </p:nvSpPr>
@@ -3087,12 +2891,15 @@
         </p:spPr>
         <p:txBody>
           <a:bodyPr/>
-          <a:p/>
-        </p:txBody>
-      </p:sp>
-      <p:sp>
-        <p:nvSpPr>
-          <p:cNvPr id="61" name="" descr="{&quot;isTemplate&quot;:true,&quot;type&quot;:&quot;text&quot;}"/>
+          <a:p>
+            <a:pPr/>
+            <a:endParaRPr/>
+          </a:p>
+        </p:txBody>
+      </p:sp>
+      <p:sp>
+        <p:nvSpPr>
+          <p:cNvPr id="60" name="" descr="{&quot;isTemplate&quot;:true,&quot;type&quot;:&quot;text&quot;}"/>
           <p:cNvSpPr txBox="1"/>
           <p:nvPr/>
         </p:nvSpPr>
@@ -3112,22 +2919,28 @@
               </a:lnSpc>
             </a:pPr>
             <a:r>
-              <a:rPr lang="en-US" sz="1350">
+              <a:rPr lang="zh-CN" sz="1350">
                 <a:solidFill>
                   <a:srgbClr val="CDEA9F"/>
                 </a:solidFill>
                 <a:latin typeface="Arial"/>
                 <a:ea typeface="Arial"/>
               </a:rPr>
-              <a:t>IMPLEMENTATION AND EVIDENCE</a:t>
-            </a:r>
-            <a:endParaRPr/>
-          </a:p>
-        </p:txBody>
-      </p:sp>
-      <p:sp>
-        <p:nvSpPr>
-          <p:cNvPr id="62" name="" descr="{&quot;isTemplate&quot;:true,&quot;type&quot;:&quot;text&quot;}"/>
+              <a:t>IMPLEMENTATION, KEY HANDLING AND EVIDENCE</a:t>
+            </a:r>
+            <a:endParaRPr lang="zh-CN" sz="1350">
+              <a:solidFill>
+                <a:srgbClr val="CDEA9F"/>
+              </a:solidFill>
+              <a:latin typeface="Arial"/>
+              <a:ea typeface="Arial"/>
+            </a:endParaRPr>
+          </a:p>
+        </p:txBody>
+      </p:sp>
+      <p:sp>
+        <p:nvSpPr>
+          <p:cNvPr id="61" name="" descr="{&quot;isTemplate&quot;:true,&quot;type&quot;:&quot;text&quot;}"/>
           <p:cNvSpPr txBox="1"/>
           <p:nvPr/>
         </p:nvSpPr>
@@ -3147,22 +2960,28 @@
               </a:lnSpc>
             </a:pPr>
             <a:r>
-              <a:rPr lang="en-US" sz="2850" b="1">
+              <a:rPr lang="zh-CN" sz="2700" b="1">
                 <a:solidFill>
                   <a:srgbClr val="F1F5E9"/>
                 </a:solidFill>
                 <a:latin typeface="Arial"/>
                 <a:ea typeface="Arial"/>
               </a:rPr>
-              <a:t>Small local stack. Persistent, reviewable outputs.</a:t>
-            </a:r>
-            <a:endParaRPr/>
-          </a:p>
-        </p:txBody>
-      </p:sp>
-      <p:sp>
-        <p:nvSpPr>
-          <p:cNvPr id="63" name=""/>
+              <a:t>Local records. Traceable drafts. Honest test limits.</a:t>
+            </a:r>
+            <a:endParaRPr lang="zh-CN" sz="2700" b="1">
+              <a:solidFill>
+                <a:srgbClr val="F1F5E9"/>
+              </a:solidFill>
+              <a:latin typeface="Arial"/>
+              <a:ea typeface="Arial"/>
+            </a:endParaRPr>
+          </a:p>
+        </p:txBody>
+      </p:sp>
+      <p:sp>
+        <p:nvSpPr>
+          <p:cNvPr id="62" name=""/>
           <p:cNvSpPr/>
           <p:nvPr/>
         </p:nvSpPr>
@@ -3181,12 +3000,15 @@
         </p:spPr>
         <p:txBody>
           <a:bodyPr/>
-          <a:p/>
-        </p:txBody>
-      </p:sp>
-      <p:sp>
-        <p:nvSpPr>
-          <p:cNvPr id="64" name="" descr="{&quot;isTemplate&quot;:true,&quot;type&quot;:&quot;text&quot;}"/>
+          <a:p>
+            <a:pPr/>
+            <a:endParaRPr/>
+          </a:p>
+        </p:txBody>
+      </p:sp>
+      <p:sp>
+        <p:nvSpPr>
+          <p:cNvPr id="63" name="" descr="{&quot;isTemplate&quot;:true,&quot;type&quot;:&quot;text&quot;}"/>
           <p:cNvSpPr txBox="1"/>
           <p:nvPr/>
         </p:nvSpPr>
@@ -3206,22 +3028,28 @@
               </a:lnSpc>
             </a:pPr>
             <a:r>
-              <a:rPr lang="en-US" sz="2100" b="1">
+              <a:rPr lang="zh-CN" sz="2100" b="1">
                 <a:solidFill>
                   <a:srgbClr val="CDEA9F"/>
                 </a:solidFill>
                 <a:latin typeface="Arial"/>
                 <a:ea typeface="Arial"/>
               </a:rPr>
-              <a:t>Browser → Node → local JSON</a:t>
-            </a:r>
-            <a:endParaRPr/>
-          </a:p>
-        </p:txBody>
-      </p:sp>
-      <p:sp>
-        <p:nvSpPr>
-          <p:cNvPr id="65" name="" descr="{&quot;isTemplate&quot;:true,&quot;type&quot;:&quot;text&quot;}"/>
+              <a:t>Browser → Node → local backend data</a:t>
+            </a:r>
+            <a:endParaRPr lang="zh-CN" sz="2100" b="1">
+              <a:solidFill>
+                <a:srgbClr val="CDEA9F"/>
+              </a:solidFill>
+              <a:latin typeface="Arial"/>
+              <a:ea typeface="Arial"/>
+            </a:endParaRPr>
+          </a:p>
+        </p:txBody>
+      </p:sp>
+      <p:sp>
+        <p:nvSpPr>
+          <p:cNvPr id="64" name="" descr="{&quot;isTemplate&quot;:true,&quot;type&quot;:&quot;text&quot;}"/>
           <p:cNvSpPr txBox="1"/>
           <p:nvPr/>
         </p:nvSpPr>
@@ -3241,58 +3069,30 @@
               </a:lnSpc>
             </a:pPr>
             <a:r>
-              <a:rPr lang="en-US" sz="1800">
+              <a:rPr lang="zh-CN" sz="1700">
                 <a:solidFill>
                   <a:srgbClr val="F1F5E9"/>
                 </a:solidFill>
                 <a:latin typeface="Arial"/>
                 <a:ea typeface="Arial"/>
               </a:rPr>
-              <a:t>Responsive HTML / CSS / JavaScript</a:t>
-            </a:r>
-            <a:endParaRPr/>
-          </a:p>
-          <a:p>
-            <a:pPr>
-              <a:lnSpc>
-                <a:spcPct val="150000"/>
-              </a:lnSpc>
-            </a:pPr>
-            <a:r>
-              <a:rPr lang="en-US" sz="1800">
-                <a:solidFill>
-                  <a:srgbClr val="F1F5E9"/>
-                </a:solidFill>
-                <a:latin typeface="Arial"/>
-                <a:ea typeface="Arial"/>
-              </a:rPr>
-              <a:t>Node 22+ service · no runtime npm dependencies</a:t>
-            </a:r>
-            <a:endParaRPr/>
-          </a:p>
-          <a:p>
-            <a:pPr>
-              <a:lnSpc>
-                <a:spcPct val="150000"/>
-              </a:lnSpc>
-            </a:pPr>
-            <a:r>
-              <a:rPr lang="en-US" sz="1800">
-                <a:solidFill>
-                  <a:srgbClr val="F1F5E9"/>
-                </a:solidFill>
-                <a:latin typeface="Arial"/>
-                <a:ea typeface="Arial"/>
-              </a:rPr>
-              <a:t>Immutable inputs + numbered saved revisions</a:t>
-            </a:r>
-            <a:endParaRPr/>
-          </a:p>
-        </p:txBody>
-      </p:sp>
-      <p:sp>
-        <p:nvSpPr>
-          <p:cNvPr id="66" name="" descr="{&quot;isTemplate&quot;:true,&quot;type&quot;:&quot;text&quot;}"/>
+              <a:t>HTML / CSS / JavaScript + Node 22+
+No runtime npm dependencies
+Original inputs + numbered saved revisions</a:t>
+            </a:r>
+            <a:endParaRPr lang="zh-CN" sz="1700">
+              <a:solidFill>
+                <a:srgbClr val="F1F5E9"/>
+              </a:solidFill>
+              <a:latin typeface="Arial"/>
+              <a:ea typeface="Arial"/>
+            </a:endParaRPr>
+          </a:p>
+        </p:txBody>
+      </p:sp>
+      <p:sp>
+        <p:nvSpPr>
+          <p:cNvPr id="65" name="" descr="{&quot;isTemplate&quot;:true,&quot;type&quot;:&quot;text&quot;}"/>
           <p:cNvSpPr txBox="1"/>
           <p:nvPr/>
         </p:nvSpPr>
@@ -3312,22 +3112,28 @@
               </a:lnSpc>
             </a:pPr>
             <a:r>
-              <a:rPr lang="en-US" sz="1875" b="1">
+              <a:rPr lang="zh-CN" sz="1900" b="1">
                 <a:solidFill>
                   <a:srgbClr val="CDEA9F"/>
                 </a:solidFill>
                 <a:latin typeface="Arial"/>
                 <a:ea typeface="Arial"/>
               </a:rPr>
-              <a:t>Bounded local adapter operations</a:t>
-            </a:r>
-            <a:endParaRPr/>
-          </a:p>
-        </p:txBody>
-      </p:sp>
-      <p:sp>
-        <p:nvSpPr>
-          <p:cNvPr id="67" name="" descr="{&quot;isTemplate&quot;:true,&quot;type&quot;:&quot;text&quot;}"/>
+              <a:t>CodeBuddy key stays out of GitHub</a:t>
+            </a:r>
+            <a:endParaRPr lang="zh-CN" sz="1900" b="1">
+              <a:solidFill>
+                <a:srgbClr val="CDEA9F"/>
+              </a:solidFill>
+              <a:latin typeface="Arial"/>
+              <a:ea typeface="Arial"/>
+            </a:endParaRPr>
+          </a:p>
+        </p:txBody>
+      </p:sp>
+      <p:sp>
+        <p:nvSpPr>
+          <p:cNvPr id="66" name="" descr="{&quot;isTemplate&quot;:true,&quot;type&quot;:&quot;text&quot;}"/>
           <p:cNvSpPr txBox="1"/>
           <p:nvPr/>
         </p:nvSpPr>
@@ -3347,40 +3153,29 @@
               </a:lnSpc>
             </a:pPr>
             <a:r>
-              <a:rPr lang="en-US" sz="1725">
+              <a:rPr lang="zh-CN" sz="1600">
                 <a:solidFill>
                   <a:srgbClr val="F1F5E9"/>
                 </a:solidFill>
                 <a:latin typeface="Arial"/>
                 <a:ea typeface="Arial"/>
               </a:rPr>
-              <a:t>read, ack, plan, preparation, continuation.</a:t>
-            </a:r>
-            <a:endParaRPr/>
-          </a:p>
-          <a:p>
-            <a:pPr>
-              <a:lnSpc>
-                <a:spcPct val="140000"/>
-              </a:lnSpc>
-            </a:pPr>
-            <a:r>
-              <a:rPr lang="en-US" sz="1725">
-                <a:solidFill>
-                  <a:srgbClr val="F1F5E9"/>
-                </a:solidFill>
-                <a:latin typeface="Arial"/>
-                <a:ea typeface="Arial"/>
-              </a:rPr>
-              <a:t>Writes require a fresh request/revision-bound receipt.</a:t>
-            </a:r>
-            <a:endParaRPr/>
-          </a:p>
-        </p:txBody>
-      </p:sp>
-      <p:sp>
-        <p:nvSpPr>
-          <p:cNvPr id="68" name="" descr="{&quot;isTemplate&quot;:true,&quot;type&quot;:&quot;text&quot;}"/>
+              <a:t>Saved only at local data/.codebuddy-key.
+Not returned to the browser; data/ is Git-ignored.</a:t>
+            </a:r>
+            <a:endParaRPr lang="zh-CN" sz="1600">
+              <a:solidFill>
+                <a:srgbClr val="F1F5E9"/>
+              </a:solidFill>
+              <a:latin typeface="Arial"/>
+              <a:ea typeface="Arial"/>
+            </a:endParaRPr>
+          </a:p>
+        </p:txBody>
+      </p:sp>
+      <p:sp>
+        <p:nvSpPr>
+          <p:cNvPr id="67" name="" descr="{&quot;isTemplate&quot;:true,&quot;type&quot;:&quot;text&quot;}"/>
           <p:cNvSpPr txBox="1"/>
           <p:nvPr/>
         </p:nvSpPr>
@@ -3400,22 +3195,28 @@
               </a:lnSpc>
             </a:pPr>
             <a:r>
-              <a:rPr lang="en-US" sz="1875" b="1">
+              <a:rPr lang="zh-CN" sz="1875" b="1">
                 <a:solidFill>
                   <a:srgbClr val="CDEA9F"/>
                 </a:solidFill>
                 <a:latin typeface="Arial"/>
                 <a:ea typeface="Arial"/>
               </a:rPr>
-              <a:t>Reviews cannot silently stay current</a:t>
-            </a:r>
-            <a:endParaRPr/>
-          </a:p>
-        </p:txBody>
-      </p:sp>
-      <p:sp>
-        <p:nvSpPr>
-          <p:cNvPr id="69" name="" descr="{&quot;isTemplate&quot;:true,&quot;type&quot;:&quot;text&quot;}"/>
+              <a:t>Review state follows content changes</a:t>
+            </a:r>
+            <a:endParaRPr lang="zh-CN" sz="1875" b="1">
+              <a:solidFill>
+                <a:srgbClr val="CDEA9F"/>
+              </a:solidFill>
+              <a:latin typeface="Arial"/>
+              <a:ea typeface="Arial"/>
+            </a:endParaRPr>
+          </a:p>
+        </p:txBody>
+      </p:sp>
+      <p:sp>
+        <p:nvSpPr>
+          <p:cNvPr id="68" name="" descr="{&quot;isTemplate&quot;:true,&quot;type&quot;:&quot;text&quot;}"/>
           <p:cNvSpPr txBox="1"/>
           <p:nvPr/>
         </p:nvSpPr>
@@ -3435,40 +3236,29 @@
               </a:lnSpc>
             </a:pPr>
             <a:r>
-              <a:rPr lang="en-US" sz="1725">
+              <a:rPr lang="zh-CN" sz="1600">
                 <a:solidFill>
                   <a:srgbClr val="F1F5E9"/>
                 </a:solidFill>
                 <a:latin typeface="Arial"/>
                 <a:ea typeface="Arial"/>
               </a:rPr>
-              <a:t>Edit → clear affected review.</a:t>
-            </a:r>
-            <a:endParaRPr/>
-          </a:p>
-          <a:p>
-            <a:pPr>
-              <a:lnSpc>
-                <a:spcPct val="140000"/>
-              </a:lnSpc>
-            </a:pPr>
-            <a:r>
-              <a:rPr lang="en-US" sz="1725">
-                <a:solidFill>
-                  <a:srgbClr val="F1F5E9"/>
-                </a:solidFill>
-                <a:latin typeface="Arial"/>
-                <a:ea typeface="Arial"/>
-              </a:rPr>
-              <a:t>New answers → stale continuation + invalidated reviews.</a:t>
-            </a:r>
-            <a:endParaRPr/>
-          </a:p>
-        </p:txBody>
-      </p:sp>
-      <p:sp>
-        <p:nvSpPr>
-          <p:cNvPr id="70" name=""/>
+              <a:t>Edit → clear the affected content review.
+New answers → stale drafts + invalidated reviews.</a:t>
+            </a:r>
+            <a:endParaRPr lang="zh-CN" sz="1600">
+              <a:solidFill>
+                <a:srgbClr val="F1F5E9"/>
+              </a:solidFill>
+              <a:latin typeface="Arial"/>
+              <a:ea typeface="Arial"/>
+            </a:endParaRPr>
+          </a:p>
+        </p:txBody>
+      </p:sp>
+      <p:sp>
+        <p:nvSpPr>
+          <p:cNvPr id="69" name=""/>
           <p:cNvSpPr/>
           <p:nvPr/>
         </p:nvSpPr>
@@ -3487,12 +3277,15 @@
         </p:spPr>
         <p:txBody>
           <a:bodyPr/>
-          <a:p/>
-        </p:txBody>
-      </p:sp>
-      <p:sp>
-        <p:nvSpPr>
-          <p:cNvPr id="71" name="" descr="{&quot;isTemplate&quot;:true,&quot;type&quot;:&quot;text&quot;}"/>
+          <a:p>
+            <a:pPr/>
+            <a:endParaRPr/>
+          </a:p>
+        </p:txBody>
+      </p:sp>
+      <p:sp>
+        <p:nvSpPr>
+          <p:cNvPr id="70" name="" descr="{&quot;isTemplate&quot;:true,&quot;type&quot;:&quot;text&quot;}"/>
           <p:cNvSpPr txBox="1"/>
           <p:nvPr/>
         </p:nvSpPr>
@@ -3512,22 +3305,28 @@
               </a:lnSpc>
             </a:pPr>
             <a:r>
-              <a:rPr lang="en-US" sz="5250" b="1">
+              <a:rPr lang="zh-CN" sz="5250" b="1">
                 <a:solidFill>
                   <a:srgbClr val="CDEA9F"/>
                 </a:solidFill>
                 <a:latin typeface="Arial"/>
                 <a:ea typeface="Arial"/>
               </a:rPr>
-              <a:t>22</a:t>
-            </a:r>
-            <a:endParaRPr/>
-          </a:p>
-        </p:txBody>
-      </p:sp>
-      <p:sp>
-        <p:nvSpPr>
-          <p:cNvPr id="72" name="" descr="{&quot;isTemplate&quot;:true,&quot;type&quot;:&quot;text&quot;}"/>
+              <a:t>25</a:t>
+            </a:r>
+            <a:endParaRPr lang="zh-CN" sz="5250" b="1">
+              <a:solidFill>
+                <a:srgbClr val="CDEA9F"/>
+              </a:solidFill>
+              <a:latin typeface="Arial"/>
+              <a:ea typeface="Arial"/>
+            </a:endParaRPr>
+          </a:p>
+        </p:txBody>
+      </p:sp>
+      <p:sp>
+        <p:nvSpPr>
+          <p:cNvPr id="71" name="" descr="{&quot;isTemplate&quot;:true,&quot;type&quot;:&quot;text&quot;}"/>
           <p:cNvSpPr txBox="1"/>
           <p:nvPr/>
         </p:nvSpPr>
@@ -3547,22 +3346,28 @@
               </a:lnSpc>
             </a:pPr>
             <a:r>
-              <a:rPr lang="en-US" sz="1875" b="1">
+              <a:rPr lang="zh-CN" sz="1875" b="1">
                 <a:solidFill>
                   <a:srgbClr val="F1F5E9"/>
                 </a:solidFill>
                 <a:latin typeface="Arial"/>
                 <a:ea typeface="Arial"/>
               </a:rPr>
-              <a:t>Existing Node checks passed</a:t>
-            </a:r>
-            <a:endParaRPr/>
-          </a:p>
-        </p:txBody>
-      </p:sp>
-      <p:sp>
-        <p:nvSpPr>
-          <p:cNvPr id="73" name="" descr="{&quot;isTemplate&quot;:true,&quot;type&quot;:&quot;text&quot;}"/>
+              <a:t>Node checks passed</a:t>
+            </a:r>
+            <a:endParaRPr lang="zh-CN" sz="1875" b="1">
+              <a:solidFill>
+                <a:srgbClr val="F1F5E9"/>
+              </a:solidFill>
+              <a:latin typeface="Arial"/>
+              <a:ea typeface="Arial"/>
+            </a:endParaRPr>
+          </a:p>
+        </p:txBody>
+      </p:sp>
+      <p:sp>
+        <p:nvSpPr>
+          <p:cNvPr id="72" name="" descr="{&quot;isTemplate&quot;:true,&quot;type&quot;:&quot;text&quot;}"/>
           <p:cNvSpPr txBox="1"/>
           <p:nvPr/>
         </p:nvSpPr>
@@ -3582,40 +3387,29 @@
               </a:lnSpc>
             </a:pPr>
             <a:r>
-              <a:rPr lang="en-US" sz="1500">
+              <a:rPr lang="zh-CN" sz="1500">
                 <a:solidFill>
                   <a:srgbClr val="F1F5E9"/>
                 </a:solidFill>
                 <a:latin typeface="Arial"/>
                 <a:ea typeface="Arial"/>
               </a:rPr>
-              <a:t>Copied submission · 11 Oct 2026</a:t>
-            </a:r>
-            <a:endParaRPr/>
-          </a:p>
-          <a:p>
-            <a:pPr>
-              <a:lnSpc>
-                <a:spcPct val="140000"/>
-              </a:lnSpc>
-            </a:pPr>
-            <a:r>
-              <a:rPr lang="en-US" sz="1500">
-                <a:solidFill>
-                  <a:srgbClr val="F1F5E9"/>
-                </a:solidFill>
-                <a:latin typeface="Arial"/>
-                <a:ea typeface="Arial"/>
-              </a:rPr>
-              <a:t>Reported result; not rerun for this deck.</a:t>
-            </a:r>
-            <a:endParaRPr/>
-          </a:p>
-        </p:txBody>
-      </p:sp>
-      <p:sp>
-        <p:nvSpPr>
-          <p:cNvPr id="74" name="" descr="{&quot;isTemplate&quot;:true,&quot;type&quot;:&quot;text&quot;}"/>
+              <a:t>Verified on 11 October 2026.
+Fake-model fixtures; no paid AI demo.</a:t>
+            </a:r>
+            <a:endParaRPr lang="zh-CN" sz="1500">
+              <a:solidFill>
+                <a:srgbClr val="F1F5E9"/>
+              </a:solidFill>
+              <a:latin typeface="Arial"/>
+              <a:ea typeface="Arial"/>
+            </a:endParaRPr>
+          </a:p>
+        </p:txBody>
+      </p:sp>
+      <p:sp>
+        <p:nvSpPr>
+          <p:cNvPr id="73" name="" descr="{&quot;isTemplate&quot;:true,&quot;type&quot;:&quot;text&quot;}"/>
           <p:cNvSpPr txBox="1"/>
           <p:nvPr/>
         </p:nvSpPr>
@@ -3635,22 +3429,28 @@
               </a:lnSpc>
             </a:pPr>
             <a:r>
-              <a:rPr lang="en-US" sz="4800" b="1">
+              <a:rPr lang="zh-CN" sz="3600" b="1">
                 <a:solidFill>
                   <a:srgbClr val="CDEA9F"/>
                 </a:solidFill>
                 <a:latin typeface="Arial"/>
                 <a:ea typeface="Arial"/>
               </a:rPr>
-              <a:t>63</a:t>
-            </a:r>
-            <a:endParaRPr/>
-          </a:p>
-        </p:txBody>
-      </p:sp>
-      <p:sp>
-        <p:nvSpPr>
-          <p:cNvPr id="75" name="" descr="{&quot;isTemplate&quot;:true,&quot;type&quot;:&quot;text&quot;}"/>
+              <a:t>SAVED</a:t>
+            </a:r>
+            <a:endParaRPr lang="zh-CN" sz="3600" b="1">
+              <a:solidFill>
+                <a:srgbClr val="CDEA9F"/>
+              </a:solidFill>
+              <a:latin typeface="Arial"/>
+              <a:ea typeface="Arial"/>
+            </a:endParaRPr>
+          </a:p>
+        </p:txBody>
+      </p:sp>
+      <p:sp>
+        <p:nvSpPr>
+          <p:cNvPr id="74" name="" descr="{&quot;isTemplate&quot;:true,&quot;type&quot;:&quot;text&quot;}"/>
           <p:cNvSpPr txBox="1"/>
           <p:nvPr/>
         </p:nvSpPr>
@@ -3670,16 +3470,65 @@
               </a:lnSpc>
             </a:pPr>
             <a:r>
-              <a:rPr lang="en-US" sz="1875" b="1">
+              <a:rPr lang="zh-CN" sz="1700" b="1">
                 <a:solidFill>
                   <a:srgbClr val="F1F5E9"/>
                 </a:solidFill>
                 <a:latin typeface="Arial"/>
                 <a:ea typeface="Arial"/>
               </a:rPr>
-              <a:t>Earlier browser UI checks</a:t>
-            </a:r>
-            <a:endParaRPr/>
+              <a:t>Content recovered + validated</a:t>
+            </a:r>
+            <a:endParaRPr lang="zh-CN" sz="1700" b="1">
+              <a:solidFill>
+                <a:srgbClr val="F1F5E9"/>
+              </a:solidFill>
+              <a:latin typeface="Arial"/>
+              <a:ea typeface="Arial"/>
+            </a:endParaRPr>
+          </a:p>
+        </p:txBody>
+      </p:sp>
+      <p:sp>
+        <p:nvSpPr>
+          <p:cNvPr id="75" name="" descr="{&quot;isTemplate&quot;:true,&quot;type&quot;:&quot;text&quot;}"/>
+          <p:cNvSpPr txBox="1"/>
+          <p:nvPr/>
+        </p:nvSpPr>
+        <p:spPr>
+          <a:xfrm flipH="0" flipV="0">
+            <a:off x="7315200" y="5041900"/>
+            <a:ext cx="4152900" cy="1054100"/>
+          </a:xfrm>
+          <a:prstGeom prst="rect"/>
+        </p:spPr>
+        <p:txBody>
+          <a:bodyPr wrap="none" lIns="0" tIns="0" rIns="0" bIns="0"/>
+          <a:p>
+            <a:pPr>
+              <a:lnSpc>
+                <a:spcPct val="140000"/>
+              </a:lnSpc>
+            </a:pPr>
+            <a:r>
+              <a:rPr lang="zh-CN" sz="1600">
+                <a:solidFill>
+                  <a:srgbClr val="F1F5E9"/>
+                </a:solidFill>
+                <a:latin typeface="Arial"/>
+                <a:ea typeface="Arial"/>
+              </a:rPr>
+              <a:t>Saved CodeBuddy card content verified.
+Final one-click path has NOT had
+a fresh live end-to-end test.</a:t>
+            </a:r>
+            <a:endParaRPr lang="zh-CN" sz="1600">
+              <a:solidFill>
+                <a:srgbClr val="F1F5E9"/>
+              </a:solidFill>
+              <a:latin typeface="Arial"/>
+              <a:ea typeface="Arial"/>
+            </a:endParaRPr>
           </a:p>
         </p:txBody>
       </p:sp>
@@ -3690,108 +3539,43 @@
           <p:nvPr/>
         </p:nvSpPr>
         <p:spPr>
-          <a:xfrm rot="0" flipH="0" flipV="0">
-            <a:off x="7315200" y="5048250"/>
-            <a:ext cx="4152900" cy="962025"/>
-          </a:xfrm>
-          <a:prstGeom prst="rect"/>
-        </p:spPr>
-        <p:txBody>
-          <a:bodyPr wrap="none" lIns="0" tIns="0" rIns="0" bIns="0"/>
-          <a:p>
-            <a:pPr>
-              <a:lnSpc>
-                <a:spcPct val="140000"/>
-              </a:lnSpc>
-            </a:pPr>
-            <a:r>
-              <a:rPr lang="en-US" sz="1500">
+          <a:xfrm flipH="0" flipV="0">
+            <a:off x="571500" y="6391275"/>
+            <a:ext cx="9906000" cy="171450"/>
+          </a:xfrm>
+          <a:prstGeom prst="rect"/>
+        </p:spPr>
+        <p:txBody>
+          <a:bodyPr wrap="none" lIns="0" tIns="0" rIns="0" bIns="0"/>
+          <a:p>
+            <a:pPr>
+              <a:lnSpc>
+                <a:spcPct val="100000"/>
+              </a:lnSpc>
+            </a:pPr>
+            <a:r>
+              <a:rPr lang="zh-CN" sz="1100">
                 <a:solidFill>
                   <a:srgbClr val="F1F5E9"/>
                 </a:solidFill>
                 <a:latin typeface="Arial"/>
                 <a:ea typeface="Arial"/>
               </a:rPr>
-              <a:t>WorkBuddy reports · 10 Oct 2026</a:t>
-            </a:r>
-            <a:endParaRPr/>
-          </a:p>
-          <a:p>
-            <a:pPr>
-              <a:lnSpc>
-                <a:spcPct val="140000"/>
-              </a:lnSpc>
-            </a:pPr>
-            <a:r>
-              <a:rPr lang="en-US" sz="1500">
-                <a:solidFill>
-                  <a:srgbClr val="F1F5E9"/>
-                </a:solidFill>
-                <a:latin typeface="Arial"/>
-                <a:ea typeface="Arial"/>
-              </a:rPr>
-              <a:t>Historical, not freshly rerun.</a:t>
-            </a:r>
-            <a:endParaRPr/>
-          </a:p>
-          <a:p>
-            <a:pPr>
-              <a:lnSpc>
-                <a:spcPct val="140000"/>
-              </a:lnSpc>
-            </a:pPr>
-            <a:r>
-              <a:rPr lang="en-US" sz="1500">
-                <a:solidFill>
-                  <a:srgbClr val="F1F5E9"/>
-                </a:solidFill>
-                <a:latin typeface="Arial"/>
-                <a:ea typeface="Arial"/>
-              </a:rPr>
-              <a:t>Includes isolated in-memory UI mocks.</a:t>
-            </a:r>
-            <a:endParaRPr/>
+              <a:t>Plain-text local key: keep the data folder private · Not production authentication</a:t>
+            </a:r>
+            <a:endParaRPr lang="zh-CN" sz="1100">
+              <a:solidFill>
+                <a:srgbClr val="F1F5E9"/>
+              </a:solidFill>
+              <a:latin typeface="Arial"/>
+              <a:ea typeface="Arial"/>
+            </a:endParaRPr>
           </a:p>
         </p:txBody>
       </p:sp>
       <p:sp>
         <p:nvSpPr>
           <p:cNvPr id="77" name="" descr="{&quot;isTemplate&quot;:true,&quot;type&quot;:&quot;text&quot;}"/>
-          <p:cNvSpPr txBox="1"/>
-          <p:nvPr/>
-        </p:nvSpPr>
-        <p:spPr>
-          <a:xfrm rot="0" flipH="0" flipV="0">
-            <a:off x="571500" y="6391275"/>
-            <a:ext cx="4838700" cy="171450"/>
-          </a:xfrm>
-          <a:prstGeom prst="rect"/>
-        </p:spPr>
-        <p:txBody>
-          <a:bodyPr wrap="none" lIns="0" tIns="0" rIns="0" bIns="0"/>
-          <a:p>
-            <a:pPr>
-              <a:lnSpc>
-                <a:spcPct val="100000"/>
-              </a:lnSpc>
-            </a:pPr>
-            <a:r>
-              <a:rPr lang="en-US" sz="1125">
-                <a:solidFill>
-                  <a:srgbClr val="F1F5E9"/>
-                </a:solidFill>
-                <a:latin typeface="Arial"/>
-                <a:ea typeface="Arial"/>
-              </a:rPr>
-              <a:t>Test provenance is explicit · No usability-study or production-readiness claim</a:t>
-            </a:r>
-            <a:endParaRPr/>
-          </a:p>
-        </p:txBody>
-      </p:sp>
-      <p:sp>
-        <p:nvSpPr>
-          <p:cNvPr id="78" name="" descr="{&quot;isTemplate&quot;:true,&quot;type&quot;:&quot;text&quot;}"/>
           <p:cNvSpPr txBox="1"/>
           <p:nvPr/>
         </p:nvSpPr>
@@ -3834,7 +3618,7 @@
   <p:cSld>
     <p:spTree>
       <p:nvGrpSpPr>
-        <p:cNvPr id="79" name="" descr="&lt;Slide notes=&quot;SponsorBridge currently works through preparation and editable package drafts. Business matching, personalised pitches and complete campaign export are next steps, not features I am claiming today. The prototype uses fictional data and manual start and resume, and runs locally for a single user. I have not contacted businesses, secured sponsorship, processed payments or obtained university approval. The public GitHub link is source code, not a hosted web application.&quot; style={{width:1280,height:720,padding:'20px 60px',background:'#0E1915',fontFamily:'Arial',color:'#F1F5E9'}}&gt;&#10;&lt;Box style={{height:100,justifyContent:'center',gap:8}}&gt;&lt;Text style={{fontSize:18,color:'#CDEA9F'}}&gt;CURRENT SCOPE AND NEXT STEPS&lt;/Text&gt;&lt;Text style={{fontSize:38,fontWeight:700}}&gt;Working preparation today. Campaign workflow next.&lt;/Text&gt;&lt;/Box&gt;&#10;&lt;Box style={{height:540,gap:22,justifyContent:'center'}}&gt;&#10;&lt;Box style={{height:354,flexDirection:'row',gap:40}}&gt;&#10;&lt;Box style={{width:336,height:354,gap:12}}&gt;&lt;Image src=&quot;SponsorBridge-ui-overview.png&quot; style={{width:240,height:316,objectFit:'contain'}}/&gt;&lt;Text style={{fontSize:16,color:'#CDEA9F'}}&gt;Actual app · historical screenshot&lt;/Text&gt;&lt;/Box&gt;&#10;&lt;Box style={{width:360,height:354,gap:12,justifyContent:'center'}}&gt;&lt;Text style={{fontSize:29,fontWeight:700,color:'#CDEA9F'}}&gt;Implemented&lt;/Text&gt;&lt;Text style={{fontSize:25,lineHeight:1.5}}&gt;Saved proposals and goals&lt;br/&gt;Plan + clarification&lt;br/&gt;Answers + package drafts&lt;br/&gt;Student editing / review&lt;/Text&gt;&lt;Text style={{fontSize:22,lineHeight:1.4}}&gt;Manual start / resume&lt;br/&gt;Local single-user operation&lt;br/&gt;Conspicuously fictional data&lt;/Text&gt;&lt;/Box&gt;&#10;&lt;Box style={{width:384,height:354,background:'#1D3328',padding:24,gap:20,justifyContent:'center'}}&gt;&lt;Text style={{fontSize:29,fontWeight:700,color:'#CDEA9F'}}&gt;Planned, not built&lt;/Text&gt;&lt;Text style={{fontSize:26,lineHeight:1.55}}&gt;Business matching&lt;br/&gt;↓&lt;br/&gt;Personalised pitches&lt;br/&gt;↓&lt;br/&gt;Complete campaign export&lt;/Text&gt;&lt;/Box&gt;&#10;&lt;/Box&gt;&#10;&lt;Box style={{height:132,background:'#1D3328',padding:22,gap:12}}&gt;&lt;Text style={{fontSize:26,fontWeight:700,color:'#CDEA9F'}}&gt;Public source repository · Not a hosted web app&lt;/Text&gt;&lt;Text href=&quot;https://github.com/ryuhanbin/sponsorbridge-hackathon&quot; style={{fontSize:25}}&gt;https://github.com/ryuhanbin/sponsorbridge-hackathon&lt;/Text&gt;&lt;Text style={{fontSize:20}}&gt;No automatic dispatch, business outreach, payments, or university approval.&lt;/Text&gt;&lt;/Box&gt;&#10;&lt;/Box&gt;&#10;&lt;Box style={{height:40,flexDirection:'row',justifyContent:'space-between',alignItems:'center'}}&gt;&lt;Text style={{fontSize:15}}&gt;Afiq · SponsorBridge · 11 October 2026&lt;/Text&gt;&lt;Text style={{fontSize:15}}&gt;06 / 06&lt;/Text&gt;&lt;/Box&gt;&#10;&lt;/Slide&gt;"/>
+        <p:cNvPr id="78" name=""/>
         <p:cNvGrpSpPr/>
         <p:nvPr/>
       </p:nvGrpSpPr>
@@ -3848,7 +3632,7 @@
       </p:grpSpPr>
       <p:sp>
         <p:nvSpPr>
-          <p:cNvPr id="80" name=""/>
+          <p:cNvPr id="79" name=""/>
           <p:cNvSpPr/>
           <p:nvPr/>
         </p:nvSpPr>
@@ -3867,12 +3651,15 @@
         </p:spPr>
         <p:txBody>
           <a:bodyPr/>
-          <a:p/>
-        </p:txBody>
-      </p:sp>
-      <p:sp>
-        <p:nvSpPr>
-          <p:cNvPr id="81" name="" descr="{&quot;isTemplate&quot;:true,&quot;type&quot;:&quot;text&quot;}"/>
+          <a:p>
+            <a:pPr/>
+            <a:endParaRPr/>
+          </a:p>
+        </p:txBody>
+      </p:sp>
+      <p:sp>
+        <p:nvSpPr>
+          <p:cNvPr id="80" name="" descr="{&quot;isTemplate&quot;:true,&quot;type&quot;:&quot;text&quot;}"/>
           <p:cNvSpPr txBox="1"/>
           <p:nvPr/>
         </p:nvSpPr>
@@ -3892,22 +3679,28 @@
               </a:lnSpc>
             </a:pPr>
             <a:r>
-              <a:rPr lang="en-US" sz="1350">
+              <a:rPr lang="zh-CN" sz="1350">
                 <a:solidFill>
                   <a:srgbClr val="CDEA9F"/>
                 </a:solidFill>
                 <a:latin typeface="Arial"/>
                 <a:ea typeface="Arial"/>
               </a:rPr>
-              <a:t>CURRENT SCOPE AND NEXT STEPS</a:t>
-            </a:r>
-            <a:endParaRPr/>
-          </a:p>
-        </p:txBody>
-      </p:sp>
-      <p:sp>
-        <p:nvSpPr>
-          <p:cNvPr id="82" name="" descr="{&quot;isTemplate&quot;:true,&quot;type&quot;:&quot;text&quot;}"/>
+              <a:t>SUBMISSION AND NEXT STEPS</a:t>
+            </a:r>
+            <a:endParaRPr lang="zh-CN" sz="1350">
+              <a:solidFill>
+                <a:srgbClr val="CDEA9F"/>
+              </a:solidFill>
+              <a:latin typeface="Arial"/>
+              <a:ea typeface="Arial"/>
+            </a:endParaRPr>
+          </a:p>
+        </p:txBody>
+      </p:sp>
+      <p:sp>
+        <p:nvSpPr>
+          <p:cNvPr id="81" name="" descr="{&quot;isTemplate&quot;:true,&quot;type&quot;:&quot;text&quot;}"/>
           <p:cNvSpPr txBox="1"/>
           <p:nvPr/>
         </p:nvSpPr>
@@ -3927,55 +3720,35 @@
               </a:lnSpc>
             </a:pPr>
             <a:r>
-              <a:rPr lang="en-US" sz="2850" b="1">
+              <a:rPr lang="zh-CN" sz="2850" b="1">
                 <a:solidFill>
                   <a:srgbClr val="F1F5E9"/>
                 </a:solidFill>
                 <a:latin typeface="Arial"/>
                 <a:ea typeface="Arial"/>
               </a:rPr>
-              <a:t>Working preparation today. Campaign workflow next.</a:t>
-            </a:r>
-            <a:endParaRPr/>
-          </a:p>
-        </p:txBody>
-      </p:sp>
-      <p:pic>
-        <p:nvPicPr>
-          <p:cNvPr id="83" name=""/>
-          <p:cNvPicPr>
-            <a:picLocks noChangeAspect="1"/>
-          </p:cNvPicPr>
-          <p:nvPr/>
-        </p:nvPicPr>
-        <p:blipFill>
-          <a:blip r:embed="rId2"/>
-          <a:srcRect l="0" t="26" r="0" b="26"/>
-          <a:stretch>
-            <a:fillRect/>
-          </a:stretch>
-        </p:blipFill>
-        <p:spPr>
-          <a:xfrm rot="0" flipH="0" flipV="0">
-            <a:off x="571500" y="1295400"/>
-            <a:ext cx="2286000" cy="3009900"/>
-          </a:xfrm>
-          <a:prstGeom prst="rect">
-            <a:avLst/>
-          </a:prstGeom>
-          <a:ln/>
-        </p:spPr>
-      </p:pic>
-      <p:sp>
-        <p:nvSpPr>
-          <p:cNvPr id="84" name="" descr="{&quot;isTemplate&quot;:true,&quot;type&quot;:&quot;text&quot;}"/>
-          <p:cNvSpPr txBox="1"/>
-          <p:nvPr/>
-        </p:nvSpPr>
-        <p:spPr>
-          <a:xfrm rot="0" flipH="0" flipV="0">
+              <a:t>Reviewable requests now. Full campaigns next.</a:t>
+            </a:r>
+            <a:endParaRPr lang="zh-CN" sz="2850" b="1">
+              <a:solidFill>
+                <a:srgbClr val="F1F5E9"/>
+              </a:solidFill>
+              <a:latin typeface="Arial"/>
+              <a:ea typeface="Arial"/>
+            </a:endParaRPr>
+          </a:p>
+        </p:txBody>
+      </p:sp>
+      <p:sp>
+        <p:nvSpPr>
+          <p:cNvPr id="82" name="" descr="{&quot;isTemplate&quot;:true,&quot;type&quot;:&quot;text&quot;}"/>
+          <p:cNvSpPr txBox="1"/>
+          <p:nvPr/>
+        </p:nvSpPr>
+        <p:spPr>
+          <a:xfrm flipH="0" flipV="0">
             <a:off x="571500" y="4419600"/>
-            <a:ext cx="3200400" cy="190500"/>
+            <a:ext cx="3429000" cy="190500"/>
           </a:xfrm>
           <a:prstGeom prst="rect"/>
         </p:spPr>
@@ -3988,22 +3761,28 @@
               </a:lnSpc>
             </a:pPr>
             <a:r>
-              <a:rPr lang="en-US" sz="1200">
+              <a:rPr lang="zh-CN" sz="1200">
                 <a:solidFill>
                   <a:srgbClr val="CDEA9F"/>
                 </a:solidFill>
                 <a:latin typeface="Arial"/>
                 <a:ea typeface="Arial"/>
               </a:rPr>
-              <a:t>Actual app · historical screenshot</a:t>
-            </a:r>
-            <a:endParaRPr/>
-          </a:p>
-        </p:txBody>
-      </p:sp>
-      <p:sp>
-        <p:nvSpPr>
-          <p:cNvPr id="85" name="" descr="{&quot;isTemplate&quot;:true,&quot;type&quot;:&quot;text&quot;}"/>
+              <a:t>Current interface · saved fictional cards</a:t>
+            </a:r>
+            <a:endParaRPr lang="zh-CN" sz="1200">
+              <a:solidFill>
+                <a:srgbClr val="CDEA9F"/>
+              </a:solidFill>
+              <a:latin typeface="Arial"/>
+              <a:ea typeface="Arial"/>
+            </a:endParaRPr>
+          </a:p>
+        </p:txBody>
+      </p:sp>
+      <p:sp>
+        <p:nvSpPr>
+          <p:cNvPr id="83" name="" descr="{&quot;isTemplate&quot;:true,&quot;type&quot;:&quot;text&quot;}"/>
           <p:cNvSpPr txBox="1"/>
           <p:nvPr/>
         </p:nvSpPr>
@@ -4038,7 +3817,7 @@
       </p:sp>
       <p:sp>
         <p:nvSpPr>
-          <p:cNvPr id="86" name="" descr="{&quot;isTemplate&quot;:true,&quot;type&quot;:&quot;text&quot;}"/>
+          <p:cNvPr id="84" name="" descr="{&quot;isTemplate&quot;:true,&quot;type&quot;:&quot;text&quot;}"/>
           <p:cNvSpPr txBox="1"/>
           <p:nvPr/>
         </p:nvSpPr>
@@ -4058,76 +3837,31 @@
               </a:lnSpc>
             </a:pPr>
             <a:r>
-              <a:rPr lang="en-US" sz="1875">
+              <a:rPr lang="zh-CN" sz="1700">
                 <a:solidFill>
                   <a:srgbClr val="F1F5E9"/>
                 </a:solidFill>
                 <a:latin typeface="Arial"/>
                 <a:ea typeface="Arial"/>
               </a:rPr>
-              <a:t>Saved proposals and goals</a:t>
-            </a:r>
-            <a:endParaRPr/>
-          </a:p>
-          <a:p>
-            <a:pPr>
-              <a:lnSpc>
-                <a:spcPct val="150000"/>
-              </a:lnSpc>
-            </a:pPr>
-            <a:r>
-              <a:rPr lang="en-US" sz="1875">
-                <a:solidFill>
-                  <a:srgbClr val="F1F5E9"/>
-                </a:solidFill>
-                <a:latin typeface="Arial"/>
-                <a:ea typeface="Arial"/>
-              </a:rPr>
-              <a:t>Plan + clarification</a:t>
-            </a:r>
-            <a:endParaRPr/>
-          </a:p>
-          <a:p>
-            <a:pPr>
-              <a:lnSpc>
-                <a:spcPct val="150000"/>
-              </a:lnSpc>
-            </a:pPr>
-            <a:r>
-              <a:rPr lang="en-US" sz="1875">
-                <a:solidFill>
-                  <a:srgbClr val="F1F5E9"/>
-                </a:solidFill>
-                <a:latin typeface="Arial"/>
-                <a:ea typeface="Arial"/>
-              </a:rPr>
-              <a:t>Answers + package drafts</a:t>
-            </a:r>
-            <a:endParaRPr/>
-          </a:p>
-          <a:p>
-            <a:pPr>
-              <a:lnSpc>
-                <a:spcPct val="150000"/>
-              </a:lnSpc>
-            </a:pPr>
-            <a:r>
-              <a:rPr lang="en-US" sz="1875">
-                <a:solidFill>
-                  <a:srgbClr val="F1F5E9"/>
-                </a:solidFill>
-                <a:latin typeface="Arial"/>
-                <a:ea typeface="Arial"/>
-              </a:rPr>
-              <a:t>Student editing / review</a:t>
-            </a:r>
-            <a:endParaRPr/>
-          </a:p>
-        </p:txBody>
-      </p:sp>
-      <p:sp>
-        <p:nvSpPr>
-          <p:cNvPr id="87" name="" descr="{&quot;isTemplate&quot;:true,&quot;type&quot;:&quot;text&quot;}"/>
+              <a:t>Saved proposals + goals
+Clarification questions + answers
+Source-linked card drafts
+Student editing + content review</a:t>
+            </a:r>
+            <a:endParaRPr lang="zh-CN" sz="1700">
+              <a:solidFill>
+                <a:srgbClr val="F1F5E9"/>
+              </a:solidFill>
+              <a:latin typeface="Arial"/>
+              <a:ea typeface="Arial"/>
+            </a:endParaRPr>
+          </a:p>
+        </p:txBody>
+      </p:sp>
+      <p:sp>
+        <p:nvSpPr>
+          <p:cNvPr id="85" name="" descr="{&quot;isTemplate&quot;:true,&quot;type&quot;:&quot;text&quot;}"/>
           <p:cNvSpPr txBox="1"/>
           <p:nvPr/>
         </p:nvSpPr>
@@ -4147,58 +3881,30 @@
               </a:lnSpc>
             </a:pPr>
             <a:r>
-              <a:rPr lang="en-US" sz="1650">
+              <a:rPr lang="zh-CN" sz="1600">
                 <a:solidFill>
                   <a:srgbClr val="F1F5E9"/>
                 </a:solidFill>
                 <a:latin typeface="Arial"/>
                 <a:ea typeface="Arial"/>
               </a:rPr>
-              <a:t>Manual start / resume</a:t>
-            </a:r>
-            <a:endParaRPr/>
-          </a:p>
-          <a:p>
-            <a:pPr>
-              <a:lnSpc>
-                <a:spcPct val="140000"/>
-              </a:lnSpc>
-            </a:pPr>
-            <a:r>
-              <a:rPr lang="en-US" sz="1650">
-                <a:solidFill>
-                  <a:srgbClr val="F1F5E9"/>
-                </a:solidFill>
-                <a:latin typeface="Arial"/>
-                <a:ea typeface="Arial"/>
-              </a:rPr>
-              <a:t>Local single-user operation</a:t>
-            </a:r>
-            <a:endParaRPr/>
-          </a:p>
-          <a:p>
-            <a:pPr>
-              <a:lnSpc>
-                <a:spcPct val="140000"/>
-              </a:lnSpc>
-            </a:pPr>
-            <a:r>
-              <a:rPr lang="en-US" sz="1650">
-                <a:solidFill>
-                  <a:srgbClr val="F1F5E9"/>
-                </a:solidFill>
-                <a:latin typeface="Arial"/>
-                <a:ea typeface="Arial"/>
-              </a:rPr>
-              <a:t>Conspicuously fictional data</a:t>
-            </a:r>
-            <a:endParaRPr/>
-          </a:p>
-        </p:txBody>
-      </p:sp>
-      <p:sp>
-        <p:nvSpPr>
-          <p:cNvPr id="88" name=""/>
+              <a:t>Optional CodeBuddy CLI route
+Manual WorkBuddy handoff
+Local single-user prototype</a:t>
+            </a:r>
+            <a:endParaRPr lang="zh-CN" sz="1600">
+              <a:solidFill>
+                <a:srgbClr val="F1F5E9"/>
+              </a:solidFill>
+              <a:latin typeface="Arial"/>
+              <a:ea typeface="Arial"/>
+            </a:endParaRPr>
+          </a:p>
+        </p:txBody>
+      </p:sp>
+      <p:sp>
+        <p:nvSpPr>
+          <p:cNvPr id="86" name=""/>
           <p:cNvSpPr/>
           <p:nvPr/>
         </p:nvSpPr>
@@ -4217,12 +3923,15 @@
         </p:spPr>
         <p:txBody>
           <a:bodyPr/>
-          <a:p/>
-        </p:txBody>
-      </p:sp>
-      <p:sp>
-        <p:nvSpPr>
-          <p:cNvPr id="89" name="" descr="{&quot;isTemplate&quot;:true,&quot;type&quot;:&quot;text&quot;}"/>
+          <a:p>
+            <a:pPr/>
+            <a:endParaRPr/>
+          </a:p>
+        </p:txBody>
+      </p:sp>
+      <p:sp>
+        <p:nvSpPr>
+          <p:cNvPr id="87" name="" descr="{&quot;isTemplate&quot;:true,&quot;type&quot;:&quot;text&quot;}"/>
           <p:cNvSpPr txBox="1"/>
           <p:nvPr/>
         </p:nvSpPr>
@@ -4242,7 +3951,7 @@
               </a:lnSpc>
             </a:pPr>
             <a:r>
-              <a:rPr lang="en-US" sz="2175" b="1">
+              <a:rPr lang="zh-CN" sz="2175" b="1">
                 <a:solidFill>
                   <a:srgbClr val="CDEA9F"/>
                 </a:solidFill>
@@ -4251,13 +3960,19 @@
               </a:rPr>
               <a:t>Planned, not built</a:t>
             </a:r>
-            <a:endParaRPr/>
-          </a:p>
-        </p:txBody>
-      </p:sp>
-      <p:sp>
-        <p:nvSpPr>
-          <p:cNvPr id="90" name="" descr="{&quot;isTemplate&quot;:true,&quot;type&quot;:&quot;text&quot;}"/>
+            <a:endParaRPr lang="zh-CN" sz="2175" b="1">
+              <a:solidFill>
+                <a:srgbClr val="CDEA9F"/>
+              </a:solidFill>
+              <a:latin typeface="Arial"/>
+              <a:ea typeface="Arial"/>
+            </a:endParaRPr>
+          </a:p>
+        </p:txBody>
+      </p:sp>
+      <p:sp>
+        <p:nvSpPr>
+          <p:cNvPr id="88" name="" descr="{&quot;isTemplate&quot;:true,&quot;type&quot;:&quot;text&quot;}"/>
           <p:cNvSpPr txBox="1"/>
           <p:nvPr/>
         </p:nvSpPr>
@@ -4277,94 +3992,30 @@
               </a:lnSpc>
             </a:pPr>
             <a:r>
-              <a:rPr lang="en-US" sz="1950">
+              <a:rPr lang="zh-CN" sz="1800">
                 <a:solidFill>
                   <a:srgbClr val="F1F5E9"/>
                 </a:solidFill>
                 <a:latin typeface="Arial"/>
                 <a:ea typeface="Arial"/>
               </a:rPr>
-              <a:t>Business matching</a:t>
-            </a:r>
-            <a:endParaRPr/>
-          </a:p>
-          <a:p>
-            <a:pPr>
-              <a:lnSpc>
-                <a:spcPct val="155000"/>
-              </a:lnSpc>
-            </a:pPr>
-            <a:r>
-              <a:rPr sz="1950">
-                <a:solidFill>
-                  <a:srgbClr val="F1F5E9"/>
-                </a:solidFill>
-                <a:latin typeface="Arial"/>
-                <a:ea typeface="Arial"/>
-              </a:rPr>
-              <a:t>↓</a:t>
-            </a:r>
-            <a:endParaRPr/>
-          </a:p>
-          <a:p>
-            <a:pPr>
-              <a:lnSpc>
-                <a:spcPct val="155000"/>
-              </a:lnSpc>
-            </a:pPr>
-            <a:r>
-              <a:rPr lang="en-US" sz="1950">
-                <a:solidFill>
-                  <a:srgbClr val="F1F5E9"/>
-                </a:solidFill>
-                <a:latin typeface="Arial"/>
-                <a:ea typeface="Arial"/>
-              </a:rPr>
-              <a:t>Personalised pitches</a:t>
-            </a:r>
-            <a:endParaRPr/>
-          </a:p>
-          <a:p>
-            <a:pPr>
-              <a:lnSpc>
-                <a:spcPct val="155000"/>
-              </a:lnSpc>
-            </a:pPr>
-            <a:r>
-              <a:rPr sz="1950">
-                <a:solidFill>
-                  <a:srgbClr val="F1F5E9"/>
-                </a:solidFill>
-                <a:latin typeface="Arial"/>
-                <a:ea typeface="Arial"/>
-              </a:rPr>
-              <a:t>↓</a:t>
-            </a:r>
-            <a:endParaRPr/>
-          </a:p>
-          <a:p>
-            <a:pPr>
-              <a:lnSpc>
-                <a:spcPct val="155000"/>
-              </a:lnSpc>
-            </a:pPr>
-            <a:r>
-              <a:rPr lang="en-US" sz="1950">
-                <a:solidFill>
-                  <a:srgbClr val="F1F5E9"/>
-                </a:solidFill>
-                <a:latin typeface="Arial"/>
-                <a:ea typeface="Arial"/>
-              </a:rPr>
-              <a:t>Complete campaign export</a:t>
-            </a:r>
-            <a:endParaRPr/>
-          </a:p>
-        </p:txBody>
-      </p:sp>
-      <p:sp>
-        <p:nvSpPr>
-          <p:cNvPr id="91" name=""/>
+              <a:t>Business matching
+Personalised pitches / outreach
+Complete campaign export</a:t>
+            </a:r>
+            <a:endParaRPr lang="zh-CN" sz="1800">
+              <a:solidFill>
+                <a:srgbClr val="F1F5E9"/>
+              </a:solidFill>
+              <a:latin typeface="Arial"/>
+              <a:ea typeface="Arial"/>
+            </a:endParaRPr>
+          </a:p>
+        </p:txBody>
+      </p:sp>
+      <p:sp>
+        <p:nvSpPr>
+          <p:cNvPr id="89" name=""/>
           <p:cNvSpPr/>
           <p:nvPr/>
         </p:nvSpPr>
@@ -4383,12 +4034,15 @@
         </p:spPr>
         <p:txBody>
           <a:bodyPr/>
-          <a:p/>
-        </p:txBody>
-      </p:sp>
-      <p:sp>
-        <p:nvSpPr>
-          <p:cNvPr id="92" name="" descr="{&quot;isTemplate&quot;:true,&quot;type&quot;:&quot;text&quot;}"/>
+          <a:p>
+            <a:pPr/>
+            <a:endParaRPr/>
+          </a:p>
+        </p:txBody>
+      </p:sp>
+      <p:sp>
+        <p:nvSpPr>
+          <p:cNvPr id="90" name="" descr="{&quot;isTemplate&quot;:true,&quot;type&quot;:&quot;text&quot;}"/>
           <p:cNvSpPr txBox="1"/>
           <p:nvPr/>
         </p:nvSpPr>
@@ -4408,23 +4062,29 @@
               </a:lnSpc>
             </a:pPr>
             <a:r>
-              <a:rPr lang="en-US" sz="1950" b="1">
+              <a:rPr lang="zh-CN" sz="1800" b="1">
                 <a:solidFill>
                   <a:srgbClr val="CDEA9F"/>
                 </a:solidFill>
                 <a:latin typeface="Arial"/>
                 <a:ea typeface="Arial"/>
               </a:rPr>
-              <a:t>Public source repository · Not a hosted web app</a:t>
-            </a:r>
-            <a:endParaRPr/>
-          </a:p>
-        </p:txBody>
-      </p:sp>
-      <p:sp>
-        <p:nvSpPr>
-          <p:cNvPr id="93" name="" descr="{&quot;isTemplate&quot;:true,&quot;type&quot;:&quot;text&quot;}">
-            <a:hlinkClick r:id="rId3"/>
+              <a:t>Public GitHub repository · Run locally, not a hosted service</a:t>
+            </a:r>
+            <a:endParaRPr lang="zh-CN" sz="1800" b="1">
+              <a:solidFill>
+                <a:srgbClr val="CDEA9F"/>
+              </a:solidFill>
+              <a:latin typeface="Arial"/>
+              <a:ea typeface="Arial"/>
+            </a:endParaRPr>
+          </a:p>
+        </p:txBody>
+      </p:sp>
+      <p:sp>
+        <p:nvSpPr>
+          <p:cNvPr id="91" name="" descr="{&quot;isTemplate&quot;:true,&quot;type&quot;:&quot;text&quot;}">
+            <a:hlinkClick r:id="rId2"/>
           </p:cNvPr>
           <p:cNvSpPr txBox="1"/>
           <p:nvPr/>
@@ -4447,21 +4107,26 @@
             <a:r>
               <a:rPr lang="en-US" sz="1875">
                 <a:solidFill>
-                  <a:srgbClr val="F1F5E9"/>
-                </a:solidFill>
-                <a:latin typeface="Arial"/>
-                <a:ea typeface="Arial"/>
-                <a:hlinkClick r:id="rId3"/>
+                  <a:srgbClr val="CDEA9F"/>
+                </a:solidFill>
+                <a:latin typeface="Arial"/>
+                <a:ea typeface="Arial"/>
               </a:rPr>
               <a:t>https://github.com/ryuhanbin/sponsorbridge-hackathon</a:t>
             </a:r>
-            <a:endParaRPr/>
-          </a:p>
-        </p:txBody>
-      </p:sp>
-      <p:sp>
-        <p:nvSpPr>
-          <p:cNvPr id="94" name="" descr="{&quot;isTemplate&quot;:true,&quot;type&quot;:&quot;text&quot;}"/>
+            <a:endParaRPr lang="en-US" sz="1875">
+              <a:solidFill>
+                <a:srgbClr val="CDEA9F"/>
+              </a:solidFill>
+              <a:latin typeface="Arial"/>
+              <a:ea typeface="Arial"/>
+            </a:endParaRPr>
+          </a:p>
+        </p:txBody>
+      </p:sp>
+      <p:sp>
+        <p:nvSpPr>
+          <p:cNvPr id="92" name="" descr="{&quot;isTemplate&quot;:true,&quot;type&quot;:&quot;text&quot;}"/>
           <p:cNvSpPr txBox="1"/>
           <p:nvPr/>
         </p:nvSpPr>
@@ -4481,22 +4146,28 @@
               </a:lnSpc>
             </a:pPr>
             <a:r>
-              <a:rPr lang="en-US" sz="1500">
+              <a:rPr lang="zh-CN" sz="1400">
                 <a:solidFill>
                   <a:srgbClr val="F1F5E9"/>
                 </a:solidFill>
                 <a:latin typeface="Arial"/>
                 <a:ea typeface="Arial"/>
               </a:rPr>
-              <a:t>No automatic dispatch, business outreach, payments, or university approval.</a:t>
-            </a:r>
-            <a:endParaRPr/>
-          </a:p>
-        </p:txBody>
-      </p:sp>
-      <p:sp>
-        <p:nvSpPr>
-          <p:cNvPr id="95" name="" descr="{&quot;isTemplate&quot;:true,&quot;type&quot;:&quot;text&quot;}"/>
+              <a:t>No secured sponsors, business contact, payments, or university approval.</a:t>
+            </a:r>
+            <a:endParaRPr lang="zh-CN" sz="1400">
+              <a:solidFill>
+                <a:srgbClr val="F1F5E9"/>
+              </a:solidFill>
+              <a:latin typeface="Arial"/>
+              <a:ea typeface="Arial"/>
+            </a:endParaRPr>
+          </a:p>
+        </p:txBody>
+      </p:sp>
+      <p:sp>
+        <p:nvSpPr>
+          <p:cNvPr id="93" name="" descr="{&quot;isTemplate&quot;:true,&quot;type&quot;:&quot;text&quot;}"/>
           <p:cNvSpPr txBox="1"/>
           <p:nvPr/>
         </p:nvSpPr>
@@ -4516,7 +4187,7 @@
               </a:lnSpc>
             </a:pPr>
             <a:r>
-              <a:rPr lang="en-US" sz="1125">
+              <a:rPr lang="zh-CN" sz="1125">
                 <a:solidFill>
                   <a:srgbClr val="F1F5E9"/>
                 </a:solidFill>
@@ -4525,13 +4196,19 @@
               </a:rPr>
               <a:t>Afiq · SponsorBridge · 11 October 2026</a:t>
             </a:r>
-            <a:endParaRPr/>
-          </a:p>
-        </p:txBody>
-      </p:sp>
-      <p:sp>
-        <p:nvSpPr>
-          <p:cNvPr id="96" name="" descr="{&quot;isTemplate&quot;:true,&quot;type&quot;:&quot;text&quot;}"/>
+            <a:endParaRPr lang="zh-CN" sz="1125">
+              <a:solidFill>
+                <a:srgbClr val="F1F5E9"/>
+              </a:solidFill>
+              <a:latin typeface="Arial"/>
+              <a:ea typeface="Arial"/>
+            </a:endParaRPr>
+          </a:p>
+        </p:txBody>
+      </p:sp>
+      <p:sp>
+        <p:nvSpPr>
+          <p:cNvPr id="94" name="" descr="{&quot;isTemplate&quot;:true,&quot;type&quot;:&quot;text&quot;}"/>
           <p:cNvSpPr txBox="1"/>
           <p:nvPr/>
         </p:nvSpPr>
@@ -4564,6 +4241,24 @@
           </a:p>
         </p:txBody>
       </p:sp>
+      <p:pic>
+        <p:nvPicPr>
+          <p:cNvPr id="95" name=""/>
+          <p:cNvPicPr/>
+          <p:nvPr/>
+        </p:nvPicPr>
+        <p:blipFill>
+          <a:blip r:embed="rId3"/>
+          <a:stretch/>
+        </p:blipFill>
+        <p:spPr>
+          <a:xfrm>
+            <a:off x="571500" y="1320800"/>
+            <a:ext cx="3200400" cy="2333625"/>
+          </a:xfrm>
+          <a:prstGeom prst="rect"/>
+        </p:spPr>
+      </p:pic>
     </p:spTree>
   </p:cSld>
 </p:sld>

</xml_diff>

<commit_message>
Add fictional business marketplace preview
</commit_message>
<xml_diff>
--- a/slides/SponsorBridge-pitch.pptx
+++ b/slides/SponsorBridge-pitch.pptx
@@ -269,7 +269,8 @@
             <a:pPr/>
             <a:r>
               <a:rPr lang="en-US"/>
-              <a:t>SponsorBridge is a local prototype built with WorkBuddy and presented by Afiq. It helps student organisers clarify a sponsorship ask. It is not an official UPM service. Screenshots use the current submission frontend with an existing saved fictional request; no new model run was started for these slides.</a:t>
+              <a:t>PUTRApitch is a local prototype built with WorkBuddy and presented by Afiq. It helps student organisers clarify a sponsorship ask. It is not an official UPM service. Screenshots use the current submission frontend with an existing saved fictional request; no new model run was started for these slides.
+Rebrand: original PUTRApitch P-and-pitch-arrow logo; not an official university identity. Current monochrome frontend screenshots are read-only captures of the existing saved fictional fair request. No new sponsorship-model call. Repository URL unchanged; local rebrand not pushed.</a:t>
             </a:r>
             <a:endParaRPr/>
           </a:p>
@@ -320,7 +321,8 @@
             <a:pPr/>
             <a:r>
               <a:rPr lang="en-US"/>
-              <a:t>This is a problem framing, not a market-statistics or user-research result. Contributions can be products, services or cash. Proposed support and organiser-stated benefits are drafts, not sponsor agreements or university approval.</a:t>
+              <a:t>This is a problem framing, not a market-statistics or user-research result. Contributions can be products, services or cash. Proposed support and organiser-stated benefits are drafts, not sponsor agreements or university approval.
+Rebrand: original PUTRApitch P-and-pitch-arrow logo; not an official university identity. Current monochrome frontend screenshots are read-only captures of the existing saved fictional fair request. No new sponsorship-model call. Repository URL unchanged; local rebrand not pushed.</a:t>
             </a:r>
             <a:endParaRPr/>
           </a:p>
@@ -371,7 +373,8 @@
             <a:pPr/>
             <a:r>
               <a:rPr lang="en-US"/>
-              <a:t>One explicit run first prepares event details and clarification questions. The organiser saves answers, then a later explicit run drafts cards. The optional button invokes CodeBuddy CLI, not an existing WorkBuddy desktop conversation. Manual WorkBuddy handoff remains available under Advanced. The screenshot shows cards already saved: the button opens them without another model run.</a:t>
+              <a:t>One explicit run first prepares event details and clarification questions. The organiser saves answers, then a later explicit run drafts cards. The optional button invokes CodeBuddy CLI, not an existing WorkBuddy desktop conversation. Manual WorkBuddy handoff remains available under Advanced. The screenshot shows cards already saved: the button opens them without another model run.
+Rebrand: original PUTRApitch P-and-pitch-arrow logo; not an official university identity. Current monochrome frontend screenshots are read-only captures of the existing saved fictional fair request. No new sponsorship-model call. Repository URL unchanged; local rebrand not pushed.</a:t>
             </a:r>
             <a:endParaRPr/>
           </a:p>
@@ -422,7 +425,8 @@
             <a:pPr/>
             <a:r>
               <a:rPr lang="en-US"/>
-              <a:t>The existing Campus Sustainability Fair request is fictional. Saved author: CodeBuddy CLI via API key. Two cards request reusable bottles and repair-workshop materials, with quantities/date/venue/approvals/tax status unconfirmed. A revision-1 fictional organiser answer supplies logo on the event page and verbal thanks during opening remarks only; no booth, social-media mention, extra branding, price or university endorsement. Both cards await content review. README documents live card content recovered from CLI traces and validated; a fresh live end-to-end run of the final one-click streamed path has not been performed.</a:t>
+              <a:t>The existing Campus Sustainability Fair request is fictional. Saved author: CodeBuddy CLI via API key. Two cards request reusable bottles and repair-workshop materials, with quantities/date/venue/approvals/tax status unconfirmed. A revision-1 fictional organiser answer supplies logo on the event page and verbal thanks during opening remarks only; no booth, social-media mention, extra branding, price or university endorsement. Both cards await content review. README documents live card content recovered from CLI traces and validated; a fresh live end-to-end run of the final one-click streamed path has not been performed.
+Rebrand: original PUTRApitch P-and-pitch-arrow logo; not an official university identity. Current monochrome frontend screenshots are read-only captures of the existing saved fictional fair request. No new sponsorship-model call. Repository URL unchanged; local rebrand not pushed.</a:t>
             </a:r>
             <a:endParaRPr/>
           </a:p>
@@ -473,7 +477,9 @@
             <a:pPr/>
             <a:r>
               <a:rPr lang="en-US"/>
-              <a:t>All 25 current Node checks passed in this task; model tests inject fake responses and do not use live credits. The CodeBuddy key is stored locally in plain text at data/.codebuddy-key, not returned by the backend to the browser, and data/ and key filenames are ignored by Git. Public main tree contains no data/ or key files. This is not an encrypted production secret store, and a complete historical secret audit was not performed. Do not confuse CodeBuddy CLI model execution with automatic WorkBuddy desktop execution. No fresh paid AI demo was run.</a:t>
+              <a:t>All 25 current Node checks passed in this task; model tests inject fake responses and do not use live credits. The CodeBuddy key is stored locally in plain text at data/.codebuddy-key, not returned by the backend to the browser, and data/ and key filenames are ignored by Git. Public main tree contains no data/ or key files. This is not an encrypted production secret store, and a complete historical secret audit was not performed. Do not confuse CodeBuddy CLI model execution with automatic WorkBuddy desktop execution. No fresh paid AI demo was run.
+Rebrand: original PUTRApitch P-and-pitch-arrow logo; not an official university identity. Current monochrome frontend screenshots are read-only captures of the existing saved fictional fair request. No new sponsorship-model call. Repository URL unchanged; local rebrand not pushed.
+Approved reference-style frontend passed 134 browser assertions prior to rebranding; rebrand checks are recorded separately. Browser writes use memory-only fixtures, not live agent execution.</a:t>
             </a:r>
             <a:endParaRPr/>
           </a:p>
@@ -524,7 +530,8 @@
             <a:pPr/>
             <a:r>
               <a:rPr lang="en-US"/>
-              <a:t>Public source verified accessible: https://github.com/ryuhanbin/sponsorbridge-hackathon. The repository is public and contains the app, README, tests, evidence and pitch deck path. Final slide edits are local until separately committed and pushed. Matching, outreach and complete campaign export remain planned, not built. No sponsors secured or university approval claimed.</a:t>
+              <a:t>Public source verified accessible: https://github.com/ryuhanbin/sponsorbridge-hackathon. The repository is public and contains the app, README, tests, evidence and pitch deck path. Final slide edits are local until separately committed and pushed. Matching, outreach and complete campaign export remain planned, not built. No sponsors secured or university approval claimed.
+Rebrand: original PUTRApitch P-and-pitch-arrow logo; not an official university identity. Current monochrome frontend screenshots are read-only captures of the existing saved fictional fair request. No new sponsorship-model call. Repository URL unchanged; local rebrand not pushed.</a:t>
             </a:r>
             <a:endParaRPr/>
           </a:p>
@@ -882,7 +889,9 @@
             <a:avLst/>
           </a:prstGeom>
           <a:solidFill>
-            <a:srgbClr val="0E1915"/>
+            <a:srgbClr val="202020">
+              <a:alpha val="100000"/>
+            </a:srgbClr>
           </a:solidFill>
           <a:ln/>
         </p:spPr>
@@ -918,16 +927,16 @@
             <a:r>
               <a:rPr lang="zh-CN" sz="1425" b="1" spc="150">
                 <a:solidFill>
-                  <a:srgbClr val="CDEA9F"/>
-                </a:solidFill>
-                <a:latin typeface="Arial"/>
-                <a:ea typeface="Arial"/>
-              </a:rPr>
-              <a:t>SPONSORBRIDGE / HACKATHON 2026</a:t>
+                  <a:srgbClr val="DADADA"/>
+                </a:solidFill>
+                <a:latin typeface="Arial"/>
+                <a:ea typeface="Arial"/>
+              </a:rPr>
+              <a:t>PUTRApitch / HACKATHON 2026</a:t>
             </a:r>
             <a:endParaRPr lang="zh-CN" sz="1425" b="1" spc="150">
               <a:solidFill>
-                <a:srgbClr val="CDEA9F"/>
+                <a:srgbClr val="DADADA"/>
               </a:solidFill>
               <a:latin typeface="Arial"/>
               <a:ea typeface="Arial"/>
@@ -938,41 +947,6 @@
       <p:sp>
         <p:nvSpPr>
           <p:cNvPr id="4" name="" descr="{&quot;isTemplate&quot;:true,&quot;type&quot;:&quot;text&quot;}"/>
-          <p:cNvSpPr txBox="1"/>
-          <p:nvPr/>
-        </p:nvSpPr>
-        <p:spPr>
-          <a:xfrm rot="0" flipH="0" flipV="0">
-            <a:off x="571500" y="1657350"/>
-            <a:ext cx="5810250" cy="914400"/>
-          </a:xfrm>
-          <a:prstGeom prst="rect"/>
-        </p:spPr>
-        <p:txBody>
-          <a:bodyPr wrap="none" lIns="0" tIns="0" rIns="0" bIns="0"/>
-          <a:p>
-            <a:pPr>
-              <a:lnSpc>
-                <a:spcPct val="110000"/>
-              </a:lnSpc>
-            </a:pPr>
-            <a:r>
-              <a:rPr lang="en-US" sz="5400" b="1">
-                <a:solidFill>
-                  <a:srgbClr val="F1F5E9"/>
-                </a:solidFill>
-                <a:latin typeface="Arial"/>
-                <a:ea typeface="Arial"/>
-              </a:rPr>
-              <a:t>SponsorBridge</a:t>
-            </a:r>
-            <a:endParaRPr/>
-          </a:p>
-        </p:txBody>
-      </p:sp>
-      <p:sp>
-        <p:nvSpPr>
-          <p:cNvPr id="5" name="" descr="{&quot;isTemplate&quot;:true,&quot;type&quot;:&quot;text&quot;}"/>
           <p:cNvSpPr txBox="1"/>
           <p:nvPr/>
         </p:nvSpPr>
@@ -994,7 +968,7 @@
             <a:r>
               <a:rPr lang="zh-CN" sz="2600" b="1">
                 <a:solidFill>
-                  <a:srgbClr val="CDEA9F"/>
+                  <a:srgbClr val="DADADA"/>
                 </a:solidFill>
                 <a:latin typeface="Arial"/>
                 <a:ea typeface="Arial"/>
@@ -1004,17 +978,17 @@
             </a:r>
             <a:endParaRPr lang="zh-CN" sz="2600" b="1">
               <a:solidFill>
-                <a:srgbClr val="CDEA9F"/>
-              </a:solidFill>
-              <a:latin typeface="Arial"/>
-              <a:ea typeface="Arial"/>
-            </a:endParaRPr>
-          </a:p>
-        </p:txBody>
-      </p:sp>
-      <p:sp>
-        <p:nvSpPr>
-          <p:cNvPr id="6" name="" descr="{&quot;isTemplate&quot;:true,&quot;type&quot;:&quot;text&quot;}"/>
+                <a:srgbClr val="DADADA"/>
+              </a:solidFill>
+              <a:latin typeface="Arial"/>
+              <a:ea typeface="Arial"/>
+            </a:endParaRPr>
+          </a:p>
+        </p:txBody>
+      </p:sp>
+      <p:sp>
+        <p:nvSpPr>
+          <p:cNvPr id="5" name="" descr="{&quot;isTemplate&quot;:true,&quot;type&quot;:&quot;text&quot;}"/>
           <p:cNvSpPr txBox="1"/>
           <p:nvPr/>
         </p:nvSpPr>
@@ -1056,7 +1030,7 @@
       </p:sp>
       <p:sp>
         <p:nvSpPr>
-          <p:cNvPr id="7" name="" descr="{&quot;isTemplate&quot;:true,&quot;type&quot;:&quot;text&quot;}"/>
+          <p:cNvPr id="6" name="" descr="{&quot;isTemplate&quot;:true,&quot;type&quot;:&quot;text&quot;}"/>
           <p:cNvSpPr txBox="1"/>
           <p:nvPr/>
         </p:nvSpPr>
@@ -1091,7 +1065,7 @@
       </p:sp>
       <p:sp>
         <p:nvSpPr>
-          <p:cNvPr id="8" name="" descr="{&quot;isTemplate&quot;:true,&quot;type&quot;:&quot;text&quot;}"/>
+          <p:cNvPr id="7" name="" descr="{&quot;isTemplate&quot;:true,&quot;type&quot;:&quot;text&quot;}"/>
           <p:cNvSpPr txBox="1"/>
           <p:nvPr/>
         </p:nvSpPr>
@@ -1132,7 +1106,7 @@
       </p:sp>
       <p:sp>
         <p:nvSpPr>
-          <p:cNvPr id="9" name=""/>
+          <p:cNvPr id="8" name=""/>
           <p:cNvSpPr/>
           <p:nvPr/>
         </p:nvSpPr>
@@ -1147,7 +1121,9 @@
             </a:avLst>
           </a:prstGeom>
           <a:solidFill>
-            <a:srgbClr val="1D3328"/>
+            <a:srgbClr val="303030">
+              <a:alpha val="100000"/>
+            </a:srgbClr>
           </a:solidFill>
           <a:ln/>
         </p:spPr>
@@ -1161,7 +1137,7 @@
       </p:sp>
       <p:sp>
         <p:nvSpPr>
-          <p:cNvPr id="10" name="" descr="{&quot;isTemplate&quot;:true,&quot;type&quot;:&quot;text&quot;}"/>
+          <p:cNvPr id="9" name="" descr="{&quot;isTemplate&quot;:true,&quot;type&quot;:&quot;text&quot;}"/>
           <p:cNvSpPr txBox="1"/>
           <p:nvPr/>
         </p:nvSpPr>
@@ -1183,7 +1159,7 @@
             <a:r>
               <a:rPr lang="zh-CN" sz="1200">
                 <a:solidFill>
-                  <a:srgbClr val="CDEA9F"/>
+                  <a:srgbClr val="DADADA"/>
                 </a:solidFill>
                 <a:latin typeface="Arial"/>
                 <a:ea typeface="Arial"/>
@@ -1192,17 +1168,17 @@
             </a:r>
             <a:endParaRPr lang="zh-CN" sz="1200">
               <a:solidFill>
-                <a:srgbClr val="CDEA9F"/>
-              </a:solidFill>
-              <a:latin typeface="Arial"/>
-              <a:ea typeface="Arial"/>
-            </a:endParaRPr>
-          </a:p>
-        </p:txBody>
-      </p:sp>
-      <p:sp>
-        <p:nvSpPr>
-          <p:cNvPr id="11" name="" descr="{&quot;isTemplate&quot;:true,&quot;type&quot;:&quot;text&quot;}"/>
+                <a:srgbClr val="DADADA"/>
+              </a:solidFill>
+              <a:latin typeface="Arial"/>
+              <a:ea typeface="Arial"/>
+            </a:endParaRPr>
+          </a:p>
+        </p:txBody>
+      </p:sp>
+      <p:sp>
+        <p:nvSpPr>
+          <p:cNvPr id="10" name="" descr="{&quot;isTemplate&quot;:true,&quot;type&quot;:&quot;text&quot;}"/>
           <p:cNvSpPr txBox="1"/>
           <p:nvPr/>
         </p:nvSpPr>
@@ -1243,7 +1219,7 @@
       </p:sp>
       <p:sp>
         <p:nvSpPr>
-          <p:cNvPr id="12" name="" descr="{&quot;isTemplate&quot;:true,&quot;type&quot;:&quot;text&quot;}"/>
+          <p:cNvPr id="11" name="" descr="{&quot;isTemplate&quot;:true,&quot;type&quot;:&quot;text&quot;}"/>
           <p:cNvSpPr txBox="1"/>
           <p:nvPr/>
         </p:nvSpPr>
@@ -1276,6 +1252,24 @@
           </a:p>
         </p:txBody>
       </p:sp>
+      <p:pic>
+        <p:nvPicPr>
+          <p:cNvPr id="12" name=""/>
+          <p:cNvPicPr/>
+          <p:nvPr/>
+        </p:nvPicPr>
+        <p:blipFill>
+          <a:blip r:embed="rId2"/>
+          <a:stretch/>
+        </p:blipFill>
+        <p:spPr>
+          <a:xfrm>
+            <a:off x="508000" y="1498600"/>
+            <a:ext cx="5905500" cy="1280710"/>
+          </a:xfrm>
+          <a:prstGeom prst="rect"/>
+        </p:spPr>
+      </p:pic>
       <p:pic>
         <p:nvPicPr>
           <p:cNvPr id="13" name=""/>
@@ -1283,7 +1277,7 @@
           <p:nvPr/>
         </p:nvPicPr>
         <p:blipFill>
-          <a:blip r:embed="rId2"/>
+          <a:blip r:embed="rId3"/>
           <a:stretch/>
         </p:blipFill>
         <p:spPr>
@@ -1300,7 +1294,7 @@
 </file>
 
 <file path=ppt/slides/slide2.xml><?xml version="1.0" encoding="utf-8"?>
-<p:sld xmlns:p="http://schemas.openxmlformats.org/presentationml/2006/main" xmlns:a="http://schemas.openxmlformats.org/drawingml/2006/main">
+<p:sld xmlns:p="http://schemas.openxmlformats.org/presentationml/2006/main" xmlns:a="http://schemas.openxmlformats.org/drawingml/2006/main" xmlns:r="http://schemas.openxmlformats.org/officeDocument/2006/relationships">
   <p:cSld>
     <p:spTree>
       <p:nvGrpSpPr>
@@ -1331,7 +1325,9 @@
             <a:avLst/>
           </a:prstGeom>
           <a:solidFill>
-            <a:srgbClr val="0E1915"/>
+            <a:srgbClr val="202020">
+              <a:alpha val="100000"/>
+            </a:srgbClr>
           </a:solidFill>
           <a:ln/>
         </p:spPr>
@@ -1367,7 +1363,7 @@
             <a:r>
               <a:rPr lang="zh-CN" sz="1350">
                 <a:solidFill>
-                  <a:srgbClr val="CDEA9F"/>
+                  <a:srgbClr val="DADADA"/>
                 </a:solidFill>
                 <a:latin typeface="Arial"/>
                 <a:ea typeface="Arial"/>
@@ -1376,7 +1372,7 @@
             </a:r>
             <a:endParaRPr lang="zh-CN" sz="1350">
               <a:solidFill>
-                <a:srgbClr val="CDEA9F"/>
+                <a:srgbClr val="DADADA"/>
               </a:solidFill>
               <a:latin typeface="Arial"/>
               <a:ea typeface="Arial"/>
@@ -1440,7 +1436,9 @@
             <a:avLst/>
           </a:prstGeom>
           <a:solidFill>
-            <a:srgbClr val="1D3328"/>
+            <a:srgbClr val="303030">
+              <a:alpha val="100000"/>
+            </a:srgbClr>
           </a:solidFill>
           <a:ln/>
         </p:spPr>
@@ -1476,50 +1474,58 @@
             <a:r>
               <a:rPr lang="en-US" sz="3600" b="1">
                 <a:solidFill>
-                  <a:srgbClr val="CDEA9F"/>
+                  <a:srgbClr val="DADADA"/>
                 </a:solidFill>
                 <a:latin typeface="Arial"/>
                 <a:ea typeface="Arial"/>
               </a:rPr>
               <a:t>Clarify</a:t>
             </a:r>
-            <a:endParaRPr/>
-          </a:p>
-          <a:p>
-            <a:pPr>
-              <a:lnSpc>
-                <a:spcPct val="114999"/>
-              </a:lnSpc>
-            </a:pPr>
+            <a:r>
+              <a:rPr lang="zh-CN">
+                <a:solidFill>
+                  <a:srgbClr val="DADADA"/>
+                </a:solidFill>
+              </a:rPr>
+              <a:t>+</a:t>
+            </a:r>
             <a:r>
               <a:rPr lang="en-US" sz="3600" b="1">
                 <a:solidFill>
-                  <a:srgbClr val="CDEA9F"/>
+                  <a:srgbClr val="DADADA"/>
                 </a:solidFill>
                 <a:latin typeface="Arial"/>
                 <a:ea typeface="Arial"/>
               </a:rPr>
               <a:t>before</a:t>
             </a:r>
-            <a:endParaRPr/>
-          </a:p>
-          <a:p>
-            <a:pPr>
-              <a:lnSpc>
-                <a:spcPct val="114999"/>
-              </a:lnSpc>
-            </a:pPr>
+            <a:r>
+              <a:rPr lang="zh-CN">
+                <a:solidFill>
+                  <a:srgbClr val="DADADA"/>
+                </a:solidFill>
+              </a:rPr>
+              <a:t>+</a:t>
+            </a:r>
             <a:r>
               <a:rPr lang="en-US" sz="3600" b="1">
                 <a:solidFill>
-                  <a:srgbClr val="CDEA9F"/>
+                  <a:srgbClr val="DADADA"/>
                 </a:solidFill>
                 <a:latin typeface="Arial"/>
                 <a:ea typeface="Arial"/>
               </a:rPr>
               <a:t>committing.</a:t>
             </a:r>
-            <a:endParaRPr/>
+            <a:endParaRPr lang="en-US" sz="3600" b="1">
+              <a:solidFill>
+                <a:srgbClr val="DADADA"/>
+              </a:solidFill>
+              <a:latin typeface="Arial"/>
+              <a:ea typeface="Arial"/>
+            </a:endParaRPr>
           </a:p>
         </p:txBody>
       </p:sp>
@@ -1594,14 +1600,20 @@
             <a:r>
               <a:rPr lang="en-US" sz="2175" b="1">
                 <a:solidFill>
-                  <a:srgbClr val="CDEA9F"/>
+                  <a:srgbClr val="DADADA"/>
                 </a:solidFill>
                 <a:latin typeface="Arial"/>
                 <a:ea typeface="Arial"/>
               </a:rPr>
               <a:t>01  Define the support need</a:t>
             </a:r>
-            <a:endParaRPr/>
+            <a:endParaRPr lang="en-US" sz="2175" b="1">
+              <a:solidFill>
+                <a:srgbClr val="DADADA"/>
+              </a:solidFill>
+              <a:latin typeface="Arial"/>
+              <a:ea typeface="Arial"/>
+            </a:endParaRPr>
           </a:p>
         </p:txBody>
       </p:sp>
@@ -1671,14 +1683,20 @@
             <a:r>
               <a:rPr lang="en-US" sz="2175" b="1">
                 <a:solidFill>
-                  <a:srgbClr val="CDEA9F"/>
+                  <a:srgbClr val="DADADA"/>
                 </a:solidFill>
                 <a:latin typeface="Arial"/>
                 <a:ea typeface="Arial"/>
               </a:rPr>
               <a:t>02  Explain authorised sponsor benefits</a:t>
             </a:r>
-            <a:endParaRPr/>
+            <a:endParaRPr lang="en-US" sz="2175" b="1">
+              <a:solidFill>
+                <a:srgbClr val="DADADA"/>
+              </a:solidFill>
+              <a:latin typeface="Arial"/>
+              <a:ea typeface="Arial"/>
+            </a:endParaRPr>
           </a:p>
         </p:txBody>
       </p:sp>
@@ -1748,7 +1766,7 @@
             <a:r>
               <a:rPr lang="zh-CN" sz="2175" b="1">
                 <a:solidFill>
-                  <a:srgbClr val="CDEA9F"/>
+                  <a:srgbClr val="DADADA"/>
                 </a:solidFill>
                 <a:latin typeface="Arial"/>
                 <a:ea typeface="Arial"/>
@@ -1757,7 +1775,7 @@
             </a:r>
             <a:endParaRPr lang="zh-CN" sz="2175" b="1">
               <a:solidFill>
-                <a:srgbClr val="CDEA9F"/>
+                <a:srgbClr val="DADADA"/>
               </a:solidFill>
               <a:latin typeface="Arial"/>
               <a:ea typeface="Arial"/>
@@ -1877,6 +1895,24 @@
           </a:p>
         </p:txBody>
       </p:sp>
+      <p:pic>
+        <p:nvPicPr>
+          <p:cNvPr id="29" name=""/>
+          <p:cNvPicPr/>
+          <p:nvPr/>
+        </p:nvPicPr>
+        <p:blipFill>
+          <a:blip r:embed="rId2"/>
+          <a:stretch/>
+        </p:blipFill>
+        <p:spPr>
+          <a:xfrm>
+            <a:off x="11607800" y="228600"/>
+            <a:ext cx="381000" cy="381000"/>
+          </a:xfrm>
+          <a:prstGeom prst="rect"/>
+        </p:spPr>
+      </p:pic>
     </p:spTree>
   </p:cSld>
 </p:sld>
@@ -1887,7 +1923,7 @@
   <p:cSld>
     <p:spTree>
       <p:nvGrpSpPr>
-        <p:cNvPr id="29" name=""/>
+        <p:cNvPr id="30" name=""/>
         <p:cNvGrpSpPr/>
         <p:nvPr/>
       </p:nvGrpSpPr>
@@ -1901,7 +1937,7 @@
       </p:grpSpPr>
       <p:sp>
         <p:nvSpPr>
-          <p:cNvPr id="30" name=""/>
+          <p:cNvPr id="31" name=""/>
           <p:cNvSpPr/>
           <p:nvPr/>
         </p:nvSpPr>
@@ -1914,7 +1950,9 @@
             <a:avLst/>
           </a:prstGeom>
           <a:solidFill>
-            <a:srgbClr val="0E1915"/>
+            <a:srgbClr val="202020">
+              <a:alpha val="100000"/>
+            </a:srgbClr>
           </a:solidFill>
           <a:ln/>
         </p:spPr>
@@ -1928,7 +1966,7 @@
       </p:sp>
       <p:sp>
         <p:nvSpPr>
-          <p:cNvPr id="31" name="" descr="{&quot;isTemplate&quot;:true,&quot;type&quot;:&quot;text&quot;}"/>
+          <p:cNvPr id="32" name="" descr="{&quot;isTemplate&quot;:true,&quot;type&quot;:&quot;text&quot;}"/>
           <p:cNvSpPr txBox="1"/>
           <p:nvPr/>
         </p:nvSpPr>
@@ -1950,7 +1988,7 @@
             <a:r>
               <a:rPr lang="zh-CN" sz="1350">
                 <a:solidFill>
-                  <a:srgbClr val="CDEA9F"/>
+                  <a:srgbClr val="DADADA"/>
                 </a:solidFill>
                 <a:latin typeface="Arial"/>
                 <a:ea typeface="Arial"/>
@@ -1959,17 +1997,17 @@
             </a:r>
             <a:endParaRPr lang="zh-CN" sz="1350">
               <a:solidFill>
-                <a:srgbClr val="CDEA9F"/>
-              </a:solidFill>
-              <a:latin typeface="Arial"/>
-              <a:ea typeface="Arial"/>
-            </a:endParaRPr>
-          </a:p>
-        </p:txBody>
-      </p:sp>
-      <p:sp>
-        <p:nvSpPr>
-          <p:cNvPr id="32" name="" descr="{&quot;isTemplate&quot;:true,&quot;type&quot;:&quot;text&quot;}"/>
+                <a:srgbClr val="DADADA"/>
+              </a:solidFill>
+              <a:latin typeface="Arial"/>
+              <a:ea typeface="Arial"/>
+            </a:endParaRPr>
+          </a:p>
+        </p:txBody>
+      </p:sp>
+      <p:sp>
+        <p:nvSpPr>
+          <p:cNvPr id="33" name="" descr="{&quot;isTemplate&quot;:true,&quot;type&quot;:&quot;text&quot;}"/>
           <p:cNvSpPr txBox="1"/>
           <p:nvPr/>
         </p:nvSpPr>
@@ -2010,7 +2048,7 @@
       </p:sp>
       <p:sp>
         <p:nvSpPr>
-          <p:cNvPr id="33" name="" descr="{&quot;isTemplate&quot;:true,&quot;type&quot;:&quot;text&quot;}"/>
+          <p:cNvPr id="34" name="" descr="{&quot;isTemplate&quot;:true,&quot;type&quot;:&quot;text&quot;}"/>
           <p:cNvSpPr txBox="1"/>
           <p:nvPr/>
         </p:nvSpPr>
@@ -2051,7 +2089,7 @@
       </p:sp>
       <p:sp>
         <p:nvSpPr>
-          <p:cNvPr id="34" name="" descr="{&quot;isTemplate&quot;:true,&quot;type&quot;:&quot;text&quot;}"/>
+          <p:cNvPr id="35" name="" descr="{&quot;isTemplate&quot;:true,&quot;type&quot;:&quot;text&quot;}"/>
           <p:cNvSpPr txBox="1"/>
           <p:nvPr/>
         </p:nvSpPr>
@@ -2084,24 +2122,6 @@
           </a:p>
         </p:txBody>
       </p:sp>
-      <p:pic>
-        <p:nvPicPr>
-          <p:cNvPr id="35" name=""/>
-          <p:cNvPicPr/>
-          <p:nvPr/>
-        </p:nvPicPr>
-        <p:blipFill>
-          <a:blip r:embed="rId2"/>
-          <a:stretch/>
-        </p:blipFill>
-        <p:spPr>
-          <a:xfrm>
-            <a:off x="571500" y="1371600"/>
-            <a:ext cx="11030272" cy="2362200"/>
-          </a:xfrm>
-          <a:prstGeom prst="rect"/>
-        </p:spPr>
-      </p:pic>
       <p:sp>
         <p:nvSpPr>
           <p:cNvPr id="36" name=""/>
@@ -2119,7 +2139,9 @@
             </a:avLst>
           </a:prstGeom>
           <a:solidFill>
-            <a:srgbClr val="1D3328"/>
+            <a:srgbClr val="303030">
+              <a:alpha val="100000"/>
+            </a:srgbClr>
           </a:solidFill>
           <a:ln>
             <a:noFill/>
@@ -2127,7 +2149,10 @@
         </p:spPr>
         <p:txBody>
           <a:bodyPr/>
-          <a:p/>
+          <a:p>
+            <a:pPr/>
+            <a:endParaRPr/>
+          </a:p>
         </p:txBody>
       </p:sp>
       <p:sp>
@@ -2147,7 +2172,9 @@
             </a:avLst>
           </a:prstGeom>
           <a:solidFill>
-            <a:srgbClr val="1D3328"/>
+            <a:srgbClr val="303030">
+              <a:alpha val="100000"/>
+            </a:srgbClr>
           </a:solidFill>
           <a:ln>
             <a:noFill/>
@@ -2155,7 +2182,10 @@
         </p:spPr>
         <p:txBody>
           <a:bodyPr/>
-          <a:p/>
+          <a:p>
+            <a:pPr/>
+            <a:endParaRPr/>
+          </a:p>
         </p:txBody>
       </p:sp>
       <p:sp>
@@ -2175,7 +2205,9 @@
             </a:avLst>
           </a:prstGeom>
           <a:solidFill>
-            <a:srgbClr val="1D3328"/>
+            <a:srgbClr val="303030">
+              <a:alpha val="100000"/>
+            </a:srgbClr>
           </a:solidFill>
           <a:ln>
             <a:noFill/>
@@ -2183,7 +2215,10 @@
         </p:spPr>
         <p:txBody>
           <a:bodyPr/>
-          <a:p/>
+          <a:p>
+            <a:pPr/>
+            <a:endParaRPr/>
+          </a:p>
         </p:txBody>
       </p:sp>
       <p:sp>
@@ -2212,14 +2247,20 @@
             <a:r>
               <a:rPr lang="zh-CN" sz="2100">
                 <a:solidFill>
-                  <a:srgbClr val="CDEA9F"/>
+                  <a:srgbClr val="DADADA"/>
                 </a:solidFill>
                 <a:latin typeface="Arial"/>
                 <a:ea typeface="Arial"/>
               </a:rPr>
               <a:t>01  First run</a:t>
             </a:r>
-            <a:endParaRPr/>
+            <a:endParaRPr lang="zh-CN" sz="2100">
+              <a:solidFill>
+                <a:srgbClr val="DADADA"/>
+              </a:solidFill>
+              <a:latin typeface="Arial"/>
+              <a:ea typeface="Arial"/>
+            </a:endParaRPr>
           </a:p>
         </p:txBody>
       </p:sp>
@@ -2288,14 +2329,20 @@
             <a:r>
               <a:rPr lang="zh-CN" sz="2100">
                 <a:solidFill>
-                  <a:srgbClr val="CDEA9F"/>
+                  <a:srgbClr val="DADADA"/>
                 </a:solidFill>
                 <a:latin typeface="Arial"/>
                 <a:ea typeface="Arial"/>
               </a:rPr>
               <a:t>02  Organiser answers</a:t>
             </a:r>
-            <a:endParaRPr/>
+            <a:endParaRPr lang="zh-CN" sz="2100">
+              <a:solidFill>
+                <a:srgbClr val="DADADA"/>
+              </a:solidFill>
+              <a:latin typeface="Arial"/>
+              <a:ea typeface="Arial"/>
+            </a:endParaRPr>
           </a:p>
         </p:txBody>
       </p:sp>
@@ -2364,14 +2411,20 @@
             <a:r>
               <a:rPr lang="zh-CN" sz="2100">
                 <a:solidFill>
-                  <a:srgbClr val="CDEA9F"/>
+                  <a:srgbClr val="DADADA"/>
                 </a:solidFill>
                 <a:latin typeface="Arial"/>
                 <a:ea typeface="Arial"/>
               </a:rPr>
               <a:t>03  Later explicit run</a:t>
             </a:r>
-            <a:endParaRPr/>
+            <a:endParaRPr lang="zh-CN" sz="2100">
+              <a:solidFill>
+                <a:srgbClr val="DADADA"/>
+              </a:solidFill>
+              <a:latin typeface="Arial"/>
+              <a:ea typeface="Arial"/>
+            </a:endParaRPr>
           </a:p>
         </p:txBody>
       </p:sp>
@@ -2414,6 +2467,42 @@
           </a:p>
         </p:txBody>
       </p:sp>
+      <p:pic>
+        <p:nvPicPr>
+          <p:cNvPr id="45" name=""/>
+          <p:cNvPicPr/>
+          <p:nvPr/>
+        </p:nvPicPr>
+        <p:blipFill>
+          <a:blip r:embed="rId2"/>
+          <a:stretch/>
+        </p:blipFill>
+        <p:spPr>
+          <a:xfrm>
+            <a:off x="571500" y="1371600"/>
+            <a:ext cx="9017858" cy="2362200"/>
+          </a:xfrm>
+          <a:prstGeom prst="rect"/>
+        </p:spPr>
+      </p:pic>
+      <p:pic>
+        <p:nvPicPr>
+          <p:cNvPr id="46" name=""/>
+          <p:cNvPicPr/>
+          <p:nvPr/>
+        </p:nvPicPr>
+        <p:blipFill>
+          <a:blip r:embed="rId3"/>
+          <a:stretch/>
+        </p:blipFill>
+        <p:spPr>
+          <a:xfrm>
+            <a:off x="11607800" y="228600"/>
+            <a:ext cx="381000" cy="381000"/>
+          </a:xfrm>
+          <a:prstGeom prst="rect"/>
+        </p:spPr>
+      </p:pic>
     </p:spTree>
   </p:cSld>
 </p:sld>
@@ -2424,7 +2513,7 @@
   <p:cSld>
     <p:spTree>
       <p:nvGrpSpPr>
-        <p:cNvPr id="45" name=""/>
+        <p:cNvPr id="47" name=""/>
         <p:cNvGrpSpPr/>
         <p:nvPr/>
       </p:nvGrpSpPr>
@@ -2438,7 +2527,7 @@
       </p:grpSpPr>
       <p:sp>
         <p:nvSpPr>
-          <p:cNvPr id="46" name=""/>
+          <p:cNvPr id="48" name=""/>
           <p:cNvSpPr/>
           <p:nvPr/>
         </p:nvSpPr>
@@ -2451,7 +2540,9 @@
             <a:avLst/>
           </a:prstGeom>
           <a:solidFill>
-            <a:srgbClr val="0E1915"/>
+            <a:srgbClr val="202020">
+              <a:alpha val="100000"/>
+            </a:srgbClr>
           </a:solidFill>
           <a:ln/>
         </p:spPr>
@@ -2465,7 +2556,7 @@
       </p:sp>
       <p:sp>
         <p:nvSpPr>
-          <p:cNvPr id="47" name="" descr="{&quot;isTemplate&quot;:true,&quot;type&quot;:&quot;text&quot;}"/>
+          <p:cNvPr id="49" name="" descr="{&quot;isTemplate&quot;:true,&quot;type&quot;:&quot;text&quot;}"/>
           <p:cNvSpPr txBox="1"/>
           <p:nvPr/>
         </p:nvSpPr>
@@ -2487,7 +2578,7 @@
             <a:r>
               <a:rPr lang="zh-CN" sz="1350">
                 <a:solidFill>
-                  <a:srgbClr val="CDEA9F"/>
+                  <a:srgbClr val="DADADA"/>
                 </a:solidFill>
                 <a:latin typeface="Arial"/>
                 <a:ea typeface="Arial"/>
@@ -2496,17 +2587,17 @@
             </a:r>
             <a:endParaRPr lang="zh-CN" sz="1350">
               <a:solidFill>
-                <a:srgbClr val="CDEA9F"/>
-              </a:solidFill>
-              <a:latin typeface="Arial"/>
-              <a:ea typeface="Arial"/>
-            </a:endParaRPr>
-          </a:p>
-        </p:txBody>
-      </p:sp>
-      <p:sp>
-        <p:nvSpPr>
-          <p:cNvPr id="48" name="" descr="{&quot;isTemplate&quot;:true,&quot;type&quot;:&quot;text&quot;}"/>
+                <a:srgbClr val="DADADA"/>
+              </a:solidFill>
+              <a:latin typeface="Arial"/>
+              <a:ea typeface="Arial"/>
+            </a:endParaRPr>
+          </a:p>
+        </p:txBody>
+      </p:sp>
+      <p:sp>
+        <p:nvSpPr>
+          <p:cNvPr id="50" name="" descr="{&quot;isTemplate&quot;:true,&quot;type&quot;:&quot;text&quot;}"/>
           <p:cNvSpPr txBox="1"/>
           <p:nvPr/>
         </p:nvSpPr>
@@ -2547,7 +2638,7 @@
       </p:sp>
       <p:sp>
         <p:nvSpPr>
-          <p:cNvPr id="49" name="" descr="{&quot;isTemplate&quot;:true,&quot;type&quot;:&quot;text&quot;}"/>
+          <p:cNvPr id="51" name="" descr="{&quot;isTemplate&quot;:true,&quot;type&quot;:&quot;text&quot;}"/>
           <p:cNvSpPr txBox="1"/>
           <p:nvPr/>
         </p:nvSpPr>
@@ -2588,7 +2679,7 @@
       </p:sp>
       <p:sp>
         <p:nvSpPr>
-          <p:cNvPr id="50" name="" descr="{&quot;isTemplate&quot;:true,&quot;type&quot;:&quot;text&quot;}"/>
+          <p:cNvPr id="52" name="" descr="{&quot;isTemplate&quot;:true,&quot;type&quot;:&quot;text&quot;}"/>
           <p:cNvSpPr txBox="1"/>
           <p:nvPr/>
         </p:nvSpPr>
@@ -2621,42 +2712,6 @@
           </a:p>
         </p:txBody>
       </p:sp>
-      <p:pic>
-        <p:nvPicPr>
-          <p:cNvPr id="51" name=""/>
-          <p:cNvPicPr/>
-          <p:nvPr/>
-        </p:nvPicPr>
-        <p:blipFill>
-          <a:blip r:embed="rId2"/>
-          <a:stretch/>
-        </p:blipFill>
-        <p:spPr>
-          <a:xfrm>
-            <a:off x="571500" y="1295400"/>
-            <a:ext cx="3296786" cy="4622800"/>
-          </a:xfrm>
-          <a:prstGeom prst="rect"/>
-        </p:spPr>
-      </p:pic>
-      <p:pic>
-        <p:nvPicPr>
-          <p:cNvPr id="52" name=""/>
-          <p:cNvPicPr/>
-          <p:nvPr/>
-        </p:nvPicPr>
-        <p:blipFill>
-          <a:blip r:embed="rId3"/>
-          <a:stretch/>
-        </p:blipFill>
-        <p:spPr>
-          <a:xfrm>
-            <a:off x="4191000" y="1295400"/>
-            <a:ext cx="3296786" cy="4622800"/>
-          </a:xfrm>
-          <a:prstGeom prst="rect"/>
-        </p:spPr>
-      </p:pic>
       <p:sp>
         <p:nvSpPr>
           <p:cNvPr id="53" name=""/>
@@ -2683,7 +2738,7 @@
             <a:r>
               <a:rPr lang="zh-CN" sz="2200">
                 <a:solidFill>
-                  <a:srgbClr val="CDEA9F"/>
+                  <a:srgbClr val="DADADA"/>
                 </a:solidFill>
                 <a:latin typeface="Arial"/>
                 <a:ea typeface="Arial"/>
@@ -2691,7 +2746,13 @@
               <a:t>Reusable bottles +
 repair-workshop materials</a:t>
             </a:r>
-            <a:endParaRPr/>
+            <a:endParaRPr lang="zh-CN" sz="2200">
+              <a:solidFill>
+                <a:srgbClr val="DADADA"/>
+              </a:solidFill>
+              <a:latin typeface="Arial"/>
+              <a:ea typeface="Arial"/>
+            </a:endParaRPr>
           </a:p>
         </p:txBody>
       </p:sp>
@@ -2721,14 +2782,20 @@
             <a:r>
               <a:rPr lang="zh-CN" sz="1700">
                 <a:solidFill>
-                  <a:srgbClr val="CDEA9F"/>
+                  <a:srgbClr val="DADADA"/>
                 </a:solidFill>
                 <a:latin typeface="Arial"/>
                 <a:ea typeface="Arial"/>
               </a:rPr>
               <a:t>Organiser-stated draft benefits</a:t>
             </a:r>
-            <a:endParaRPr/>
+            <a:endParaRPr lang="zh-CN" sz="1700">
+              <a:solidFill>
+                <a:srgbClr val="DADADA"/>
+              </a:solidFill>
+              <a:latin typeface="Arial"/>
+              <a:ea typeface="Arial"/>
+            </a:endParaRPr>
           </a:p>
         </p:txBody>
       </p:sp>
@@ -2797,14 +2864,20 @@
             <a:r>
               <a:rPr lang="zh-CN" sz="1800">
                 <a:solidFill>
-                  <a:srgbClr val="CDEA9F"/>
+                  <a:srgbClr val="DADADA"/>
                 </a:solidFill>
                 <a:latin typeface="Arial"/>
                 <a:ea typeface="Arial"/>
               </a:rPr>
               <a:t>Still unconfirmed</a:t>
             </a:r>
-            <a:endParaRPr/>
+            <a:endParaRPr lang="zh-CN" sz="1800">
+              <a:solidFill>
+                <a:srgbClr val="DADADA"/>
+              </a:solidFill>
+              <a:latin typeface="Arial"/>
+              <a:ea typeface="Arial"/>
+            </a:endParaRPr>
           </a:p>
         </p:txBody>
       </p:sp>
@@ -2848,17 +2921,71 @@
           </a:p>
         </p:txBody>
       </p:sp>
+      <p:pic>
+        <p:nvPicPr>
+          <p:cNvPr id="58" name=""/>
+          <p:cNvPicPr/>
+          <p:nvPr/>
+        </p:nvPicPr>
+        <p:blipFill>
+          <a:blip r:embed="rId2"/>
+          <a:stretch/>
+        </p:blipFill>
+        <p:spPr>
+          <a:xfrm>
+            <a:off x="571500" y="1295400"/>
+            <a:ext cx="2934698" cy="4622800"/>
+          </a:xfrm>
+          <a:prstGeom prst="rect"/>
+        </p:spPr>
+      </p:pic>
+      <p:pic>
+        <p:nvPicPr>
+          <p:cNvPr id="59" name=""/>
+          <p:cNvPicPr/>
+          <p:nvPr/>
+        </p:nvPicPr>
+        <p:blipFill>
+          <a:blip r:embed="rId3"/>
+          <a:stretch/>
+        </p:blipFill>
+        <p:spPr>
+          <a:xfrm>
+            <a:off x="4191000" y="1295400"/>
+            <a:ext cx="2934698" cy="4622800"/>
+          </a:xfrm>
+          <a:prstGeom prst="rect"/>
+        </p:spPr>
+      </p:pic>
+      <p:pic>
+        <p:nvPicPr>
+          <p:cNvPr id="60" name=""/>
+          <p:cNvPicPr/>
+          <p:nvPr/>
+        </p:nvPicPr>
+        <p:blipFill>
+          <a:blip r:embed="rId4"/>
+          <a:stretch/>
+        </p:blipFill>
+        <p:spPr>
+          <a:xfrm>
+            <a:off x="11607800" y="228600"/>
+            <a:ext cx="381000" cy="381000"/>
+          </a:xfrm>
+          <a:prstGeom prst="rect"/>
+        </p:spPr>
+      </p:pic>
     </p:spTree>
   </p:cSld>
 </p:sld>
 </file>
 
 <file path=ppt/slides/slide5.xml><?xml version="1.0" encoding="utf-8"?>
-<p:sld xmlns:p="http://schemas.openxmlformats.org/presentationml/2006/main" xmlns:a="http://schemas.openxmlformats.org/drawingml/2006/main">
+<p:sld xmlns:p="http://schemas.openxmlformats.org/presentationml/2006/main" xmlns:a="http://schemas.openxmlformats.org/drawingml/2006/main" xmlns:r="http://schemas.openxmlformats.org/officeDocument/2006/relationships">
   <p:cSld>
     <p:spTree>
       <p:nvGrpSpPr>
-        <p:cNvPr id="58" name=""/>
+        <p:cNvPr id="61" name=""/>
         <p:cNvGrpSpPr/>
         <p:nvPr/>
       </p:nvGrpSpPr>
@@ -2872,7 +2999,7 @@
       </p:grpSpPr>
       <p:sp>
         <p:nvSpPr>
-          <p:cNvPr id="59" name=""/>
+          <p:cNvPr id="62" name=""/>
           <p:cNvSpPr/>
           <p:nvPr/>
         </p:nvSpPr>
@@ -2885,7 +3012,9 @@
             <a:avLst/>
           </a:prstGeom>
           <a:solidFill>
-            <a:srgbClr val="0E1915"/>
+            <a:srgbClr val="202020">
+              <a:alpha val="100000"/>
+            </a:srgbClr>
           </a:solidFill>
           <a:ln/>
         </p:spPr>
@@ -2899,7 +3028,7 @@
       </p:sp>
       <p:sp>
         <p:nvSpPr>
-          <p:cNvPr id="60" name="" descr="{&quot;isTemplate&quot;:true,&quot;type&quot;:&quot;text&quot;}"/>
+          <p:cNvPr id="63" name="" descr="{&quot;isTemplate&quot;:true,&quot;type&quot;:&quot;text&quot;}"/>
           <p:cNvSpPr txBox="1"/>
           <p:nvPr/>
         </p:nvSpPr>
@@ -2921,7 +3050,7 @@
             <a:r>
               <a:rPr lang="zh-CN" sz="1350">
                 <a:solidFill>
-                  <a:srgbClr val="CDEA9F"/>
+                  <a:srgbClr val="DADADA"/>
                 </a:solidFill>
                 <a:latin typeface="Arial"/>
                 <a:ea typeface="Arial"/>
@@ -2930,17 +3059,17 @@
             </a:r>
             <a:endParaRPr lang="zh-CN" sz="1350">
               <a:solidFill>
-                <a:srgbClr val="CDEA9F"/>
-              </a:solidFill>
-              <a:latin typeface="Arial"/>
-              <a:ea typeface="Arial"/>
-            </a:endParaRPr>
-          </a:p>
-        </p:txBody>
-      </p:sp>
-      <p:sp>
-        <p:nvSpPr>
-          <p:cNvPr id="61" name="" descr="{&quot;isTemplate&quot;:true,&quot;type&quot;:&quot;text&quot;}"/>
+                <a:srgbClr val="DADADA"/>
+              </a:solidFill>
+              <a:latin typeface="Arial"/>
+              <a:ea typeface="Arial"/>
+            </a:endParaRPr>
+          </a:p>
+        </p:txBody>
+      </p:sp>
+      <p:sp>
+        <p:nvSpPr>
+          <p:cNvPr id="64" name="" descr="{&quot;isTemplate&quot;:true,&quot;type&quot;:&quot;text&quot;}"/>
           <p:cNvSpPr txBox="1"/>
           <p:nvPr/>
         </p:nvSpPr>
@@ -2981,7 +3110,7 @@
       </p:sp>
       <p:sp>
         <p:nvSpPr>
-          <p:cNvPr id="62" name=""/>
+          <p:cNvPr id="65" name=""/>
           <p:cNvSpPr/>
           <p:nvPr/>
         </p:nvSpPr>
@@ -2994,7 +3123,9 @@
             <a:avLst/>
           </a:prstGeom>
           <a:solidFill>
-            <a:srgbClr val="1D3328"/>
+            <a:srgbClr val="303030">
+              <a:alpha val="100000"/>
+            </a:srgbClr>
           </a:solidFill>
           <a:ln/>
         </p:spPr>
@@ -3008,7 +3139,7 @@
       </p:sp>
       <p:sp>
         <p:nvSpPr>
-          <p:cNvPr id="63" name="" descr="{&quot;isTemplate&quot;:true,&quot;type&quot;:&quot;text&quot;}"/>
+          <p:cNvPr id="66" name="" descr="{&quot;isTemplate&quot;:true,&quot;type&quot;:&quot;text&quot;}"/>
           <p:cNvSpPr txBox="1"/>
           <p:nvPr/>
         </p:nvSpPr>
@@ -3030,7 +3161,7 @@
             <a:r>
               <a:rPr lang="zh-CN" sz="2100" b="1">
                 <a:solidFill>
-                  <a:srgbClr val="CDEA9F"/>
+                  <a:srgbClr val="DADADA"/>
                 </a:solidFill>
                 <a:latin typeface="Arial"/>
                 <a:ea typeface="Arial"/>
@@ -3039,17 +3170,17 @@
             </a:r>
             <a:endParaRPr lang="zh-CN" sz="2100" b="1">
               <a:solidFill>
-                <a:srgbClr val="CDEA9F"/>
-              </a:solidFill>
-              <a:latin typeface="Arial"/>
-              <a:ea typeface="Arial"/>
-            </a:endParaRPr>
-          </a:p>
-        </p:txBody>
-      </p:sp>
-      <p:sp>
-        <p:nvSpPr>
-          <p:cNvPr id="64" name="" descr="{&quot;isTemplate&quot;:true,&quot;type&quot;:&quot;text&quot;}"/>
+                <a:srgbClr val="DADADA"/>
+              </a:solidFill>
+              <a:latin typeface="Arial"/>
+              <a:ea typeface="Arial"/>
+            </a:endParaRPr>
+          </a:p>
+        </p:txBody>
+      </p:sp>
+      <p:sp>
+        <p:nvSpPr>
+          <p:cNvPr id="67" name="" descr="{&quot;isTemplate&quot;:true,&quot;type&quot;:&quot;text&quot;}"/>
           <p:cNvSpPr txBox="1"/>
           <p:nvPr/>
         </p:nvSpPr>
@@ -3092,7 +3223,7 @@
       </p:sp>
       <p:sp>
         <p:nvSpPr>
-          <p:cNvPr id="65" name="" descr="{&quot;isTemplate&quot;:true,&quot;type&quot;:&quot;text&quot;}"/>
+          <p:cNvPr id="68" name="" descr="{&quot;isTemplate&quot;:true,&quot;type&quot;:&quot;text&quot;}"/>
           <p:cNvSpPr txBox="1"/>
           <p:nvPr/>
         </p:nvSpPr>
@@ -3114,7 +3245,7 @@
             <a:r>
               <a:rPr lang="zh-CN" sz="1900" b="1">
                 <a:solidFill>
-                  <a:srgbClr val="CDEA9F"/>
+                  <a:srgbClr val="DADADA"/>
                 </a:solidFill>
                 <a:latin typeface="Arial"/>
                 <a:ea typeface="Arial"/>
@@ -3123,17 +3254,17 @@
             </a:r>
             <a:endParaRPr lang="zh-CN" sz="1900" b="1">
               <a:solidFill>
-                <a:srgbClr val="CDEA9F"/>
-              </a:solidFill>
-              <a:latin typeface="Arial"/>
-              <a:ea typeface="Arial"/>
-            </a:endParaRPr>
-          </a:p>
-        </p:txBody>
-      </p:sp>
-      <p:sp>
-        <p:nvSpPr>
-          <p:cNvPr id="66" name="" descr="{&quot;isTemplate&quot;:true,&quot;type&quot;:&quot;text&quot;}"/>
+                <a:srgbClr val="DADADA"/>
+              </a:solidFill>
+              <a:latin typeface="Arial"/>
+              <a:ea typeface="Arial"/>
+            </a:endParaRPr>
+          </a:p>
+        </p:txBody>
+      </p:sp>
+      <p:sp>
+        <p:nvSpPr>
+          <p:cNvPr id="69" name="" descr="{&quot;isTemplate&quot;:true,&quot;type&quot;:&quot;text&quot;}"/>
           <p:cNvSpPr txBox="1"/>
           <p:nvPr/>
         </p:nvSpPr>
@@ -3175,7 +3306,7 @@
       </p:sp>
       <p:sp>
         <p:nvSpPr>
-          <p:cNvPr id="67" name="" descr="{&quot;isTemplate&quot;:true,&quot;type&quot;:&quot;text&quot;}"/>
+          <p:cNvPr id="70" name="" descr="{&quot;isTemplate&quot;:true,&quot;type&quot;:&quot;text&quot;}"/>
           <p:cNvSpPr txBox="1"/>
           <p:nvPr/>
         </p:nvSpPr>
@@ -3197,7 +3328,7 @@
             <a:r>
               <a:rPr lang="zh-CN" sz="1875" b="1">
                 <a:solidFill>
-                  <a:srgbClr val="CDEA9F"/>
+                  <a:srgbClr val="DADADA"/>
                 </a:solidFill>
                 <a:latin typeface="Arial"/>
                 <a:ea typeface="Arial"/>
@@ -3206,17 +3337,17 @@
             </a:r>
             <a:endParaRPr lang="zh-CN" sz="1875" b="1">
               <a:solidFill>
-                <a:srgbClr val="CDEA9F"/>
-              </a:solidFill>
-              <a:latin typeface="Arial"/>
-              <a:ea typeface="Arial"/>
-            </a:endParaRPr>
-          </a:p>
-        </p:txBody>
-      </p:sp>
-      <p:sp>
-        <p:nvSpPr>
-          <p:cNvPr id="68" name="" descr="{&quot;isTemplate&quot;:true,&quot;type&quot;:&quot;text&quot;}"/>
+                <a:srgbClr val="DADADA"/>
+              </a:solidFill>
+              <a:latin typeface="Arial"/>
+              <a:ea typeface="Arial"/>
+            </a:endParaRPr>
+          </a:p>
+        </p:txBody>
+      </p:sp>
+      <p:sp>
+        <p:nvSpPr>
+          <p:cNvPr id="71" name="" descr="{&quot;isTemplate&quot;:true,&quot;type&quot;:&quot;text&quot;}"/>
           <p:cNvSpPr txBox="1"/>
           <p:nvPr/>
         </p:nvSpPr>
@@ -3258,7 +3389,7 @@
       </p:sp>
       <p:sp>
         <p:nvSpPr>
-          <p:cNvPr id="69" name=""/>
+          <p:cNvPr id="72" name=""/>
           <p:cNvSpPr/>
           <p:nvPr/>
         </p:nvSpPr>
@@ -3271,7 +3402,9 @@
             <a:avLst/>
           </a:prstGeom>
           <a:solidFill>
-            <a:srgbClr val="1D3328"/>
+            <a:srgbClr val="303030">
+              <a:alpha val="100000"/>
+            </a:srgbClr>
           </a:solidFill>
           <a:ln/>
         </p:spPr>
@@ -3285,7 +3418,7 @@
       </p:sp>
       <p:sp>
         <p:nvSpPr>
-          <p:cNvPr id="70" name="" descr="{&quot;isTemplate&quot;:true,&quot;type&quot;:&quot;text&quot;}"/>
+          <p:cNvPr id="73" name="" descr="{&quot;isTemplate&quot;:true,&quot;type&quot;:&quot;text&quot;}"/>
           <p:cNvSpPr txBox="1"/>
           <p:nvPr/>
         </p:nvSpPr>
@@ -3307,7 +3440,7 @@
             <a:r>
               <a:rPr lang="zh-CN" sz="5250" b="1">
                 <a:solidFill>
-                  <a:srgbClr val="CDEA9F"/>
+                  <a:srgbClr val="DADADA"/>
                 </a:solidFill>
                 <a:latin typeface="Arial"/>
                 <a:ea typeface="Arial"/>
@@ -3316,17 +3449,17 @@
             </a:r>
             <a:endParaRPr lang="zh-CN" sz="5250" b="1">
               <a:solidFill>
-                <a:srgbClr val="CDEA9F"/>
-              </a:solidFill>
-              <a:latin typeface="Arial"/>
-              <a:ea typeface="Arial"/>
-            </a:endParaRPr>
-          </a:p>
-        </p:txBody>
-      </p:sp>
-      <p:sp>
-        <p:nvSpPr>
-          <p:cNvPr id="71" name="" descr="{&quot;isTemplate&quot;:true,&quot;type&quot;:&quot;text&quot;}"/>
+                <a:srgbClr val="DADADA"/>
+              </a:solidFill>
+              <a:latin typeface="Arial"/>
+              <a:ea typeface="Arial"/>
+            </a:endParaRPr>
+          </a:p>
+        </p:txBody>
+      </p:sp>
+      <p:sp>
+        <p:nvSpPr>
+          <p:cNvPr id="74" name="" descr="{&quot;isTemplate&quot;:true,&quot;type&quot;:&quot;text&quot;}"/>
           <p:cNvSpPr txBox="1"/>
           <p:nvPr/>
         </p:nvSpPr>
@@ -3367,7 +3500,7 @@
       </p:sp>
       <p:sp>
         <p:nvSpPr>
-          <p:cNvPr id="72" name="" descr="{&quot;isTemplate&quot;:true,&quot;type&quot;:&quot;text&quot;}"/>
+          <p:cNvPr id="75" name="" descr="{&quot;isTemplate&quot;:true,&quot;type&quot;:&quot;text&quot;}"/>
           <p:cNvSpPr txBox="1"/>
           <p:nvPr/>
         </p:nvSpPr>
@@ -3409,7 +3542,7 @@
       </p:sp>
       <p:sp>
         <p:nvSpPr>
-          <p:cNvPr id="73" name="" descr="{&quot;isTemplate&quot;:true,&quot;type&quot;:&quot;text&quot;}"/>
+          <p:cNvPr id="76" name="" descr="{&quot;isTemplate&quot;:true,&quot;type&quot;:&quot;text&quot;}"/>
           <p:cNvSpPr txBox="1"/>
           <p:nvPr/>
         </p:nvSpPr>
@@ -3431,7 +3564,7 @@
             <a:r>
               <a:rPr lang="zh-CN" sz="3600" b="1">
                 <a:solidFill>
-                  <a:srgbClr val="CDEA9F"/>
+                  <a:srgbClr val="DADADA"/>
                 </a:solidFill>
                 <a:latin typeface="Arial"/>
                 <a:ea typeface="Arial"/>
@@ -3440,17 +3573,17 @@
             </a:r>
             <a:endParaRPr lang="zh-CN" sz="3600" b="1">
               <a:solidFill>
-                <a:srgbClr val="CDEA9F"/>
-              </a:solidFill>
-              <a:latin typeface="Arial"/>
-              <a:ea typeface="Arial"/>
-            </a:endParaRPr>
-          </a:p>
-        </p:txBody>
-      </p:sp>
-      <p:sp>
-        <p:nvSpPr>
-          <p:cNvPr id="74" name="" descr="{&quot;isTemplate&quot;:true,&quot;type&quot;:&quot;text&quot;}"/>
+                <a:srgbClr val="DADADA"/>
+              </a:solidFill>
+              <a:latin typeface="Arial"/>
+              <a:ea typeface="Arial"/>
+            </a:endParaRPr>
+          </a:p>
+        </p:txBody>
+      </p:sp>
+      <p:sp>
+        <p:nvSpPr>
+          <p:cNvPr id="77" name="" descr="{&quot;isTemplate&quot;:true,&quot;type&quot;:&quot;text&quot;}"/>
           <p:cNvSpPr txBox="1"/>
           <p:nvPr/>
         </p:nvSpPr>
@@ -3491,7 +3624,7 @@
       </p:sp>
       <p:sp>
         <p:nvSpPr>
-          <p:cNvPr id="75" name="" descr="{&quot;isTemplate&quot;:true,&quot;type&quot;:&quot;text&quot;}"/>
+          <p:cNvPr id="78" name="" descr="{&quot;isTemplate&quot;:true,&quot;type&quot;:&quot;text&quot;}"/>
           <p:cNvSpPr txBox="1"/>
           <p:nvPr/>
         </p:nvSpPr>
@@ -3534,7 +3667,7 @@
       </p:sp>
       <p:sp>
         <p:nvSpPr>
-          <p:cNvPr id="76" name="" descr="{&quot;isTemplate&quot;:true,&quot;type&quot;:&quot;text&quot;}"/>
+          <p:cNvPr id="79" name="" descr="{&quot;isTemplate&quot;:true,&quot;type&quot;:&quot;text&quot;}"/>
           <p:cNvSpPr txBox="1"/>
           <p:nvPr/>
         </p:nvSpPr>
@@ -3575,7 +3708,7 @@
       </p:sp>
       <p:sp>
         <p:nvSpPr>
-          <p:cNvPr id="77" name="" descr="{&quot;isTemplate&quot;:true,&quot;type&quot;:&quot;text&quot;}"/>
+          <p:cNvPr id="80" name="" descr="{&quot;isTemplate&quot;:true,&quot;type&quot;:&quot;text&quot;}"/>
           <p:cNvSpPr txBox="1"/>
           <p:nvPr/>
         </p:nvSpPr>
@@ -3608,6 +3741,24 @@
           </a:p>
         </p:txBody>
       </p:sp>
+      <p:pic>
+        <p:nvPicPr>
+          <p:cNvPr id="81" name=""/>
+          <p:cNvPicPr/>
+          <p:nvPr/>
+        </p:nvPicPr>
+        <p:blipFill>
+          <a:blip r:embed="rId2"/>
+          <a:stretch/>
+        </p:blipFill>
+        <p:spPr>
+          <a:xfrm>
+            <a:off x="11607800" y="228600"/>
+            <a:ext cx="381000" cy="381000"/>
+          </a:xfrm>
+          <a:prstGeom prst="rect"/>
+        </p:spPr>
+      </p:pic>
     </p:spTree>
   </p:cSld>
 </p:sld>
@@ -3618,7 +3769,7 @@
   <p:cSld>
     <p:spTree>
       <p:nvGrpSpPr>
-        <p:cNvPr id="78" name=""/>
+        <p:cNvPr id="82" name=""/>
         <p:cNvGrpSpPr/>
         <p:nvPr/>
       </p:nvGrpSpPr>
@@ -3632,7 +3783,7 @@
       </p:grpSpPr>
       <p:sp>
         <p:nvSpPr>
-          <p:cNvPr id="79" name=""/>
+          <p:cNvPr id="83" name=""/>
           <p:cNvSpPr/>
           <p:nvPr/>
         </p:nvSpPr>
@@ -3645,7 +3796,9 @@
             <a:avLst/>
           </a:prstGeom>
           <a:solidFill>
-            <a:srgbClr val="0E1915"/>
+            <a:srgbClr val="202020">
+              <a:alpha val="100000"/>
+            </a:srgbClr>
           </a:solidFill>
           <a:ln/>
         </p:spPr>
@@ -3659,7 +3812,7 @@
       </p:sp>
       <p:sp>
         <p:nvSpPr>
-          <p:cNvPr id="80" name="" descr="{&quot;isTemplate&quot;:true,&quot;type&quot;:&quot;text&quot;}"/>
+          <p:cNvPr id="84" name="" descr="{&quot;isTemplate&quot;:true,&quot;type&quot;:&quot;text&quot;}"/>
           <p:cNvSpPr txBox="1"/>
           <p:nvPr/>
         </p:nvSpPr>
@@ -3681,7 +3834,7 @@
             <a:r>
               <a:rPr lang="zh-CN" sz="1350">
                 <a:solidFill>
-                  <a:srgbClr val="CDEA9F"/>
+                  <a:srgbClr val="DADADA"/>
                 </a:solidFill>
                 <a:latin typeface="Arial"/>
                 <a:ea typeface="Arial"/>
@@ -3690,17 +3843,17 @@
             </a:r>
             <a:endParaRPr lang="zh-CN" sz="1350">
               <a:solidFill>
-                <a:srgbClr val="CDEA9F"/>
-              </a:solidFill>
-              <a:latin typeface="Arial"/>
-              <a:ea typeface="Arial"/>
-            </a:endParaRPr>
-          </a:p>
-        </p:txBody>
-      </p:sp>
-      <p:sp>
-        <p:nvSpPr>
-          <p:cNvPr id="81" name="" descr="{&quot;isTemplate&quot;:true,&quot;type&quot;:&quot;text&quot;}"/>
+                <a:srgbClr val="DADADA"/>
+              </a:solidFill>
+              <a:latin typeface="Arial"/>
+              <a:ea typeface="Arial"/>
+            </a:endParaRPr>
+          </a:p>
+        </p:txBody>
+      </p:sp>
+      <p:sp>
+        <p:nvSpPr>
+          <p:cNvPr id="85" name="" descr="{&quot;isTemplate&quot;:true,&quot;type&quot;:&quot;text&quot;}"/>
           <p:cNvSpPr txBox="1"/>
           <p:nvPr/>
         </p:nvSpPr>
@@ -3741,7 +3894,7 @@
       </p:sp>
       <p:sp>
         <p:nvSpPr>
-          <p:cNvPr id="82" name="" descr="{&quot;isTemplate&quot;:true,&quot;type&quot;:&quot;text&quot;}"/>
+          <p:cNvPr id="86" name="" descr="{&quot;isTemplate&quot;:true,&quot;type&quot;:&quot;text&quot;}"/>
           <p:cNvSpPr txBox="1"/>
           <p:nvPr/>
         </p:nvSpPr>
@@ -3763,7 +3916,7 @@
             <a:r>
               <a:rPr lang="zh-CN" sz="1200">
                 <a:solidFill>
-                  <a:srgbClr val="CDEA9F"/>
+                  <a:srgbClr val="DADADA"/>
                 </a:solidFill>
                 <a:latin typeface="Arial"/>
                 <a:ea typeface="Arial"/>
@@ -3772,17 +3925,17 @@
             </a:r>
             <a:endParaRPr lang="zh-CN" sz="1200">
               <a:solidFill>
-                <a:srgbClr val="CDEA9F"/>
-              </a:solidFill>
-              <a:latin typeface="Arial"/>
-              <a:ea typeface="Arial"/>
-            </a:endParaRPr>
-          </a:p>
-        </p:txBody>
-      </p:sp>
-      <p:sp>
-        <p:nvSpPr>
-          <p:cNvPr id="83" name="" descr="{&quot;isTemplate&quot;:true,&quot;type&quot;:&quot;text&quot;}"/>
+                <a:srgbClr val="DADADA"/>
+              </a:solidFill>
+              <a:latin typeface="Arial"/>
+              <a:ea typeface="Arial"/>
+            </a:endParaRPr>
+          </a:p>
+        </p:txBody>
+      </p:sp>
+      <p:sp>
+        <p:nvSpPr>
+          <p:cNvPr id="87" name="" descr="{&quot;isTemplate&quot;:true,&quot;type&quot;:&quot;text&quot;}"/>
           <p:cNvSpPr txBox="1"/>
           <p:nvPr/>
         </p:nvSpPr>
@@ -3804,20 +3957,26 @@
             <a:r>
               <a:rPr lang="en-US" sz="2175" b="1">
                 <a:solidFill>
-                  <a:srgbClr val="CDEA9F"/>
+                  <a:srgbClr val="DADADA"/>
                 </a:solidFill>
                 <a:latin typeface="Arial"/>
                 <a:ea typeface="Arial"/>
               </a:rPr>
               <a:t>Implemented</a:t>
             </a:r>
-            <a:endParaRPr/>
-          </a:p>
-        </p:txBody>
-      </p:sp>
-      <p:sp>
-        <p:nvSpPr>
-          <p:cNvPr id="84" name="" descr="{&quot;isTemplate&quot;:true,&quot;type&quot;:&quot;text&quot;}"/>
+            <a:endParaRPr lang="en-US" sz="2175" b="1">
+              <a:solidFill>
+                <a:srgbClr val="DADADA"/>
+              </a:solidFill>
+              <a:latin typeface="Arial"/>
+              <a:ea typeface="Arial"/>
+            </a:endParaRPr>
+          </a:p>
+        </p:txBody>
+      </p:sp>
+      <p:sp>
+        <p:nvSpPr>
+          <p:cNvPr id="88" name="" descr="{&quot;isTemplate&quot;:true,&quot;type&quot;:&quot;text&quot;}"/>
           <p:cNvSpPr txBox="1"/>
           <p:nvPr/>
         </p:nvSpPr>
@@ -3861,7 +4020,7 @@
       </p:sp>
       <p:sp>
         <p:nvSpPr>
-          <p:cNvPr id="85" name="" descr="{&quot;isTemplate&quot;:true,&quot;type&quot;:&quot;text&quot;}"/>
+          <p:cNvPr id="89" name="" descr="{&quot;isTemplate&quot;:true,&quot;type&quot;:&quot;text&quot;}"/>
           <p:cNvSpPr txBox="1"/>
           <p:nvPr/>
         </p:nvSpPr>
@@ -3904,7 +4063,7 @@
       </p:sp>
       <p:sp>
         <p:nvSpPr>
-          <p:cNvPr id="86" name=""/>
+          <p:cNvPr id="90" name=""/>
           <p:cNvSpPr/>
           <p:nvPr/>
         </p:nvSpPr>
@@ -3917,7 +4076,9 @@
             <a:avLst/>
           </a:prstGeom>
           <a:solidFill>
-            <a:srgbClr val="1D3328"/>
+            <a:srgbClr val="303030">
+              <a:alpha val="100000"/>
+            </a:srgbClr>
           </a:solidFill>
           <a:ln/>
         </p:spPr>
@@ -3931,7 +4092,7 @@
       </p:sp>
       <p:sp>
         <p:nvSpPr>
-          <p:cNvPr id="87" name="" descr="{&quot;isTemplate&quot;:true,&quot;type&quot;:&quot;text&quot;}"/>
+          <p:cNvPr id="91" name="" descr="{&quot;isTemplate&quot;:true,&quot;type&quot;:&quot;text&quot;}"/>
           <p:cNvSpPr txBox="1"/>
           <p:nvPr/>
         </p:nvSpPr>
@@ -3953,7 +4114,7 @@
             <a:r>
               <a:rPr lang="zh-CN" sz="2175" b="1">
                 <a:solidFill>
-                  <a:srgbClr val="CDEA9F"/>
+                  <a:srgbClr val="DADADA"/>
                 </a:solidFill>
                 <a:latin typeface="Arial"/>
                 <a:ea typeface="Arial"/>
@@ -3962,17 +4123,17 @@
             </a:r>
             <a:endParaRPr lang="zh-CN" sz="2175" b="1">
               <a:solidFill>
-                <a:srgbClr val="CDEA9F"/>
-              </a:solidFill>
-              <a:latin typeface="Arial"/>
-              <a:ea typeface="Arial"/>
-            </a:endParaRPr>
-          </a:p>
-        </p:txBody>
-      </p:sp>
-      <p:sp>
-        <p:nvSpPr>
-          <p:cNvPr id="88" name="" descr="{&quot;isTemplate&quot;:true,&quot;type&quot;:&quot;text&quot;}"/>
+                <a:srgbClr val="DADADA"/>
+              </a:solidFill>
+              <a:latin typeface="Arial"/>
+              <a:ea typeface="Arial"/>
+            </a:endParaRPr>
+          </a:p>
+        </p:txBody>
+      </p:sp>
+      <p:sp>
+        <p:nvSpPr>
+          <p:cNvPr id="92" name="" descr="{&quot;isTemplate&quot;:true,&quot;type&quot;:&quot;text&quot;}"/>
           <p:cNvSpPr txBox="1"/>
           <p:nvPr/>
         </p:nvSpPr>
@@ -4015,7 +4176,7 @@
       </p:sp>
       <p:sp>
         <p:nvSpPr>
-          <p:cNvPr id="89" name=""/>
+          <p:cNvPr id="93" name=""/>
           <p:cNvSpPr/>
           <p:nvPr/>
         </p:nvSpPr>
@@ -4028,7 +4189,9 @@
             <a:avLst/>
           </a:prstGeom>
           <a:solidFill>
-            <a:srgbClr val="1D3328"/>
+            <a:srgbClr val="303030">
+              <a:alpha val="100000"/>
+            </a:srgbClr>
           </a:solidFill>
           <a:ln/>
         </p:spPr>
@@ -4042,7 +4205,7 @@
       </p:sp>
       <p:sp>
         <p:nvSpPr>
-          <p:cNvPr id="90" name="" descr="{&quot;isTemplate&quot;:true,&quot;type&quot;:&quot;text&quot;}"/>
+          <p:cNvPr id="94" name="" descr="{&quot;isTemplate&quot;:true,&quot;type&quot;:&quot;text&quot;}"/>
           <p:cNvSpPr txBox="1"/>
           <p:nvPr/>
         </p:nvSpPr>
@@ -4064,7 +4227,7 @@
             <a:r>
               <a:rPr lang="zh-CN" sz="1800" b="1">
                 <a:solidFill>
-                  <a:srgbClr val="CDEA9F"/>
+                  <a:srgbClr val="DADADA"/>
                 </a:solidFill>
                 <a:latin typeface="Arial"/>
                 <a:ea typeface="Arial"/>
@@ -4073,17 +4236,17 @@
             </a:r>
             <a:endParaRPr lang="zh-CN" sz="1800" b="1">
               <a:solidFill>
-                <a:srgbClr val="CDEA9F"/>
-              </a:solidFill>
-              <a:latin typeface="Arial"/>
-              <a:ea typeface="Arial"/>
-            </a:endParaRPr>
-          </a:p>
-        </p:txBody>
-      </p:sp>
-      <p:sp>
-        <p:nvSpPr>
-          <p:cNvPr id="91" name="" descr="{&quot;isTemplate&quot;:true,&quot;type&quot;:&quot;text&quot;}">
+                <a:srgbClr val="DADADA"/>
+              </a:solidFill>
+              <a:latin typeface="Arial"/>
+              <a:ea typeface="Arial"/>
+            </a:endParaRPr>
+          </a:p>
+        </p:txBody>
+      </p:sp>
+      <p:sp>
+        <p:nvSpPr>
+          <p:cNvPr id="95" name="" descr="{&quot;isTemplate&quot;:true,&quot;type&quot;:&quot;text&quot;}">
             <a:hlinkClick r:id="rId2"/>
           </p:cNvPr>
           <p:cNvSpPr txBox="1"/>
@@ -4107,7 +4270,7 @@
             <a:r>
               <a:rPr lang="en-US" sz="1875">
                 <a:solidFill>
-                  <a:srgbClr val="CDEA9F"/>
+                  <a:srgbClr val="DADADA"/>
                 </a:solidFill>
                 <a:latin typeface="Arial"/>
                 <a:ea typeface="Arial"/>
@@ -4116,17 +4279,17 @@
             </a:r>
             <a:endParaRPr lang="en-US" sz="1875">
               <a:solidFill>
-                <a:srgbClr val="CDEA9F"/>
-              </a:solidFill>
-              <a:latin typeface="Arial"/>
-              <a:ea typeface="Arial"/>
-            </a:endParaRPr>
-          </a:p>
-        </p:txBody>
-      </p:sp>
-      <p:sp>
-        <p:nvSpPr>
-          <p:cNvPr id="92" name="" descr="{&quot;isTemplate&quot;:true,&quot;type&quot;:&quot;text&quot;}"/>
+                <a:srgbClr val="DADADA"/>
+              </a:solidFill>
+              <a:latin typeface="Arial"/>
+              <a:ea typeface="Arial"/>
+            </a:endParaRPr>
+          </a:p>
+        </p:txBody>
+      </p:sp>
+      <p:sp>
+        <p:nvSpPr>
+          <p:cNvPr id="96" name="" descr="{&quot;isTemplate&quot;:true,&quot;type&quot;:&quot;text&quot;}"/>
           <p:cNvSpPr txBox="1"/>
           <p:nvPr/>
         </p:nvSpPr>
@@ -4167,7 +4330,7 @@
       </p:sp>
       <p:sp>
         <p:nvSpPr>
-          <p:cNvPr id="93" name="" descr="{&quot;isTemplate&quot;:true,&quot;type&quot;:&quot;text&quot;}"/>
+          <p:cNvPr id="97" name="" descr="{&quot;isTemplate&quot;:true,&quot;type&quot;:&quot;text&quot;}"/>
           <p:cNvSpPr txBox="1"/>
           <p:nvPr/>
         </p:nvSpPr>
@@ -4194,7 +4357,7 @@
                 <a:latin typeface="Arial"/>
                 <a:ea typeface="Arial"/>
               </a:rPr>
-              <a:t>Afiq · SponsorBridge · 11 October 2026</a:t>
+              <a:t>Afiq · PUTRApitch · 11 October 2026</a:t>
             </a:r>
             <a:endParaRPr lang="zh-CN" sz="1125">
               <a:solidFill>
@@ -4208,7 +4371,7 @@
       </p:sp>
       <p:sp>
         <p:nvSpPr>
-          <p:cNvPr id="94" name="" descr="{&quot;isTemplate&quot;:true,&quot;type&quot;:&quot;text&quot;}"/>
+          <p:cNvPr id="98" name="" descr="{&quot;isTemplate&quot;:true,&quot;type&quot;:&quot;text&quot;}"/>
           <p:cNvSpPr txBox="1"/>
           <p:nvPr/>
         </p:nvSpPr>
@@ -4243,7 +4406,7 @@
       </p:sp>
       <p:pic>
         <p:nvPicPr>
-          <p:cNvPr id="95" name=""/>
+          <p:cNvPr id="99" name=""/>
           <p:cNvPicPr/>
           <p:nvPr/>
         </p:nvPicPr>
@@ -4255,6 +4418,24 @@
           <a:xfrm>
             <a:off x="571500" y="1320800"/>
             <a:ext cx="3200400" cy="2333625"/>
+          </a:xfrm>
+          <a:prstGeom prst="rect"/>
+        </p:spPr>
+      </p:pic>
+      <p:pic>
+        <p:nvPicPr>
+          <p:cNvPr id="100" name=""/>
+          <p:cNvPicPr/>
+          <p:nvPr/>
+        </p:nvPicPr>
+        <p:blipFill>
+          <a:blip r:embed="rId4"/>
+          <a:stretch/>
+        </p:blipFill>
+        <p:spPr>
+          <a:xfrm>
+            <a:off x="11607800" y="228600"/>
+            <a:ext cx="381000" cy="381000"/>
           </a:xfrm>
           <a:prstGeom prst="rect"/>
         </p:spPr>

</xml_diff>